<commit_message>
Fill gaps in revised deck: source labels, creative-team opening line, digital skills source
Co-Authored-By: Claude Sonnet 5.5 <noreply@anthropic.com>
Claude-Session: https://claude.ai/code/session_01Ha62b6Wcst3n47bFqEFLKV
</commit_message>
<xml_diff>
--- a/Earning-the-Signal_revised.pptx
+++ b/Earning-the-Signal_revised.pptx
@@ -4051,6 +4051,26 @@
             </a:r>
             <a:endParaRPr lang="en-US" sz="1200" dirty="0"/>
           </a:p>
+          <a:p>
+            <a:pPr indent="0" marL="0">
+              <a:spcAft>
+                <a:spcPts val="400"/>
+              </a:spcAft>
+              <a:buNone/>
+            </a:pPr>
+            <a:r>
+              <a:rPr lang="en-US" sz="1200" dirty="0">
+                <a:solidFill>
+                  <a:srgbClr val="27314D"/>
+                </a:solidFill>
+                <a:latin typeface="Calibri" pitchFamily="34" charset="0"/>
+                <a:ea typeface="Calibri" pitchFamily="34" charset="-122"/>
+                <a:cs typeface="Calibri" pitchFamily="34" charset="-120"/>
+              </a:rPr>
+              <a:t>Vial, G. (2019) ‘Understanding digital transformation: a review and a research agenda’, Journal of Strategic Information Systems, 28(2), pp.118–144.</a:t>
+            </a:r>
+            <a:endParaRPr lang="en-US" sz="1200" dirty="0"/>
+          </a:p>
         </p:txBody>
       </p:sp>
     </p:spTree>
@@ -6892,7 +6912,7 @@
         </p:nvSpPr>
         <p:spPr>
           <a:xfrm>
-            <a:off x="548640" y="5623560"/>
+            <a:off x="548640" y="5577840"/>
             <a:ext cx="11064240" cy="640080"/>
           </a:xfrm>
           <a:prstGeom prst="rect">
@@ -6934,6 +6954,45 @@
               <a:t>discovery (benefit), because a small catalogue of original shows only pays off if each is found; and creative originality (limitation), because Apple competes on quality. Personalisation is necessary but not sufficient.</a:t>
             </a:r>
             <a:endParaRPr lang="en-US" sz="1300" dirty="0"/>
+          </a:p>
+        </p:txBody>
+      </p:sp>
+      <p:sp>
+        <p:nvSpPr>
+          <p:cNvPr id="26" name="Text 23"/>
+          <p:cNvSpPr txBox="1"/>
+          <p:nvPr/>
+        </p:nvSpPr>
+        <p:spPr>
+          <a:xfrm>
+            <a:off x="548640" y="6263640"/>
+            <a:ext cx="11064240" cy="365760"/>
+          </a:xfrm>
+          <a:prstGeom prst="rect">
+            <a:avLst/>
+          </a:prstGeom>
+          <a:noFill/>
+          <a:ln/>
+        </p:spPr>
+        <p:txBody>
+          <a:bodyPr wrap="square" lIns="0" tIns="0" rIns="0" bIns="0" rtlCol="0" anchor="t"/>
+          <a:lstStyle/>
+          <a:p>
+            <a:pPr indent="0" marL="0">
+              <a:buNone/>
+            </a:pPr>
+            <a:r>
+              <a:rPr lang="en-US" sz="1100" i="1" dirty="0">
+                <a:solidFill>
+                  <a:srgbClr val="6B7590"/>
+                </a:solidFill>
+                <a:latin typeface="Calibri" pitchFamily="34" charset="0"/>
+                <a:ea typeface="Calibri" pitchFamily="34" charset="-122"/>
+                <a:cs typeface="Calibri" pitchFamily="34" charset="-120"/>
+              </a:rPr>
+              <a:t>Sources as cited in each row. Gracenote (2025) figure still to be verified at the original report.</a:t>
+            </a:r>
+            <a:endParaRPr lang="en-US" sz="1100" dirty="0"/>
           </a:p>
         </p:txBody>
       </p:sp>
@@ -7049,14 +7108,53 @@
       </p:sp>
       <p:sp>
         <p:nvSpPr>
-          <p:cNvPr id="5" name="Shape 2"/>
+          <p:cNvPr id="5" name="Text 2"/>
+          <p:cNvSpPr txBox="1"/>
+          <p:nvPr/>
+        </p:nvSpPr>
+        <p:spPr>
+          <a:xfrm>
+            <a:off x="548640" y="1097280"/>
+            <a:ext cx="11064240" cy="320040"/>
+          </a:xfrm>
+          <a:prstGeom prst="rect">
+            <a:avLst/>
+          </a:prstGeom>
+          <a:noFill/>
+          <a:ln/>
+        </p:spPr>
+        <p:txBody>
+          <a:bodyPr wrap="square" lIns="0" tIns="0" rIns="0" bIns="0" rtlCol="0" anchor="t"/>
+          <a:lstStyle/>
+          <a:p>
+            <a:pPr indent="0" marL="0">
+              <a:buNone/>
+            </a:pPr>
+            <a:r>
+              <a:rPr lang="en-US" sz="1400" i="1" dirty="0">
+                <a:solidFill>
+                  <a:srgbClr val="1E56A0"/>
+                </a:solidFill>
+                <a:latin typeface="Calibri" pitchFamily="34" charset="0"/>
+                <a:ea typeface="Calibri" pitchFamily="34" charset="-122"/>
+                <a:cs typeface="Calibri" pitchFamily="34" charset="-120"/>
+              </a:rPr>
+              <a:t>Personalisation at this scale does not only change what customers see; it also changes how creative teams decide what gets made.</a:t>
+            </a:r>
+            <a:endParaRPr lang="en-US" sz="1400" dirty="0"/>
+          </a:p>
+        </p:txBody>
+      </p:sp>
+      <p:sp>
+        <p:nvSpPr>
+          <p:cNvPr id="6" name="Shape 3"/>
           <p:cNvSpPr/>
           <p:nvPr/>
         </p:nvSpPr>
         <p:spPr>
           <a:xfrm>
-            <a:off x="548640" y="1371600"/>
-            <a:ext cx="3291840" cy="3840480"/>
+            <a:off x="548640" y="1600200"/>
+            <a:ext cx="3291840" cy="3611880"/>
           </a:xfrm>
           <a:prstGeom prst="roundRect">
             <a:avLst>
@@ -7076,13 +7174,13 @@
       </p:sp>
       <p:sp>
         <p:nvSpPr>
-          <p:cNvPr id="6" name="Text 3"/>
+          <p:cNvPr id="7" name="Text 4"/>
           <p:cNvSpPr txBox="1"/>
           <p:nvPr/>
         </p:nvSpPr>
         <p:spPr>
           <a:xfrm>
-            <a:off x="731520" y="1508760"/>
+            <a:off x="731520" y="1737360"/>
             <a:ext cx="2926080" cy="457200"/>
           </a:xfrm>
           <a:prstGeom prst="rect">
@@ -7115,14 +7213,14 @@
       </p:sp>
       <p:sp>
         <p:nvSpPr>
-          <p:cNvPr id="7" name="Text 4"/>
+          <p:cNvPr id="8" name="Text 5"/>
           <p:cNvSpPr txBox="1"/>
           <p:nvPr/>
         </p:nvSpPr>
         <p:spPr>
           <a:xfrm>
-            <a:off x="731520" y="2103120"/>
-            <a:ext cx="2926080" cy="2926080"/>
+            <a:off x="731520" y="2286000"/>
+            <a:ext cx="2926080" cy="2743200"/>
           </a:xfrm>
           <a:prstGeom prst="rect">
             <a:avLst/>
@@ -7188,14 +7286,14 @@
       </p:sp>
       <p:sp>
         <p:nvSpPr>
-          <p:cNvPr id="8" name="Shape 5"/>
+          <p:cNvPr id="9" name="Shape 6"/>
           <p:cNvSpPr/>
           <p:nvPr/>
         </p:nvSpPr>
         <p:spPr>
           <a:xfrm>
-            <a:off x="4114800" y="1371600"/>
-            <a:ext cx="2423160" cy="3840480"/>
+            <a:off x="4114800" y="1600200"/>
+            <a:ext cx="2423160" cy="3611880"/>
           </a:xfrm>
           <a:prstGeom prst="roundRect">
             <a:avLst>
@@ -7215,13 +7313,13 @@
       </p:sp>
       <p:sp>
         <p:nvSpPr>
-          <p:cNvPr id="9" name="Text 6"/>
+          <p:cNvPr id="10" name="Text 7"/>
           <p:cNvSpPr txBox="1"/>
           <p:nvPr/>
         </p:nvSpPr>
         <p:spPr>
           <a:xfrm>
-            <a:off x="4251960" y="1508760"/>
+            <a:off x="4251960" y="1737360"/>
             <a:ext cx="2148840" cy="411480"/>
           </a:xfrm>
           <a:prstGeom prst="rect">
@@ -7254,14 +7352,14 @@
       </p:sp>
       <p:sp>
         <p:nvSpPr>
-          <p:cNvPr id="10" name="Text 7"/>
+          <p:cNvPr id="11" name="Text 8"/>
           <p:cNvSpPr txBox="1"/>
           <p:nvPr/>
         </p:nvSpPr>
         <p:spPr>
           <a:xfrm>
-            <a:off x="4251960" y="2011680"/>
-            <a:ext cx="2148840" cy="3108960"/>
+            <a:off x="4251960" y="2240280"/>
+            <a:ext cx="2148840" cy="2834640"/>
           </a:xfrm>
           <a:prstGeom prst="rect">
             <a:avLst/>
@@ -7293,14 +7391,14 @@
       </p:sp>
       <p:sp>
         <p:nvSpPr>
-          <p:cNvPr id="11" name="Shape 8"/>
+          <p:cNvPr id="12" name="Shape 9"/>
           <p:cNvSpPr/>
           <p:nvPr/>
         </p:nvSpPr>
         <p:spPr>
           <a:xfrm>
-            <a:off x="6675120" y="1371600"/>
-            <a:ext cx="2423160" cy="3840480"/>
+            <a:off x="6675120" y="1600200"/>
+            <a:ext cx="2423160" cy="3611880"/>
           </a:xfrm>
           <a:prstGeom prst="roundRect">
             <a:avLst>
@@ -7320,13 +7418,13 @@
       </p:sp>
       <p:sp>
         <p:nvSpPr>
-          <p:cNvPr id="12" name="Text 9"/>
+          <p:cNvPr id="13" name="Text 10"/>
           <p:cNvSpPr txBox="1"/>
           <p:nvPr/>
         </p:nvSpPr>
         <p:spPr>
           <a:xfrm>
-            <a:off x="6812280" y="1508760"/>
+            <a:off x="6812280" y="1737360"/>
             <a:ext cx="2148840" cy="411480"/>
           </a:xfrm>
           <a:prstGeom prst="rect">
@@ -7359,14 +7457,14 @@
       </p:sp>
       <p:sp>
         <p:nvSpPr>
-          <p:cNvPr id="13" name="Text 10"/>
+          <p:cNvPr id="14" name="Text 11"/>
           <p:cNvSpPr txBox="1"/>
           <p:nvPr/>
         </p:nvSpPr>
         <p:spPr>
           <a:xfrm>
-            <a:off x="6812280" y="2011680"/>
-            <a:ext cx="2148840" cy="3108960"/>
+            <a:off x="6812280" y="2240280"/>
+            <a:ext cx="2148840" cy="2834640"/>
           </a:xfrm>
           <a:prstGeom prst="rect">
             <a:avLst/>
@@ -7398,14 +7496,14 @@
       </p:sp>
       <p:sp>
         <p:nvSpPr>
-          <p:cNvPr id="14" name="Shape 11"/>
+          <p:cNvPr id="15" name="Shape 12"/>
           <p:cNvSpPr/>
           <p:nvPr/>
         </p:nvSpPr>
         <p:spPr>
           <a:xfrm>
-            <a:off x="9235440" y="1371600"/>
-            <a:ext cx="2423160" cy="3840480"/>
+            <a:off x="9235440" y="1600200"/>
+            <a:ext cx="2423160" cy="3611880"/>
           </a:xfrm>
           <a:prstGeom prst="roundRect">
             <a:avLst>
@@ -7425,13 +7523,13 @@
       </p:sp>
       <p:sp>
         <p:nvSpPr>
-          <p:cNvPr id="15" name="Text 12"/>
+          <p:cNvPr id="16" name="Text 13"/>
           <p:cNvSpPr txBox="1"/>
           <p:nvPr/>
         </p:nvSpPr>
         <p:spPr>
           <a:xfrm>
-            <a:off x="9372600" y="1508760"/>
+            <a:off x="9372600" y="1737360"/>
             <a:ext cx="2148840" cy="411480"/>
           </a:xfrm>
           <a:prstGeom prst="rect">
@@ -7464,14 +7562,14 @@
       </p:sp>
       <p:sp>
         <p:nvSpPr>
-          <p:cNvPr id="16" name="Text 13"/>
+          <p:cNvPr id="17" name="Text 14"/>
           <p:cNvSpPr txBox="1"/>
           <p:nvPr/>
         </p:nvSpPr>
         <p:spPr>
           <a:xfrm>
-            <a:off x="9372600" y="2011680"/>
-            <a:ext cx="2148840" cy="3108960"/>
+            <a:off x="9372600" y="2240280"/>
+            <a:ext cx="2148840" cy="2834640"/>
           </a:xfrm>
           <a:prstGeom prst="rect">
             <a:avLst/>
@@ -7503,7 +7601,7 @@
       </p:sp>
       <p:sp>
         <p:nvSpPr>
-          <p:cNvPr id="17" name="Text 14"/>
+          <p:cNvPr id="18" name="Text 15"/>
           <p:cNvSpPr txBox="1"/>
           <p:nvPr/>
         </p:nvSpPr>
@@ -8315,7 +8413,7 @@
                 <a:ea typeface="Calibri" pitchFamily="34" charset="-122"/>
                 <a:cs typeface="Calibri" pitchFamily="34" charset="-120"/>
               </a:rPr>
-              <a:t>Kotter (1995) change model, tailored to Apple TV+</a:t>
+              <a:t>Kotter (1995) change model, tailored to Apple TV+. Digital skills and confidence: Vial (2019).</a:t>
             </a:r>
             <a:endParaRPr lang="en-US" sz="1100" dirty="0"/>
           </a:p>
@@ -8594,7 +8692,7 @@
                 <a:ea typeface="Calibri" pitchFamily="34" charset="-122"/>
                 <a:cs typeface="Calibri" pitchFamily="34" charset="-120"/>
               </a:rPr>
-              <a:t>Training in reading audience data, built around real projects.</a:t>
+              <a:t>Training in reading audience data, built around real projects (Vial, 2019).</a:t>
             </a:r>
             <a:endParaRPr lang="en-US" sz="1300" dirty="0"/>
           </a:p>

</xml_diff>

<commit_message>
Replace unverified Gracenote stat with verified 49%, update source details
Co-Authored-By: Claude Sonnet 5.5 <noreply@anthropic.com>
Claude-Session: https://claude.ai/code/session_01Ha62b6Wcst3n47bFqEFLKV
</commit_message>
<xml_diff>
--- a/Earning-the-Signal_revised.pptx
+++ b/Earning-the-Signal_revised.pptx
@@ -777,7 +777,7 @@
           <a:p>
             <a:r>
               <a:rPr lang="en-US" dirty="0"/>
-              <a:t>Every in-text citation appears here. Verify Antenna/ABC News and Gracenote figures against the originals before submission.</a:t>
+              <a:t>Every in-text citation appears here. Verify the Antenna/ABC News figure against the original before submission.</a:t>
             </a:r>
             <a:endParaRPr lang="en-US" dirty="0"/>
           </a:p>
@@ -1129,7 +1129,7 @@
           <a:p>
             <a:r>
               <a:rPr lang="en-US" dirty="0"/>
-              <a:t>Gracenote (2025) figure: verify at the source before final submission. Mokoena and Obagbuwa (2025) is a single national-market study, so applying it to Apple TV+ is an inference. Conclusion: personalisation is necessary but not sufficient.</a:t>
+              <a:t>Gracenote (2025): 49% likely to cancel over poor discovery (State of Play 2025, released 5 Nov 2025). Mokoena and Obagbuwa (2025) is a single national-market study, so applying it to Apple TV+ is an inference. Conclusion: personalisation is necessary but not sufficient.</a:t>
             </a:r>
             <a:endParaRPr lang="en-US" dirty="0"/>
           </a:p>
@@ -3867,7 +3867,7 @@
                 <a:ea typeface="Calibri" pitchFamily="34" charset="-122"/>
                 <a:cs typeface="Calibri" pitchFamily="34" charset="-120"/>
               </a:rPr>
-              <a:t>Gracenote (2025) State of Play. [verify against original report]</a:t>
+              <a:t>Gracenote (2025) State of Play 2025. Gracenote, a Nielsen company. Released 5 November 2025.</a:t>
             </a:r>
             <a:endParaRPr lang="en-US" sz="1200" dirty="0"/>
           </a:p>
@@ -3927,7 +3927,7 @@
                 <a:ea typeface="Calibri" pitchFamily="34" charset="-122"/>
                 <a:cs typeface="Calibri" pitchFamily="34" charset="-120"/>
               </a:rPr>
-              <a:t>Mokoena, T. and Obagbuwa, O. (2025) Personalisation and continuance intention in SVOD [journal details to be confirmed].</a:t>
+              <a:t>Mokoena, N. and Obagbuwa, I.C. (2025) ‘An analysis of artificial intelligence automation in digital music streaming platforms for improving consumer subscription responses: a review’, Frontiers in Artificial Intelligence, 7, Article 1515716.</a:t>
             </a:r>
             <a:endParaRPr lang="en-US" sz="1200" dirty="0"/>
           </a:p>
@@ -3967,7 +3967,7 @@
                 <a:ea typeface="Calibri" pitchFamily="34" charset="-122"/>
                 <a:cs typeface="Calibri" pitchFamily="34" charset="-120"/>
               </a:rPr>
-              <a:t>Pariser, E. (2011) The Filter Bubble. London: Viking.</a:t>
+              <a:t>Pariser, E. (2011) The Filter Bubble. New York: Penguin Press.</a:t>
             </a:r>
             <a:endParaRPr lang="en-US" sz="1200" dirty="0"/>
           </a:p>
@@ -4672,7 +4672,7 @@
                 <a:ea typeface="Calibri" pitchFamily="34" charset="-122"/>
                 <a:cs typeface="Calibri" pitchFamily="34" charset="-120"/>
               </a:rPr>
-              <a:t>Source: Antenna, as reported by ABC News (2024). Industry-wide figure, not specific to Apple TV+.</a:t>
+              <a:t>Source: Antenna (2024), as reported by ABC News. Industry-wide figure, not specific to Apple TV+.</a:t>
             </a:r>
             <a:endParaRPr lang="en-US" sz="1100" dirty="0"/>
           </a:p>
@@ -6288,7 +6288,7 @@
                 <a:ea typeface="Calibri" pitchFamily="34" charset="-122"/>
                 <a:cs typeface="Calibri" pitchFamily="34" charset="-120"/>
               </a:rPr>
-              <a:t>Viewers find relevant titles in a large catalogue; 74% rate recommendations “very” or “extremely” important (Gracenote, 2025).</a:t>
+              <a:t>Poor discovery costs subscribers: 49% of viewers say they are likely to cancel if they cannot find something to watch (Gracenote, 2025).</a:t>
             </a:r>
             <a:endParaRPr lang="en-US" sz="1250" dirty="0"/>
           </a:p>
@@ -6990,7 +6990,7 @@
                 <a:ea typeface="Calibri" pitchFamily="34" charset="-122"/>
                 <a:cs typeface="Calibri" pitchFamily="34" charset="-120"/>
               </a:rPr>
-              <a:t>Sources as cited in each row. Gracenote (2025) figure still to be verified at the original report.</a:t>
+              <a:t>Sources as cited in each row.</a:t>
             </a:r>
             <a:endParaRPr lang="en-US" sz="1100" dirty="0"/>
           </a:p>

</xml_diff>

<commit_message>
Add Apple TV+ serial-churn stat; reframe Mokoena and Obagbuwa as risk source
Co-Authored-By: Claude Sonnet 5.5 <noreply@anthropic.com>
Claude-Session: https://claude.ai/code/session_01Ha62b6Wcst3n47bFqEFLKV
</commit_message>
<xml_diff>
--- a/Earning-the-Signal_revised.pptx
+++ b/Earning-the-Signal_revised.pptx
@@ -865,7 +865,7 @@
           <a:p>
             <a:r>
               <a:rPr lang="en-US" dirty="0"/>
-              <a:t>Apple TV+ is an original-content subscription service that competes on quality rather than library size. Its content is integrated across Apple devices. The challenge: use data to improve recommendations without limiting creativity. Stat: Antenna churn data as reported by ABC News (check the original Antenna report before final submission). Reichheld (2003): retention is cheaper than acquisition.</a:t>
+              <a:t>Apple TV+ is an original-content subscription service that competes on quality rather than library size. Its content is integrated across Apple devices. The challenge: use data to improve recommendations without limiting creativity. Stat: Antenna (2024) serial-churn figure for Apple TV+; industry churn via ABC News. Confirm both against the Antenna report before submission. Reichheld (2003): retention is cheaper than acquisition.</a:t>
             </a:r>
             <a:endParaRPr lang="en-US" dirty="0"/>
           </a:p>
@@ -1129,7 +1129,7 @@
           <a:p>
             <a:r>
               <a:rPr lang="en-US" dirty="0"/>
-              <a:t>Gracenote (2025): 49% likely to cancel over poor discovery (State of Play 2025, released 5 Nov 2025). Mokoena and Obagbuwa (2025) is a single national-market study, so applying it to Apple TV+ is an inference. Conclusion: personalisation is necessary but not sufficient.</a:t>
+              <a:t>Gracenote (2025): 49% likely to cancel over poor discovery (State of Play 2025, released 5 Nov 2025). Mokoena and Obagbuwa (2025) is a review of AI in music streaming, used here for its privacy, governance and bias risks. Conclusion: personalisation is necessary but not sufficient.</a:t>
             </a:r>
             <a:endParaRPr lang="en-US" dirty="0"/>
           </a:p>
@@ -1393,7 +1393,7 @@
           <a:p>
             <a:r>
               <a:rPr lang="en-US" dirty="0"/>
-              <a:t>VRIO from Barney (1991). Honest verdict: valuable but not rare or hard to imitate, so the recommender alone gives parity. Engagement does not automatically produce retention (Mokoena and Obagbuwa, 2025). Optional Ansoff placement omitted.</a:t>
+              <a:t>VRIO from Barney (1991). Honest verdict: valuable but not rare or hard to imitate, so the recommender alone gives parity. Scaling AI brings privacy, governance and bias risks (Mokoena and Obagbuwa, 2025). Optional Ansoff placement omitted.</a:t>
             </a:r>
             <a:endParaRPr lang="en-US" dirty="0"/>
           </a:p>
@@ -3727,7 +3727,7 @@
                 <a:ea typeface="Calibri" pitchFamily="34" charset="-122"/>
                 <a:cs typeface="Calibri" pitchFamily="34" charset="-120"/>
               </a:rPr>
-              <a:t>Antenna (2024) as reported in ‘Streaming services see rising churn as serial cancelers seek value for money’, ABC News.</a:t>
+              <a:t>Antenna (2024) Domestic SVOD market data. Industry churn figures as reported in ‘Streaming services see rising churn as serial cancelers seek value for money’, ABC News.</a:t>
             </a:r>
             <a:endParaRPr lang="en-US" sz="1200" dirty="0"/>
           </a:p>
@@ -4555,7 +4555,7 @@
                 <a:ea typeface="Cambria" pitchFamily="34" charset="-122"/>
                 <a:cs typeface="Cambria" pitchFamily="34" charset="-120"/>
               </a:rPr>
-              <a:t>6.3%</a:t>
+              <a:t>37.2%</a:t>
             </a:r>
             <a:endParaRPr lang="en-US" sz="6000" dirty="0"/>
           </a:p>
@@ -4569,8 +4569,8 @@
         </p:nvSpPr>
         <p:spPr>
           <a:xfrm>
-            <a:off x="8046720" y="2834640"/>
-            <a:ext cx="3291840" cy="1280160"/>
+            <a:off x="8046720" y="2743200"/>
+            <a:ext cx="3291840" cy="1554480"/>
           </a:xfrm>
           <a:prstGeom prst="rect">
             <a:avLst/>
@@ -4594,7 +4594,7 @@
                 <a:ea typeface="Calibri" pitchFamily="34" charset="-122"/>
                 <a:cs typeface="Calibri" pitchFamily="34" charset="-120"/>
               </a:rPr>
-              <a:t>average monthly churn across major US streaming services, November 2023 (up from 5.1% in November 2022)</a:t>
+              <a:t>of Apple TV+ gross subscriber additions were returning subscribers who had cancelled within the prior 12 months, the highest serial-churn rate in the industry (Antenna, 2024)</a:t>
             </a:r>
             <a:endParaRPr lang="en-US" sz="1400" dirty="0"/>
           </a:p>
@@ -4608,8 +4608,8 @@
         </p:nvSpPr>
         <p:spPr>
           <a:xfrm>
-            <a:off x="8046720" y="4389120"/>
-            <a:ext cx="3291840" cy="822960"/>
+            <a:off x="8046720" y="4343400"/>
+            <a:ext cx="3291840" cy="1371600"/>
           </a:xfrm>
           <a:prstGeom prst="rect">
             <a:avLst/>
@@ -4625,7 +4625,7 @@
               <a:buNone/>
             </a:pPr>
             <a:r>
-              <a:rPr lang="en-US" sz="1300" i="1" dirty="0">
+              <a:rPr lang="en-US" sz="1200" i="1" dirty="0">
                 <a:solidFill>
                   <a:srgbClr val="6B7590"/>
                 </a:solidFill>
@@ -4633,9 +4633,9 @@
                 <a:ea typeface="Calibri" pitchFamily="34" charset="-122"/>
                 <a:cs typeface="Calibri" pitchFamily="34" charset="-120"/>
               </a:rPr>
-              <a:t>Retaining a subscriber costs less than acquiring one (Reichheld, 2003).</a:t>
-            </a:r>
-            <a:endParaRPr lang="en-US" sz="1300" dirty="0"/>
+              <a:t>Industry context: monthly churn across major US streaming services rose from 5.1% to 6.3% (Nov 2022 to Nov 2023). Retaining a subscriber costs less than acquiring one (Reichheld, 2003).</a:t>
+            </a:r>
+            <a:endParaRPr lang="en-US" sz="1200" dirty="0"/>
           </a:p>
         </p:txBody>
       </p:sp>
@@ -4672,7 +4672,7 @@
                 <a:ea typeface="Calibri" pitchFamily="34" charset="-122"/>
                 <a:cs typeface="Calibri" pitchFamily="34" charset="-120"/>
               </a:rPr>
-              <a:t>Source: Antenna (2024), as reported by ABC News. Industry-wide figure, not specific to Apple TV+.</a:t>
+              <a:t>Source: Antenna (2024); industry churn as reported by ABC News.</a:t>
             </a:r>
             <a:endParaRPr lang="en-US" sz="1100" dirty="0"/>
           </a:p>
@@ -6884,7 +6884,7 @@
                 <a:ea typeface="Calibri" pitchFamily="34" charset="-122"/>
                 <a:cs typeface="Calibri" pitchFamily="34" charset="-120"/>
               </a:rPr>
-              <a:t>Not decisive. </a:t>
+              <a:t>Privacy and governance. </a:t>
             </a:r>
             <a:pPr indent="0" marL="0">
               <a:buNone/>
@@ -6898,7 +6898,7 @@
                 <a:ea typeface="Calibri" pitchFamily="34" charset="-122"/>
                 <a:cs typeface="Calibri" pitchFamily="34" charset="-120"/>
               </a:rPr>
-              <a:t>Satisfaction and value predict continued use more than personalisation (Mokoena and Obagbuwa, 2025; single national market).</a:t>
+              <a:t>Scaling AI adds privacy risk, governance demands and algorithmic bias that limits content diversity (Mokoena and Obagbuwa, 2025).</a:t>
             </a:r>
             <a:endParaRPr lang="en-US" sz="1250" dirty="0"/>
           </a:p>
@@ -6951,7 +6951,7 @@
                 <a:ea typeface="Calibri" pitchFamily="34" charset="-122"/>
                 <a:cs typeface="Calibri" pitchFamily="34" charset="-120"/>
               </a:rPr>
-              <a:t>discovery (benefit), because a small catalogue of original shows only pays off if each is found; and creative originality (limitation), because Apple competes on quality. Personalisation is necessary but not sufficient.</a:t>
+              <a:t>discovery (benefit), because a small catalogue of original shows only pays off if each is found; and creative originality (limitation), because Apple competes on quality. Personalisation is necessary but not sufficient: its benefits depend on managing these limits.</a:t>
             </a:r>
             <a:endParaRPr lang="en-US" sz="1300" dirty="0"/>
           </a:p>
@@ -9367,7 +9367,7 @@
                           <a:ea typeface="Calibri" pitchFamily="34" charset="-122"/>
                           <a:cs typeface="Calibri" pitchFamily="34" charset="-120"/>
                         </a:rPr>
-                        <a:t>Better discovery supports retention and engagement (Gomez-Uribe and Hunt, 2015). But engagement alone does not guarantee renewal (Mokoena and Obagbuwa, 2025).</a:t>
+                        <a:t>Better discovery supports retention and engagement (Gomez-Uribe and Hunt, 2015). But scaling it brings privacy, governance and bias risks (Mokoena and Obagbuwa, 2025).</a:t>
                       </a:r>
                       <a:endParaRPr lang="en-US" sz="1250" dirty="0">
                         <a:latin typeface="Calibri" charset="0"/>

</xml_diff>

<commit_message>
Use brief departments as recommendation owners; label figures and tables
Co-Authored-By: Claude Sonnet 5.5 <noreply@anthropic.com>
Claude-Session: https://claude.ai/code/session_01Ha62b6Wcst3n47bFqEFLKV
</commit_message>
<xml_diff>
--- a/Earning-the-Signal_revised.pptx
+++ b/Earning-the-Signal_revised.pptx
@@ -2385,7 +2385,7 @@
                 <a:ea typeface="Calibri" pitchFamily="34" charset="-122"/>
                 <a:cs typeface="Calibri" pitchFamily="34" charset="-120"/>
               </a:rPr>
-              <a:t>Chief Content Officer, with Head of Data Science</a:t>
+              <a:t>Creative leadership (writers, producers, content developers), supported by the data team</a:t>
             </a:r>
             <a:endParaRPr lang="en-US" sz="1300" dirty="0"/>
           </a:p>
@@ -2648,7 +2648,7 @@
                 <a:ea typeface="Calibri" pitchFamily="34" charset="-122"/>
                 <a:cs typeface="Calibri" pitchFamily="34" charset="-120"/>
               </a:rPr>
-              <a:t>Head of Product</a:t>
+              <a:t>Marketing, with the product and technology teams</a:t>
             </a:r>
             <a:endParaRPr lang="en-US" sz="1300" dirty="0"/>
           </a:p>
@@ -2911,7 +2911,7 @@
                 <a:ea typeface="Calibri" pitchFamily="34" charset="-122"/>
                 <a:cs typeface="Calibri" pitchFamily="34" charset="-120"/>
               </a:rPr>
-              <a:t>Data Protection Officer</a:t>
+              <a:t>Operations (legal, compliance and employee support)</a:t>
             </a:r>
             <a:endParaRPr lang="en-US" sz="1300" dirty="0"/>
           </a:p>
@@ -5200,6 +5200,45 @@
         </p:nvSpPr>
         <p:spPr>
           <a:xfrm>
+            <a:off x="548640" y="6263640"/>
+            <a:ext cx="11064240" cy="365760"/>
+          </a:xfrm>
+          <a:prstGeom prst="rect">
+            <a:avLst/>
+          </a:prstGeom>
+          <a:noFill/>
+          <a:ln/>
+        </p:spPr>
+        <p:txBody>
+          <a:bodyPr wrap="square" lIns="0" tIns="0" rIns="0" bIns="0" rtlCol="0" anchor="t"/>
+          <a:lstStyle/>
+          <a:p>
+            <a:pPr indent="0" marL="0">
+              <a:buNone/>
+            </a:pPr>
+            <a:r>
+              <a:rPr lang="en-US" sz="1100" i="1" dirty="0">
+                <a:solidFill>
+                  <a:srgbClr val="6B7590"/>
+                </a:solidFill>
+                <a:latin typeface="Calibri" pitchFamily="34" charset="0"/>
+                <a:ea typeface="Calibri" pitchFamily="34" charset="-122"/>
+                <a:cs typeface="Calibri" pitchFamily="34" charset="-120"/>
+              </a:rPr>
+              <a:t>Figure 1: Input, process and output of a recommendation engine. Adapted from Resnick and Varian (1997) and Gomez-Uribe and Hunt (2015).</a:t>
+            </a:r>
+            <a:endParaRPr lang="en-US" sz="1100" dirty="0"/>
+          </a:p>
+        </p:txBody>
+      </p:sp>
+      <p:sp>
+        <p:nvSpPr>
+          <p:cNvPr id="18" name="Text 15"/>
+          <p:cNvSpPr txBox="1"/>
+          <p:nvPr/>
+        </p:nvSpPr>
+        <p:spPr>
+          <a:xfrm>
             <a:off x="548640" y="4663440"/>
             <a:ext cx="11064240" cy="1463040"/>
           </a:xfrm>
@@ -6036,7 +6075,7 @@
                 <a:ea typeface="Calibri" pitchFamily="34" charset="-122"/>
                 <a:cs typeface="Calibri" pitchFamily="34" charset="-120"/>
               </a:rPr>
-              <a:t>Source: Porter (2008). Highlighted forces are the two the recommender changes most.</a:t>
+              <a:t>Figure 2: Porter’s Five Forces (adapted from Porter, 2008). Highlighted forces are the two the recommender changes most.</a:t>
             </a:r>
             <a:endParaRPr lang="en-US" sz="1100" dirty="0"/>
           </a:p>
@@ -6990,7 +7029,7 @@
                 <a:ea typeface="Calibri" pitchFamily="34" charset="-122"/>
                 <a:cs typeface="Calibri" pitchFamily="34" charset="-120"/>
               </a:rPr>
-              <a:t>Sources as cited in each row.</a:t>
+              <a:t>Table 1: Benefits and limitations of personalisation. Sources as cited in each row.</a:t>
             </a:r>
             <a:endParaRPr lang="en-US" sz="1100" dirty="0"/>
           </a:p>
@@ -7607,6 +7646,45 @@
         </p:nvSpPr>
         <p:spPr>
           <a:xfrm>
+            <a:off x="548640" y="6263640"/>
+            <a:ext cx="11064240" cy="365760"/>
+          </a:xfrm>
+          <a:prstGeom prst="rect">
+            <a:avLst/>
+          </a:prstGeom>
+          <a:noFill/>
+          <a:ln/>
+        </p:spPr>
+        <p:txBody>
+          <a:bodyPr wrap="square" lIns="0" tIns="0" rIns="0" bIns="0" rtlCol="0" anchor="t"/>
+          <a:lstStyle/>
+          <a:p>
+            <a:pPr indent="0" marL="0">
+              <a:buNone/>
+            </a:pPr>
+            <a:r>
+              <a:rPr lang="en-US" sz="1100" i="1" dirty="0">
+                <a:solidFill>
+                  <a:srgbClr val="6B7590"/>
+                </a:solidFill>
+                <a:latin typeface="Calibri" pitchFamily="34" charset="0"/>
+                <a:ea typeface="Calibri" pitchFamily="34" charset="-122"/>
+                <a:cs typeface="Calibri" pitchFamily="34" charset="-120"/>
+              </a:rPr>
+              <a:t>Figure 3: Impact on creative teams (adapted from Davis, 1989; Napoli, 2014).</a:t>
+            </a:r>
+            <a:endParaRPr lang="en-US" sz="1100" dirty="0"/>
+          </a:p>
+        </p:txBody>
+      </p:sp>
+      <p:sp>
+        <p:nvSpPr>
+          <p:cNvPr id="19" name="Text 16"/>
+          <p:cNvSpPr txBox="1"/>
+          <p:nvPr/>
+        </p:nvSpPr>
+        <p:spPr>
+          <a:xfrm>
             <a:off x="548640" y="5440680"/>
             <a:ext cx="11064240" cy="731520"/>
           </a:xfrm>
@@ -8413,7 +8491,7 @@
                 <a:ea typeface="Calibri" pitchFamily="34" charset="-122"/>
                 <a:cs typeface="Calibri" pitchFamily="34" charset="-120"/>
               </a:rPr>
-              <a:t>Kotter (1995) change model, tailored to Apple TV+. Digital skills and confidence: Vial (2019).</a:t>
+              <a:t>Figure 4: Kotter (1995) change model, tailored to Apple TV+. Digital skills and confidence: Vial (2019).</a:t>
             </a:r>
             <a:endParaRPr lang="en-US" sz="1100" dirty="0"/>
           </a:p>
@@ -10049,6 +10127,45 @@
         </p:nvSpPr>
         <p:spPr>
           <a:xfrm>
+            <a:off x="548640" y="6263640"/>
+            <a:ext cx="11064240" cy="365760"/>
+          </a:xfrm>
+          <a:prstGeom prst="rect">
+            <a:avLst/>
+          </a:prstGeom>
+          <a:noFill/>
+          <a:ln/>
+        </p:spPr>
+        <p:txBody>
+          <a:bodyPr wrap="square" lIns="0" tIns="0" rIns="0" bIns="0" rtlCol="0" anchor="t"/>
+          <a:lstStyle/>
+          <a:p>
+            <a:pPr indent="0" marL="0">
+              <a:buNone/>
+            </a:pPr>
+            <a:r>
+              <a:rPr lang="en-US" sz="1100" i="1" dirty="0">
+                <a:solidFill>
+                  <a:srgbClr val="6B7590"/>
+                </a:solidFill>
+                <a:latin typeface="Calibri" pitchFamily="34" charset="0"/>
+                <a:ea typeface="Calibri" pitchFamily="34" charset="-122"/>
+                <a:cs typeface="Calibri" pitchFamily="34" charset="-120"/>
+              </a:rPr>
+              <a:t>Table 2: VRIO analysis of the recommendation engine (framework from Barney, 1991).</a:t>
+            </a:r>
+            <a:endParaRPr lang="en-US" sz="1100" dirty="0"/>
+          </a:p>
+        </p:txBody>
+      </p:sp>
+      <p:sp>
+        <p:nvSpPr>
+          <p:cNvPr id="7" name="Text 3"/>
+          <p:cNvSpPr txBox="1"/>
+          <p:nvPr/>
+        </p:nvSpPr>
+        <p:spPr>
+          <a:xfrm>
             <a:off x="548640" y="4297680"/>
             <a:ext cx="11064240" cy="640080"/>
           </a:xfrm>
@@ -10096,7 +10213,7 @@
       </p:sp>
       <p:sp>
         <p:nvSpPr>
-          <p:cNvPr id="7" name="Text 3"/>
+          <p:cNvPr id="8" name="Text 4"/>
           <p:cNvSpPr txBox="1"/>
           <p:nvPr/>
         </p:nvSpPr>
@@ -10135,7 +10252,7 @@
       </p:sp>
       <p:sp>
         <p:nvSpPr>
-          <p:cNvPr id="8" name="Shape 4"/>
+          <p:cNvPr id="9" name="Shape 5"/>
           <p:cNvSpPr/>
           <p:nvPr/>
         </p:nvSpPr>
@@ -10162,7 +10279,7 @@
       </p:sp>
       <p:sp>
         <p:nvSpPr>
-          <p:cNvPr id="9" name="Text 5"/>
+          <p:cNvPr id="10" name="Text 6"/>
           <p:cNvSpPr txBox="1"/>
           <p:nvPr/>
         </p:nvSpPr>
@@ -10215,7 +10332,7 @@
       </p:sp>
       <p:sp>
         <p:nvSpPr>
-          <p:cNvPr id="10" name="Shape 6"/>
+          <p:cNvPr id="11" name="Shape 7"/>
           <p:cNvSpPr/>
           <p:nvPr/>
         </p:nvSpPr>
@@ -10242,7 +10359,7 @@
       </p:sp>
       <p:sp>
         <p:nvSpPr>
-          <p:cNvPr id="11" name="Text 7"/>
+          <p:cNvPr id="12" name="Text 8"/>
           <p:cNvSpPr txBox="1"/>
           <p:nvPr/>
         </p:nvSpPr>
@@ -10295,7 +10412,7 @@
       </p:sp>
       <p:sp>
         <p:nvSpPr>
-          <p:cNvPr id="12" name="Shape 8"/>
+          <p:cNvPr id="13" name="Shape 9"/>
           <p:cNvSpPr/>
           <p:nvPr/>
         </p:nvSpPr>
@@ -10322,7 +10439,7 @@
       </p:sp>
       <p:sp>
         <p:nvSpPr>
-          <p:cNvPr id="13" name="Text 9"/>
+          <p:cNvPr id="14" name="Text 10"/>
           <p:cNvSpPr txBox="1"/>
           <p:nvPr/>
         </p:nvSpPr>
@@ -12192,7 +12309,7 @@
                 <a:ea typeface="Calibri" pitchFamily="34" charset="-122"/>
                 <a:cs typeface="Calibri" pitchFamily="34" charset="-120"/>
               </a:rPr>
-              <a:t>Sources: European Parliament and Council (2016); Ricci et al. (2015); Floridi et al. (2018); Napoli (2014); Pariser (2011); Helberger (2019).</a:t>
+              <a:t>Table 3: Ethical, social and risk issues. Sources: European Parliament and Council (2016); Ricci et al. (2015); Floridi et al. (2018); Napoli (2014); Pariser (2011); Helberger (2019).</a:t>
             </a:r>
             <a:endParaRPr lang="en-US" sz="1100" dirty="0"/>
           </a:p>

</xml_diff>

<commit_message>
Add slide 4 flow and Ansoff placement
Co-Authored-By: Claude Sonnet 5.5 <noreply@anthropic.com>
Claude-Session: https://claude.ai/code/session_01Ha62b6Wcst3n47bFqEFLKV
</commit_message>
<xml_diff>
--- a/Earning-the-Signal_revised.pptx
+++ b/Earning-the-Signal_revised.pptx
@@ -1393,7 +1393,7 @@
           <a:p>
             <a:r>
               <a:rPr lang="en-US" dirty="0"/>
-              <a:t>VRIO from Barney (1991). Honest verdict: valuable but not rare or hard to imitate, so the recommender alone gives parity. Scaling AI brings privacy, governance and bias risks (Mokoena and Obagbuwa, 2025). Optional Ansoff placement omitted.</a:t>
+              <a:t>VRIO from Barney (1991). Honest verdict: valuable but not rare or hard to imitate, so the recommender alone gives parity. Scaling AI brings privacy, governance and bias risks (Mokoena and Obagbuwa, 2025). Ansoff placement: market penetration (Ansoff, 1957).</a:t>
             </a:r>
             <a:endParaRPr lang="en-US" dirty="0"/>
           </a:p>
@@ -3747,6 +3747,26 @@
                 <a:ea typeface="Calibri" pitchFamily="34" charset="-122"/>
                 <a:cs typeface="Calibri" pitchFamily="34" charset="-120"/>
               </a:rPr>
+              <a:t>Ansoff, H.I. (1957) ‘Strategies for diversification’, Harvard Business Review, 35(5), pp.113–124.</a:t>
+            </a:r>
+            <a:endParaRPr lang="en-US" sz="1200" dirty="0"/>
+          </a:p>
+          <a:p>
+            <a:pPr indent="0" marL="0">
+              <a:spcAft>
+                <a:spcPts val="400"/>
+              </a:spcAft>
+              <a:buNone/>
+            </a:pPr>
+            <a:r>
+              <a:rPr lang="en-US" sz="1200" dirty="0">
+                <a:solidFill>
+                  <a:srgbClr val="27314D"/>
+                </a:solidFill>
+                <a:latin typeface="Calibri" pitchFamily="34" charset="0"/>
+                <a:ea typeface="Calibri" pitchFamily="34" charset="-122"/>
+                <a:cs typeface="Calibri" pitchFamily="34" charset="-120"/>
+              </a:rPr>
               <a:t>Apple Inc. (2025) Apple TV App &amp; Privacy. Cupertino: Apple Inc.</a:t>
             </a:r>
             <a:endParaRPr lang="en-US" sz="1200" dirty="0"/>
@@ -5654,6 +5674,262 @@
         </p:nvSpPr>
         <p:spPr>
           <a:xfrm>
+            <a:off x="548640" y="5120640"/>
+            <a:ext cx="1508760" cy="731520"/>
+          </a:xfrm>
+          <a:prstGeom prst="homePlate">
+            <a:avLst/>
+          </a:prstGeom>
+          <a:solidFill>
+            <a:srgbClr val="1E56A0"/>
+          </a:solidFill>
+          <a:ln w="12700">
+            <a:solidFill>
+              <a:srgbClr val="FFFFFF"/>
+            </a:solidFill>
+            <a:prstDash val="solid"/>
+          </a:ln>
+        </p:spPr>
+      </p:sp>
+      <p:sp>
+        <p:nvSpPr>
+          <p:cNvPr id="7" name="Text 4"/>
+          <p:cNvSpPr txBox="1"/>
+          <p:nvPr/>
+        </p:nvSpPr>
+        <p:spPr>
+          <a:xfrm>
+            <a:off x="621792" y="5120640"/>
+            <a:ext cx="1188720" cy="731520"/>
+          </a:xfrm>
+          <a:prstGeom prst="rect">
+            <a:avLst/>
+          </a:prstGeom>
+          <a:noFill/>
+          <a:ln/>
+        </p:spPr>
+        <p:txBody>
+          <a:bodyPr wrap="square" lIns="0" tIns="0" rIns="0" bIns="0" rtlCol="0" anchor="ctr"/>
+          <a:lstStyle/>
+          <a:p>
+            <a:pPr indent="0" marL="0">
+              <a:buNone/>
+            </a:pPr>
+            <a:r>
+              <a:rPr lang="en-US" sz="1200" b="1" dirty="0">
+                <a:solidFill>
+                  <a:srgbClr val="FFFFFF"/>
+                </a:solidFill>
+                <a:latin typeface="Calibri" pitchFamily="34" charset="0"/>
+                <a:ea typeface="Calibri" pitchFamily="34" charset="-122"/>
+                <a:cs typeface="Calibri" pitchFamily="34" charset="-120"/>
+              </a:rPr>
+              <a:t>Viewing data</a:t>
+            </a:r>
+            <a:endParaRPr lang="en-US" sz="1200" dirty="0"/>
+          </a:p>
+        </p:txBody>
+      </p:sp>
+      <p:sp>
+        <p:nvSpPr>
+          <p:cNvPr id="8" name="Shape 5"/>
+          <p:cNvSpPr/>
+          <p:nvPr/>
+        </p:nvSpPr>
+        <p:spPr>
+          <a:xfrm>
+            <a:off x="2084832" y="5120640"/>
+            <a:ext cx="1508760" cy="731520"/>
+          </a:xfrm>
+          <a:prstGeom prst="homePlate">
+            <a:avLst/>
+          </a:prstGeom>
+          <a:solidFill>
+            <a:srgbClr val="1E2761"/>
+          </a:solidFill>
+          <a:ln w="12700">
+            <a:solidFill>
+              <a:srgbClr val="FFFFFF"/>
+            </a:solidFill>
+            <a:prstDash val="solid"/>
+          </a:ln>
+        </p:spPr>
+      </p:sp>
+      <p:sp>
+        <p:nvSpPr>
+          <p:cNvPr id="9" name="Text 6"/>
+          <p:cNvSpPr txBox="1"/>
+          <p:nvPr/>
+        </p:nvSpPr>
+        <p:spPr>
+          <a:xfrm>
+            <a:off x="2157984" y="5120640"/>
+            <a:ext cx="1188720" cy="731520"/>
+          </a:xfrm>
+          <a:prstGeom prst="rect">
+            <a:avLst/>
+          </a:prstGeom>
+          <a:noFill/>
+          <a:ln/>
+        </p:spPr>
+        <p:txBody>
+          <a:bodyPr wrap="square" lIns="0" tIns="0" rIns="0" bIns="0" rtlCol="0" anchor="ctr"/>
+          <a:lstStyle/>
+          <a:p>
+            <a:pPr indent="0" marL="0">
+              <a:buNone/>
+            </a:pPr>
+            <a:r>
+              <a:rPr lang="en-US" sz="1200" b="1" dirty="0">
+                <a:solidFill>
+                  <a:srgbClr val="FFFFFF"/>
+                </a:solidFill>
+                <a:latin typeface="Calibri" pitchFamily="34" charset="0"/>
+                <a:ea typeface="Calibri" pitchFamily="34" charset="-122"/>
+                <a:cs typeface="Calibri" pitchFamily="34" charset="-120"/>
+              </a:rPr>
+              <a:t>Recommendation engine</a:t>
+            </a:r>
+            <a:endParaRPr lang="en-US" sz="1200" dirty="0"/>
+          </a:p>
+        </p:txBody>
+      </p:sp>
+      <p:sp>
+        <p:nvSpPr>
+          <p:cNvPr id="10" name="Shape 7"/>
+          <p:cNvSpPr/>
+          <p:nvPr/>
+        </p:nvSpPr>
+        <p:spPr>
+          <a:xfrm>
+            <a:off x="3621024" y="5120640"/>
+            <a:ext cx="1508760" cy="731520"/>
+          </a:xfrm>
+          <a:prstGeom prst="homePlate">
+            <a:avLst/>
+          </a:prstGeom>
+          <a:solidFill>
+            <a:srgbClr val="1E56A0"/>
+          </a:solidFill>
+          <a:ln w="12700">
+            <a:solidFill>
+              <a:srgbClr val="FFFFFF"/>
+            </a:solidFill>
+            <a:prstDash val="solid"/>
+          </a:ln>
+        </p:spPr>
+      </p:sp>
+      <p:sp>
+        <p:nvSpPr>
+          <p:cNvPr id="11" name="Text 8"/>
+          <p:cNvSpPr txBox="1"/>
+          <p:nvPr/>
+        </p:nvSpPr>
+        <p:spPr>
+          <a:xfrm>
+            <a:off x="3694176" y="5120640"/>
+            <a:ext cx="1188720" cy="731520"/>
+          </a:xfrm>
+          <a:prstGeom prst="rect">
+            <a:avLst/>
+          </a:prstGeom>
+          <a:noFill/>
+          <a:ln/>
+        </p:spPr>
+        <p:txBody>
+          <a:bodyPr wrap="square" lIns="0" tIns="0" rIns="0" bIns="0" rtlCol="0" anchor="ctr"/>
+          <a:lstStyle/>
+          <a:p>
+            <a:pPr indent="0" marL="0">
+              <a:buNone/>
+            </a:pPr>
+            <a:r>
+              <a:rPr lang="en-US" sz="1200" b="1" dirty="0">
+                <a:solidFill>
+                  <a:srgbClr val="FFFFFF"/>
+                </a:solidFill>
+                <a:latin typeface="Calibri" pitchFamily="34" charset="0"/>
+                <a:ea typeface="Calibri" pitchFamily="34" charset="-122"/>
+                <a:cs typeface="Calibri" pitchFamily="34" charset="-120"/>
+              </a:rPr>
+              <a:t>Tailored home screen</a:t>
+            </a:r>
+            <a:endParaRPr lang="en-US" sz="1200" dirty="0"/>
+          </a:p>
+        </p:txBody>
+      </p:sp>
+      <p:sp>
+        <p:nvSpPr>
+          <p:cNvPr id="12" name="Shape 9"/>
+          <p:cNvSpPr/>
+          <p:nvPr/>
+        </p:nvSpPr>
+        <p:spPr>
+          <a:xfrm>
+            <a:off x="5157216" y="5120640"/>
+            <a:ext cx="1508760" cy="731520"/>
+          </a:xfrm>
+          <a:prstGeom prst="homePlate">
+            <a:avLst/>
+          </a:prstGeom>
+          <a:solidFill>
+            <a:srgbClr val="1E56A0"/>
+          </a:solidFill>
+          <a:ln w="12700">
+            <a:solidFill>
+              <a:srgbClr val="FFFFFF"/>
+            </a:solidFill>
+            <a:prstDash val="solid"/>
+          </a:ln>
+        </p:spPr>
+      </p:sp>
+      <p:sp>
+        <p:nvSpPr>
+          <p:cNvPr id="13" name="Text 10"/>
+          <p:cNvSpPr txBox="1"/>
+          <p:nvPr/>
+        </p:nvSpPr>
+        <p:spPr>
+          <a:xfrm>
+            <a:off x="5230368" y="5120640"/>
+            <a:ext cx="1188720" cy="731520"/>
+          </a:xfrm>
+          <a:prstGeom prst="rect">
+            <a:avLst/>
+          </a:prstGeom>
+          <a:noFill/>
+          <a:ln/>
+        </p:spPr>
+        <p:txBody>
+          <a:bodyPr wrap="square" lIns="0" tIns="0" rIns="0" bIns="0" rtlCol="0" anchor="ctr"/>
+          <a:lstStyle/>
+          <a:p>
+            <a:pPr indent="0" marL="0">
+              <a:buNone/>
+            </a:pPr>
+            <a:r>
+              <a:rPr lang="en-US" sz="1200" b="1" dirty="0">
+                <a:solidFill>
+                  <a:srgbClr val="FFFFFF"/>
+                </a:solidFill>
+                <a:latin typeface="Calibri" pitchFamily="34" charset="0"/>
+                <a:ea typeface="Calibri" pitchFamily="34" charset="-122"/>
+                <a:cs typeface="Calibri" pitchFamily="34" charset="-120"/>
+              </a:rPr>
+              <a:t>Retention vs rivals</a:t>
+            </a:r>
+            <a:endParaRPr lang="en-US" sz="1200" dirty="0"/>
+          </a:p>
+        </p:txBody>
+      </p:sp>
+      <p:sp>
+        <p:nvSpPr>
+          <p:cNvPr id="14" name="Shape 11"/>
+          <p:cNvSpPr/>
+          <p:nvPr/>
+        </p:nvSpPr>
+        <p:spPr>
+          <a:xfrm>
             <a:off x="6949440" y="1371600"/>
             <a:ext cx="4663440" cy="4572000"/>
           </a:xfrm>
@@ -5675,7 +5951,7 @@
       </p:sp>
       <p:sp>
         <p:nvSpPr>
-          <p:cNvPr id="7" name="Text 4"/>
+          <p:cNvPr id="15" name="Text 12"/>
           <p:cNvSpPr txBox="1"/>
           <p:nvPr/>
         </p:nvSpPr>
@@ -5714,7 +5990,7 @@
       </p:sp>
       <p:sp>
         <p:nvSpPr>
-          <p:cNvPr id="8" name="Shape 5"/>
+          <p:cNvPr id="16" name="Shape 13"/>
           <p:cNvSpPr/>
           <p:nvPr/>
         </p:nvSpPr>
@@ -5741,7 +6017,7 @@
       </p:sp>
       <p:sp>
         <p:nvSpPr>
-          <p:cNvPr id="9" name="Text 6"/>
+          <p:cNvPr id="17" name="Text 14"/>
           <p:cNvSpPr txBox="1"/>
           <p:nvPr/>
         </p:nvSpPr>
@@ -5780,7 +6056,7 @@
       </p:sp>
       <p:sp>
         <p:nvSpPr>
-          <p:cNvPr id="10" name="Shape 7"/>
+          <p:cNvPr id="18" name="Shape 15"/>
           <p:cNvSpPr/>
           <p:nvPr/>
         </p:nvSpPr>
@@ -5807,7 +6083,7 @@
       </p:sp>
       <p:sp>
         <p:nvSpPr>
-          <p:cNvPr id="11" name="Text 8"/>
+          <p:cNvPr id="19" name="Text 16"/>
           <p:cNvSpPr txBox="1"/>
           <p:nvPr/>
         </p:nvSpPr>
@@ -5846,7 +6122,7 @@
       </p:sp>
       <p:sp>
         <p:nvSpPr>
-          <p:cNvPr id="12" name="Shape 9"/>
+          <p:cNvPr id="20" name="Shape 17"/>
           <p:cNvSpPr/>
           <p:nvPr/>
         </p:nvSpPr>
@@ -5873,7 +6149,7 @@
       </p:sp>
       <p:sp>
         <p:nvSpPr>
-          <p:cNvPr id="13" name="Text 10"/>
+          <p:cNvPr id="21" name="Text 18"/>
           <p:cNvSpPr txBox="1"/>
           <p:nvPr/>
         </p:nvSpPr>
@@ -5912,7 +6188,7 @@
       </p:sp>
       <p:sp>
         <p:nvSpPr>
-          <p:cNvPr id="14" name="Shape 11"/>
+          <p:cNvPr id="22" name="Shape 19"/>
           <p:cNvSpPr/>
           <p:nvPr/>
         </p:nvSpPr>
@@ -5939,7 +6215,7 @@
       </p:sp>
       <p:sp>
         <p:nvSpPr>
-          <p:cNvPr id="15" name="Text 12"/>
+          <p:cNvPr id="23" name="Text 20"/>
           <p:cNvSpPr txBox="1"/>
           <p:nvPr/>
         </p:nvSpPr>
@@ -5978,7 +6254,7 @@
       </p:sp>
       <p:sp>
         <p:nvSpPr>
-          <p:cNvPr id="16" name="Shape 13"/>
+          <p:cNvPr id="24" name="Shape 21"/>
           <p:cNvSpPr/>
           <p:nvPr/>
         </p:nvSpPr>
@@ -6005,7 +6281,7 @@
       </p:sp>
       <p:sp>
         <p:nvSpPr>
-          <p:cNvPr id="17" name="Text 14"/>
+          <p:cNvPr id="25" name="Text 22"/>
           <p:cNvSpPr txBox="1"/>
           <p:nvPr/>
         </p:nvSpPr>
@@ -6044,7 +6320,7 @@
       </p:sp>
       <p:sp>
         <p:nvSpPr>
-          <p:cNvPr id="18" name="Text 15"/>
+          <p:cNvPr id="26" name="Text 23"/>
           <p:cNvSpPr txBox="1"/>
           <p:nvPr/>
         </p:nvSpPr>
@@ -10259,7 +10535,7 @@
         <p:spPr>
           <a:xfrm>
             <a:off x="548640" y="5349240"/>
-            <a:ext cx="3611880" cy="822960"/>
+            <a:ext cx="2697480" cy="822960"/>
           </a:xfrm>
           <a:prstGeom prst="roundRect">
             <a:avLst>
@@ -10285,8 +10561,8 @@
         </p:nvSpPr>
         <p:spPr>
           <a:xfrm>
-            <a:off x="685800" y="5349240"/>
-            <a:ext cx="3337560" cy="822960"/>
+            <a:off x="658368" y="5349240"/>
+            <a:ext cx="2478024" cy="822960"/>
           </a:xfrm>
           <a:prstGeom prst="rect">
             <a:avLst/>
@@ -10302,7 +10578,7 @@
               <a:buNone/>
             </a:pPr>
             <a:r>
-              <a:rPr lang="en-US" sz="1300" b="1" dirty="0">
+              <a:rPr lang="en-US" sz="1200" b="1" dirty="0">
                 <a:solidFill>
                   <a:srgbClr val="1E2761"/>
                 </a:solidFill>
@@ -10316,7 +10592,7 @@
               <a:buNone/>
             </a:pPr>
             <a:r>
-              <a:rPr lang="en-US" sz="1300" dirty="0">
+              <a:rPr lang="en-US" sz="1200" dirty="0">
                 <a:solidFill>
                   <a:srgbClr val="27314D"/>
                 </a:solidFill>
@@ -10324,9 +10600,9 @@
                 <a:ea typeface="Calibri" pitchFamily="34" charset="-122"/>
                 <a:cs typeface="Calibri" pitchFamily="34" charset="-120"/>
               </a:rPr>
-              <a:t>A/B test recommendation changes against retention</a:t>
-            </a:r>
-            <a:endParaRPr lang="en-US" sz="1300" dirty="0"/>
+              <a:t>A/B test changes against retention</a:t>
+            </a:r>
+            <a:endParaRPr lang="en-US" sz="1200" dirty="0"/>
           </a:p>
         </p:txBody>
       </p:sp>
@@ -10338,8 +10614,8 @@
         </p:nvSpPr>
         <p:spPr>
           <a:xfrm>
-            <a:off x="4297680" y="5349240"/>
-            <a:ext cx="3611880" cy="822960"/>
+            <a:off x="3355848" y="5349240"/>
+            <a:ext cx="2697480" cy="822960"/>
           </a:xfrm>
           <a:prstGeom prst="roundRect">
             <a:avLst>
@@ -10365,8 +10641,8 @@
         </p:nvSpPr>
         <p:spPr>
           <a:xfrm>
-            <a:off x="4434840" y="5349240"/>
-            <a:ext cx="3337560" cy="822960"/>
+            <a:off x="3465576" y="5349240"/>
+            <a:ext cx="2478024" cy="822960"/>
           </a:xfrm>
           <a:prstGeom prst="rect">
             <a:avLst/>
@@ -10382,7 +10658,7 @@
               <a:buNone/>
             </a:pPr>
             <a:r>
-              <a:rPr lang="en-US" sz="1300" b="1" dirty="0">
+              <a:rPr lang="en-US" sz="1200" b="1" dirty="0">
                 <a:solidFill>
                   <a:srgbClr val="1E2761"/>
                 </a:solidFill>
@@ -10396,7 +10672,7 @@
               <a:buNone/>
             </a:pPr>
             <a:r>
-              <a:rPr lang="en-US" sz="1300" dirty="0">
+              <a:rPr lang="en-US" sz="1200" dirty="0">
                 <a:solidFill>
                   <a:srgbClr val="27314D"/>
                 </a:solidFill>
@@ -10406,7 +10682,7 @@
               </a:rPr>
               <a:t>Creatives help set the goals the model optimises</a:t>
             </a:r>
-            <a:endParaRPr lang="en-US" sz="1300" dirty="0"/>
+            <a:endParaRPr lang="en-US" sz="1200" dirty="0"/>
           </a:p>
         </p:txBody>
       </p:sp>
@@ -10418,8 +10694,8 @@
         </p:nvSpPr>
         <p:spPr>
           <a:xfrm>
-            <a:off x="8046720" y="5349240"/>
-            <a:ext cx="3611880" cy="822960"/>
+            <a:off x="6163056" y="5349240"/>
+            <a:ext cx="2697480" cy="822960"/>
           </a:xfrm>
           <a:prstGeom prst="roundRect">
             <a:avLst>
@@ -10445,8 +10721,8 @@
         </p:nvSpPr>
         <p:spPr>
           <a:xfrm>
-            <a:off x="8183880" y="5349240"/>
-            <a:ext cx="3337560" cy="822960"/>
+            <a:off x="6272784" y="5349240"/>
+            <a:ext cx="2478024" cy="822960"/>
           </a:xfrm>
           <a:prstGeom prst="rect">
             <a:avLst/>
@@ -10462,7 +10738,7 @@
               <a:buNone/>
             </a:pPr>
             <a:r>
-              <a:rPr lang="en-US" sz="1300" b="1" dirty="0">
+              <a:rPr lang="en-US" sz="1200" b="1" dirty="0">
                 <a:solidFill>
                   <a:srgbClr val="1E2761"/>
                 </a:solidFill>
@@ -10476,7 +10752,7 @@
               <a:buNone/>
             </a:pPr>
             <a:r>
-              <a:rPr lang="en-US" sz="1300" dirty="0">
+              <a:rPr lang="en-US" sz="1200" dirty="0">
                 <a:solidFill>
                   <a:srgbClr val="27314D"/>
                 </a:solidFill>
@@ -10486,7 +10762,87 @@
               </a:rPr>
               <a:t>Update data and models regularly</a:t>
             </a:r>
-            <a:endParaRPr lang="en-US" sz="1300" dirty="0"/>
+            <a:endParaRPr lang="en-US" sz="1200" dirty="0"/>
+          </a:p>
+        </p:txBody>
+      </p:sp>
+      <p:sp>
+        <p:nvSpPr>
+          <p:cNvPr id="15" name="Shape 11"/>
+          <p:cNvSpPr/>
+          <p:nvPr/>
+        </p:nvSpPr>
+        <p:spPr>
+          <a:xfrm>
+            <a:off x="8970264" y="5349240"/>
+            <a:ext cx="2697480" cy="822960"/>
+          </a:xfrm>
+          <a:prstGeom prst="roundRect">
+            <a:avLst>
+              <a:gd name="adj" fmla="val 8889"/>
+            </a:avLst>
+          </a:prstGeom>
+          <a:solidFill>
+            <a:srgbClr val="F2F5FB"/>
+          </a:solidFill>
+          <a:ln w="12700">
+            <a:solidFill>
+              <a:srgbClr val="CADCFC"/>
+            </a:solidFill>
+            <a:prstDash val="solid"/>
+          </a:ln>
+        </p:spPr>
+      </p:sp>
+      <p:sp>
+        <p:nvSpPr>
+          <p:cNvPr id="16" name="Text 12"/>
+          <p:cNvSpPr txBox="1"/>
+          <p:nvPr/>
+        </p:nvSpPr>
+        <p:spPr>
+          <a:xfrm>
+            <a:off x="9079992" y="5349240"/>
+            <a:ext cx="2478024" cy="822960"/>
+          </a:xfrm>
+          <a:prstGeom prst="rect">
+            <a:avLst/>
+          </a:prstGeom>
+          <a:noFill/>
+          <a:ln/>
+        </p:spPr>
+        <p:txBody>
+          <a:bodyPr wrap="square" lIns="0" tIns="0" rIns="0" bIns="0" rtlCol="0" anchor="ctr"/>
+          <a:lstStyle/>
+          <a:p>
+            <a:pPr indent="0" marL="0">
+              <a:buNone/>
+            </a:pPr>
+            <a:r>
+              <a:rPr lang="en-US" sz="1200" b="1" dirty="0">
+                <a:solidFill>
+                  <a:srgbClr val="1E2761"/>
+                </a:solidFill>
+                <a:latin typeface="Calibri" pitchFamily="34" charset="0"/>
+                <a:ea typeface="Calibri" pitchFamily="34" charset="-122"/>
+                <a:cs typeface="Calibri" pitchFamily="34" charset="-120"/>
+              </a:rPr>
+              <a:t>Ansoff: </a:t>
+            </a:r>
+            <a:pPr indent="0" marL="0">
+              <a:buNone/>
+            </a:pPr>
+            <a:r>
+              <a:rPr lang="en-US" sz="1200" dirty="0">
+                <a:solidFill>
+                  <a:srgbClr val="27314D"/>
+                </a:solidFill>
+                <a:latin typeface="Calibri" pitchFamily="34" charset="0"/>
+                <a:ea typeface="Calibri" pitchFamily="34" charset="-122"/>
+                <a:cs typeface="Calibri" pitchFamily="34" charset="-120"/>
+              </a:rPr>
+              <a:t>Market penetration: deeper retention in existing markets (Ansoff, 1957)</a:t>
+            </a:r>
+            <a:endParaRPr lang="en-US" sz="1200" dirty="0"/>
           </a:p>
         </p:txBody>
       </p:sp>

</xml_diff>

<commit_message>
Add Gartner Hype Cycle placement to slide 5
Co-Authored-By: Claude Sonnet 5.5 <noreply@anthropic.com>
Claude-Session: https://claude.ai/code/session_01Ha62b6Wcst3n47bFqEFLKV
</commit_message>
<xml_diff>
--- a/Earning-the-Signal_revised.pptx
+++ b/Earning-the-Signal_revised.pptx
@@ -1129,7 +1129,7 @@
           <a:p>
             <a:r>
               <a:rPr lang="en-US" dirty="0"/>
-              <a:t>Gracenote (2025): 49% likely to cancel over poor discovery (State of Play 2025, released 5 Nov 2025). Mokoena and Obagbuwa (2025) is a review of AI in music streaming, used here for its privacy, governance and bias risks. Conclusion: personalisation is necessary but not sufficient.</a:t>
+              <a:t>Gracenote (2025): 49% likely to cancel over poor discovery (State of Play 2025, released 5 Nov 2025). Mokoena and Obagbuwa (2025) is a review of AI in music streaming, used here for its privacy, governance and bias risks. Conclusion: personalisation is necessary but not sufficient. Hype Cycle placement per Gartner (2024), Hype Cycle for Digital Marketing; confirm against the report.</a:t>
             </a:r>
             <a:endParaRPr lang="en-US" dirty="0"/>
           </a:p>
@@ -3867,6 +3867,26 @@
                 <a:ea typeface="Calibri" pitchFamily="34" charset="-122"/>
                 <a:cs typeface="Calibri" pitchFamily="34" charset="-120"/>
               </a:rPr>
+              <a:t>Gartner (2024) Hype Cycle for Digital Marketing, 2024. Stamford: Gartner. Available at: https://www.gartner.com/en/documents/5623191 (Accessed: 25 October 2026).</a:t>
+            </a:r>
+            <a:endParaRPr lang="en-US" sz="1200" dirty="0"/>
+          </a:p>
+          <a:p>
+            <a:pPr indent="0" marL="0">
+              <a:spcAft>
+                <a:spcPts val="400"/>
+              </a:spcAft>
+              <a:buNone/>
+            </a:pPr>
+            <a:r>
+              <a:rPr lang="en-US" sz="1200" dirty="0">
+                <a:solidFill>
+                  <a:srgbClr val="27314D"/>
+                </a:solidFill>
+                <a:latin typeface="Calibri" pitchFamily="34" charset="0"/>
+                <a:ea typeface="Calibri" pitchFamily="34" charset="-122"/>
+                <a:cs typeface="Calibri" pitchFamily="34" charset="-120"/>
+              </a:rPr>
               <a:t>Gomez-Uribe, C.A. and Hunt, N. (2015) ‘The Netflix recommender system’, ACM Transactions on Management Information Systems, 6(4), Article 13.</a:t>
             </a:r>
             <a:endParaRPr lang="en-US" sz="1200" dirty="0"/>
@@ -6838,7 +6858,7 @@
         <p:spPr>
           <a:xfrm>
             <a:off x="6217920" y="1828800"/>
-            <a:ext cx="5394960" cy="731520"/>
+            <a:ext cx="5394960" cy="676656"/>
           </a:xfrm>
           <a:prstGeom prst="rect">
             <a:avLst/>
@@ -6863,7 +6883,7 @@
         <p:spPr>
           <a:xfrm>
             <a:off x="6355080" y="1874520"/>
-            <a:ext cx="5120640" cy="640080"/>
+            <a:ext cx="5120640" cy="585216"/>
           </a:xfrm>
           <a:prstGeom prst="rect">
             <a:avLst/>
@@ -6915,8 +6935,8 @@
         </p:nvSpPr>
         <p:spPr>
           <a:xfrm>
-            <a:off x="6217920" y="2560320"/>
-            <a:ext cx="5394960" cy="731520"/>
+            <a:off x="6217920" y="2505456"/>
+            <a:ext cx="5394960" cy="676656"/>
           </a:xfrm>
           <a:prstGeom prst="rect">
             <a:avLst/>
@@ -6940,8 +6960,8 @@
         </p:nvSpPr>
         <p:spPr>
           <a:xfrm>
-            <a:off x="6355080" y="2606040"/>
-            <a:ext cx="5120640" cy="640080"/>
+            <a:off x="6355080" y="2551176"/>
+            <a:ext cx="5120640" cy="585216"/>
           </a:xfrm>
           <a:prstGeom prst="rect">
             <a:avLst/>
@@ -6993,8 +7013,8 @@
         </p:nvSpPr>
         <p:spPr>
           <a:xfrm>
-            <a:off x="6217920" y="3291840"/>
-            <a:ext cx="5394960" cy="731520"/>
+            <a:off x="6217920" y="3182112"/>
+            <a:ext cx="5394960" cy="676656"/>
           </a:xfrm>
           <a:prstGeom prst="rect">
             <a:avLst/>
@@ -7018,8 +7038,8 @@
         </p:nvSpPr>
         <p:spPr>
           <a:xfrm>
-            <a:off x="6355080" y="3337560"/>
-            <a:ext cx="5120640" cy="640080"/>
+            <a:off x="6355080" y="3227832"/>
+            <a:ext cx="5120640" cy="585216"/>
           </a:xfrm>
           <a:prstGeom prst="rect">
             <a:avLst/>
@@ -7071,8 +7091,8 @@
         </p:nvSpPr>
         <p:spPr>
           <a:xfrm>
-            <a:off x="6217920" y="4023360"/>
-            <a:ext cx="5394960" cy="731520"/>
+            <a:off x="6217920" y="3858768"/>
+            <a:ext cx="5394960" cy="676656"/>
           </a:xfrm>
           <a:prstGeom prst="rect">
             <a:avLst/>
@@ -7096,8 +7116,8 @@
         </p:nvSpPr>
         <p:spPr>
           <a:xfrm>
-            <a:off x="6355080" y="4069080"/>
-            <a:ext cx="5120640" cy="640080"/>
+            <a:off x="6355080" y="3904488"/>
+            <a:ext cx="5120640" cy="585216"/>
           </a:xfrm>
           <a:prstGeom prst="rect">
             <a:avLst/>
@@ -7149,8 +7169,8 @@
         </p:nvSpPr>
         <p:spPr>
           <a:xfrm>
-            <a:off x="6217920" y="4754880"/>
-            <a:ext cx="5394960" cy="731520"/>
+            <a:off x="6217920" y="4535424"/>
+            <a:ext cx="5394960" cy="676656"/>
           </a:xfrm>
           <a:prstGeom prst="rect">
             <a:avLst/>
@@ -7174,8 +7194,8 @@
         </p:nvSpPr>
         <p:spPr>
           <a:xfrm>
-            <a:off x="6355080" y="4800600"/>
-            <a:ext cx="5120640" cy="640080"/>
+            <a:off x="6355080" y="4581144"/>
+            <a:ext cx="5120640" cy="585216"/>
           </a:xfrm>
           <a:prstGeom prst="rect">
             <a:avLst/>
@@ -7227,8 +7247,8 @@
         </p:nvSpPr>
         <p:spPr>
           <a:xfrm>
-            <a:off x="548640" y="5577840"/>
-            <a:ext cx="11064240" cy="640080"/>
+            <a:off x="548640" y="5349240"/>
+            <a:ext cx="11064240" cy="868680"/>
           </a:xfrm>
           <a:prstGeom prst="rect">
             <a:avLst/>
@@ -7241,6 +7261,9 @@
           <a:lstStyle/>
           <a:p>
             <a:pPr indent="0" marL="0">
+              <a:spcAft>
+                <a:spcPts val="400"/>
+              </a:spcAft>
               <a:buNone/>
             </a:pPr>
             <a:r>
@@ -7255,6 +7278,9 @@
               <a:t>Matters most for Apple TV+: </a:t>
             </a:r>
             <a:pPr indent="0" marL="0">
+              <a:spcAft>
+                <a:spcPts val="400"/>
+              </a:spcAft>
               <a:buNone/>
             </a:pPr>
             <a:r>
@@ -7267,6 +7293,43 @@
                 <a:cs typeface="Calibri" pitchFamily="34" charset="-120"/>
               </a:rPr>
               <a:t>discovery (benefit), because a small catalogue of original shows only pays off if each is found; and creative originality (limitation), because Apple competes on quality. Personalisation is necessary but not sufficient: its benefits depend on managing these limits.</a:t>
+            </a:r>
+            <a:endParaRPr lang="en-US" sz="1300" dirty="0"/>
+          </a:p>
+          <a:p>
+            <a:pPr indent="0" marL="0">
+              <a:spcAft>
+                <a:spcPts val="400"/>
+              </a:spcAft>
+              <a:buNone/>
+            </a:pPr>
+            <a:r>
+              <a:rPr lang="en-US" sz="1300" b="1" dirty="0">
+                <a:solidFill>
+                  <a:srgbClr val="1E2761"/>
+                </a:solidFill>
+                <a:latin typeface="Calibri" pitchFamily="34" charset="0"/>
+                <a:ea typeface="Calibri" pitchFamily="34" charset="-122"/>
+                <a:cs typeface="Calibri" pitchFamily="34" charset="-120"/>
+              </a:rPr>
+              <a:t>Maturity: </a:t>
+            </a:r>
+            <a:pPr indent="0" marL="0">
+              <a:spcAft>
+                <a:spcPts val="400"/>
+              </a:spcAft>
+              <a:buNone/>
+            </a:pPr>
+            <a:r>
+              <a:rPr lang="en-US" sz="1300" dirty="0">
+                <a:solidFill>
+                  <a:srgbClr val="27314D"/>
+                </a:solidFill>
+                <a:latin typeface="Calibri" pitchFamily="34" charset="0"/>
+                <a:ea typeface="Calibri" pitchFamily="34" charset="-122"/>
+                <a:cs typeface="Calibri" pitchFamily="34" charset="-120"/>
+              </a:rPr>
+              <a:t>Gartner (2024) places personalization engines on the Slope of Enlightenment, so the technology is maturing and the harder task is using it well.</a:t>
             </a:r>
             <a:endParaRPr lang="en-US" sz="1300" dirty="0"/>
           </a:p>

</xml_diff>

<commit_message>
Remove unverified Hype Cycle placement and reference
Co-Authored-By: Claude Sonnet 5.5 <noreply@anthropic.com>
Claude-Session: https://claude.ai/code/session_01Ha62b6Wcst3n47bFqEFLKV
</commit_message>
<xml_diff>
--- a/Earning-the-Signal_revised.pptx
+++ b/Earning-the-Signal_revised.pptx
@@ -1129,7 +1129,7 @@
           <a:p>
             <a:r>
               <a:rPr lang="en-US" dirty="0"/>
-              <a:t>Gracenote (2025): 49% likely to cancel over poor discovery (State of Play 2025, released 5 Nov 2025). Mokoena and Obagbuwa (2025) is a review of AI in music streaming, used here for its privacy, governance and bias risks. Conclusion: personalisation is necessary but not sufficient. Hype Cycle placement per Gartner (2024), Hype Cycle for Digital Marketing; confirm against the report.</a:t>
+              <a:t>Gracenote (2025): 49% likely to cancel over poor discovery (State of Play 2025, released 5 Nov 2025). Mokoena and Obagbuwa (2025) is a review of AI in music streaming, used here for its privacy, governance and bias risks. Conclusion: personalisation is necessary but not sufficient.</a:t>
             </a:r>
             <a:endParaRPr lang="en-US" dirty="0"/>
           </a:p>
@@ -3867,26 +3867,6 @@
                 <a:ea typeface="Calibri" pitchFamily="34" charset="-122"/>
                 <a:cs typeface="Calibri" pitchFamily="34" charset="-120"/>
               </a:rPr>
-              <a:t>Gartner (2024) Hype Cycle for Digital Marketing, 2024. Stamford: Gartner. Available at: https://www.gartner.com/en/documents/5623191 (Accessed: 25 October 2026).</a:t>
-            </a:r>
-            <a:endParaRPr lang="en-US" sz="1200" dirty="0"/>
-          </a:p>
-          <a:p>
-            <a:pPr indent="0" marL="0">
-              <a:spcAft>
-                <a:spcPts val="400"/>
-              </a:spcAft>
-              <a:buNone/>
-            </a:pPr>
-            <a:r>
-              <a:rPr lang="en-US" sz="1200" dirty="0">
-                <a:solidFill>
-                  <a:srgbClr val="27314D"/>
-                </a:solidFill>
-                <a:latin typeface="Calibri" pitchFamily="34" charset="0"/>
-                <a:ea typeface="Calibri" pitchFamily="34" charset="-122"/>
-                <a:cs typeface="Calibri" pitchFamily="34" charset="-120"/>
-              </a:rPr>
               <a:t>Gomez-Uribe, C.A. and Hunt, N. (2015) ‘The Netflix recommender system’, ACM Transactions on Management Information Systems, 6(4), Article 13.</a:t>
             </a:r>
             <a:endParaRPr lang="en-US" sz="1200" dirty="0"/>
@@ -7293,43 +7273,6 @@
                 <a:cs typeface="Calibri" pitchFamily="34" charset="-120"/>
               </a:rPr>
               <a:t>discovery (benefit), because a small catalogue of original shows only pays off if each is found; and creative originality (limitation), because Apple competes on quality. Personalisation is necessary but not sufficient: its benefits depend on managing these limits.</a:t>
-            </a:r>
-            <a:endParaRPr lang="en-US" sz="1300" dirty="0"/>
-          </a:p>
-          <a:p>
-            <a:pPr indent="0" marL="0">
-              <a:spcAft>
-                <a:spcPts val="400"/>
-              </a:spcAft>
-              <a:buNone/>
-            </a:pPr>
-            <a:r>
-              <a:rPr lang="en-US" sz="1300" b="1" dirty="0">
-                <a:solidFill>
-                  <a:srgbClr val="1E2761"/>
-                </a:solidFill>
-                <a:latin typeface="Calibri" pitchFamily="34" charset="0"/>
-                <a:ea typeface="Calibri" pitchFamily="34" charset="-122"/>
-                <a:cs typeface="Calibri" pitchFamily="34" charset="-120"/>
-              </a:rPr>
-              <a:t>Maturity: </a:t>
-            </a:r>
-            <a:pPr indent="0" marL="0">
-              <a:spcAft>
-                <a:spcPts val="400"/>
-              </a:spcAft>
-              <a:buNone/>
-            </a:pPr>
-            <a:r>
-              <a:rPr lang="en-US" sz="1300" dirty="0">
-                <a:solidFill>
-                  <a:srgbClr val="27314D"/>
-                </a:solidFill>
-                <a:latin typeface="Calibri" pitchFamily="34" charset="0"/>
-                <a:ea typeface="Calibri" pitchFamily="34" charset="-122"/>
-                <a:cs typeface="Calibri" pitchFamily="34" charset="-120"/>
-              </a:rPr>
-              <a:t>Gartner (2024) places personalization engines on the Slope of Enlightenment, so the technology is maturing and the harder task is using it well.</a:t>
             </a:r>
             <a:endParaRPr lang="en-US" sz="1300" dirty="0"/>
           </a:p>

</xml_diff>

<commit_message>
Add speaker notes to all slides
Co-Authored-By: Claude Sonnet 5.5 <noreply@anthropic.com>
Claude-Session: https://claude.ai/code/session_01Ha62b6Wcst3n47bFqEFLKV
</commit_message>
<xml_diff>
--- a/Earning-the-Signal_revised.pptx
+++ b/Earning-the-Signal_revised.pptx
@@ -513,7 +513,10 @@
           <a:p>
             <a:r>
               <a:rPr lang="en-US" dirty="0"/>
-              <a:t>Introduce yourself as the Digital Transformation Consultant, state the purpose, then name the three parts.</a:t>
+              <a:t>Introduce yourself as Apple TV+'s Digital Transformation Consultant and give your SRN.
+Purpose: show how a machine-learning recommendation engine could help Apple TV+ use data without limiting creativity.
+Structure: Task 1 is the technology, Task 2 is the impact on creative teams, Task 3 is strategy, ethics and recommendations.
+Aim for about 30 seconds on this slide.</a:t>
             </a:r>
             <a:endParaRPr lang="en-US" dirty="0"/>
           </a:p>
@@ -601,7 +604,11 @@
           <a:p>
             <a:r>
               <a:rPr lang="en-US" dirty="0"/>
-              <a:t>Do first: the creative-team pilot, because it addresses the central challenge and builds the evidence the other two rest on.</a:t>
+              <a:t>Three recommendations, each with action, owner, evidence and the slide it comes from.
+1. Creative-team pilot in Kotter-style steps. Owner: creative leadership with the data team. Evidence: Kotter (1995), Napoli (2014). From slides 6 and 7.
+2. Explanation feature for recommendations. Owner: marketing with product and technology. Evidence: Floridi et al. (2018), Apple Inc. (2025). From slides 4 and 9.
+3. Governance review of purpose limitation and diversity auditing. Owner: operations (legal and compliance). Evidence: GDPR Article 5, Ricci et al. (2015). From slides 5 and 9.
+Do first: the pilot. It tackles the central challenge and builds the evidence the other two depend on.</a:t>
             </a:r>
             <a:endParaRPr lang="en-US" dirty="0"/>
           </a:p>
@@ -689,7 +696,10 @@
           <a:p>
             <a:r>
               <a:rPr lang="en-US" dirty="0"/>
-              <a:t>No new evidence on this slide.</a:t>
+              <a:t>Task 1: a machine-learning recommendation engine helps match a small catalogue to many viewers, but it protects Apple TV+'s position rather than creating a lead.
+Task 2: creative teams are most affected. A Kotter-style change plan can protect originality while they adopt data.
+Task 3: rivals can copy the technology, so advantage depends on ecosystem, creative judgement and ethical safeguards.
+Restate the three recommendations in one line each, then close: used with creative teams at its side, the engine can help Apple TV+ keep subscribers without giving up its originality.</a:t>
             </a:r>
             <a:endParaRPr lang="en-US" dirty="0"/>
           </a:p>
@@ -777,7 +787,7 @@
           <a:p>
             <a:r>
               <a:rPr lang="en-US" dirty="0"/>
-              <a:t>Every in-text citation appears here. Verify the Antenna/ABC News figure against the original before submission.</a:t>
+              <a:t>Reference list in alphabetical Harvard style. Not presented; provided for information.</a:t>
             </a:r>
             <a:endParaRPr lang="en-US" dirty="0"/>
           </a:p>
@@ -865,7 +875,12 @@
           <a:p>
             <a:r>
               <a:rPr lang="en-US" dirty="0"/>
-              <a:t>Apple TV+ is an original-content subscription service that competes on quality rather than library size. Its content is integrated across Apple devices. The challenge: use data to improve recommendations without limiting creativity. Stat: Antenna (2024) serial-churn figure for Apple TV+; industry churn via ABC News. Confirm both against the Antenna report before submission. Reichheld (2003): retention is cheaper than acquisition.</a:t>
+              <a:t>Apple TV+ is an original-content subscription service. It competes on the quality of its programmes, not the size of its library, so every title matters more.
+Its strategy is the Apple ecosystem: content sits across iPhone, iPad and other Apple devices.
+Our challenge, taken from the brief: using data to improve recommendations without limiting creativity.
+Why it matters: retention, competition with Netflix, Prime Video and Disney+, and the tension between creative teams and data-driven teams inside the organisation.
+Stat: Antenna (2024) reports 37.2% of Apple TV+ gross additions were returning subscribers who had cancelled within the prior 12 months, the highest serial-churn rate in the industry. Industry churn across major US services also rose from 5.1% to 6.3% between November 2022 and November 2023.
+Link to cost: Reichheld (2003) shows keeping a customer is cheaper than winning a new one, so churn matters financially.</a:t>
             </a:r>
             <a:endParaRPr lang="en-US" dirty="0"/>
           </a:p>
@@ -953,7 +968,11 @@
           <a:p>
             <a:r>
               <a:rPr lang="en-US" dirty="0"/>
-              <a:t>A recommender system helps people choose among many options by using patterns in other people's behaviour (Resnick and Varian, 1997). Netflix is the best-documented streaming example (Gomez-Uribe and Hunt, 2015). Apple states it collects data “to tailor features and offer personalised recommendations” (Apple Inc., 2025).</a:t>
+              <a:t>Plain-language definition: a machine-learning recommendation engine learns from what viewers do and predicts what each viewer will want next.
+Resnick and Varian (1997) describe recommender systems as helping people choose among many options by using the patterns of other people's choices.
+Walk the diagram left to right. Input: viewing history, searches and behaviour signals such as pauses and rewinds. Process: machine learning finds patterns. Output: a personalised home screen.
+Example: Netflix is the best-documented case. Gomez-Uribe and Hunt (2015) describe personalised rows and titles and estimate the system is worth over $1 billion a year in retained subscribers.
+Apple's own privacy documentation says data is collected to tailor features and offer personalised recommendations (Apple Inc., 2025).</a:t>
             </a:r>
             <a:endParaRPr lang="en-US" dirty="0"/>
           </a:p>
@@ -1041,7 +1060,11 @@
           <a:p>
             <a:r>
               <a:rPr lang="en-US" dirty="0"/>
-              <a:t>Porter's Five Forces (Porter, 2008). The engine helps with the challenge by matching content to viewers at scale. The creativity concern comes from the engine steering which content is promoted.</a:t>
+              <a:t>Matching at scale: Apple TV+ has a small, high-quality catalogue. The engine matches it to millions of different viewers so good originals are found, not buried. This is how the engine helps with the challenge.
+Porter's Five Forces (Porter, 2008): two forces change most.
+Rivalry: better discovery raises the value of each subscription, but Netflix, Prime Video and Disney+ run similar engines, so it protects our position rather than creating a lead.
+Buyer power: switching costs are low. A profile that has learned a viewer's taste adds a small cost to leaving.
+Creativity side: the engine can steer which content is promoted. This is where creative teams' concern comes from, and it leads into Task 2.</a:t>
             </a:r>
             <a:endParaRPr lang="en-US" dirty="0"/>
           </a:p>
@@ -1129,7 +1152,10 @@
           <a:p>
             <a:r>
               <a:rPr lang="en-US" dirty="0"/>
-              <a:t>Gracenote (2025): 49% likely to cancel over poor discovery (State of Play 2025, released 5 Nov 2025). Mokoena and Obagbuwa (2025) is a review of AI in music streaming, used here for its privacy, governance and bias risks. Conclusion: personalisation is necessary but not sufficient.</a:t>
+              <a:t>Benefits, each sourced: discovery (Gracenote, 2025: 49% of viewers say they are likely to cancel if they cannot find something to watch), engagement and retention (Gomez-Uribe and Hunt, 2015; Reichheld, 2003).
+Limitations: narrowing recommendations and data quality (Ricci, Rokach and Shapira, 2015), reduced diversity (Helberger, 2019), possible loss of creative originality (Napoli, 2014), and privacy, governance and bias risks when AI is scaled (Mokoena and Obagbuwa, 2025, a review of AI in music streaming).
+Most important for Apple TV+: discovery on the benefit side, because a small catalogue only pays off if each show is found; creative originality on the limitation side, because Apple competes on quality.
+Conclusion: personalisation is necessary but not sufficient. Its benefits depend on managing these limits.</a:t>
             </a:r>
             <a:endParaRPr lang="en-US" dirty="0"/>
           </a:p>
@@ -1217,7 +1243,12 @@
           <a:p>
             <a:r>
               <a:rPr lang="en-US" dirty="0"/>
-              <a:t>Group: writers, producers and content developers. Concern: heavy reliance on data could affect originality. TAM (Davis, 1989): usefulness and ease of use. Napoli (2014) on algorithms shaping media production.</a:t>
+              <a:t>Chosen stakeholder group: creative teams, meaning writers, producers and content developers.
+Their concern, from the brief: too much reliance on data could affect originality.
+Structure: who decides what gets made. Data should inform commissioning, not replace it.
+Culture: creative autonomy versus data-driven decisions. Teams need to see data as a tool, not a verdict (Napoli, 2014).
+Process: green-lighting and pitches. Add a data check to pitches but keep creative sign-off at the final step.
+TAM (Davis, 1989): would they find it useful and easy to use? Useful if it shows which audiences a pitch could reach; easy only if insights are in plain language and built into the pitch workflow.</a:t>
             </a:r>
             <a:endParaRPr lang="en-US" dirty="0"/>
           </a:p>
@@ -1305,7 +1336,9 @@
           <a:p>
             <a:r>
               <a:rPr lang="en-US" dirty="0"/>
-              <a:t>Change model: Kotter (1995), eight steps condensed to six for Apple TV+. Barriers: fear of losing creative control, distrust of algorithms, skills gaps. Creative champions and feedback channels build digital confidence.</a:t>
+              <a:t>Barriers: fear of losing creative control, distrust of algorithms, and skills gaps. Responses: keep creative sign-off final and publish rules for data use; show why content is promoted so creatives can see how data influences decisions; train people on real projects (Vial, 2019).
+Change model: Kotter (1995), condensed to six steps for Apple TV+. Urgency (churn and rivals), coalition (creative champions plus data leads), vision (data informs, creatives decide), pilot on one slate of originals and share early wins, extend into pitches and green-lighting, embed in how Apple TV+ commissions.
+Digital confidence actions: training, pilots, creative champions and feedback channels into the model team.</a:t>
             </a:r>
             <a:endParaRPr lang="en-US" dirty="0"/>
           </a:p>
@@ -1393,7 +1426,13 @@
           <a:p>
             <a:r>
               <a:rPr lang="en-US" dirty="0"/>
-              <a:t>VRIO from Barney (1991). Honest verdict: valuable but not rare or hard to imitate, so the recommender alone gives parity. Scaling AI brings privacy, governance and bias risks (Mokoena and Obagbuwa, 2025). Ansoff placement: market penetration (Ansoff, 1957).</a:t>
+              <a:t>VRIO (Barney, 1991) applied honestly.
+Valuable: yes. Better discovery supports retention and engagement, but scaling AI brings privacy, governance and bias risks.
+Rare: no. Streaming rivals already run recommenders and the technique is widely documented.
+Hard to imitate: partly. Models are copyable; Apple's ecosystem data and quality-focused catalogue are harder to copy.
+Organised: not yet. Creative and data teams are not aligned and there are no shared rules for how data shapes commissioning.
+Verdict: competitive parity, not sustained advantage. As models converge, accuracy alone differentiates little.
+Continuous improvement: A/B testing, creative input into the goals the model optimises, and regular data and model refresh. Ansoff (1957): this is market penetration, deepening retention in existing markets.</a:t>
             </a:r>
             <a:endParaRPr lang="en-US" dirty="0"/>
           </a:p>
@@ -1481,7 +1520,12 @@
           <a:p>
             <a:r>
               <a:rPr lang="en-US" dirty="0"/>
-              <a:t>Privacy: GDPR Article 5 purpose limitation (European Parliament and Council, 2016). Bias: Ricci et al. (2015). Principles from Floridi et al. (2018). The earlier App Tracking Transparency claim was dropped because it was unsourced.</a:t>
+              <a:t>Five issues, each with a principle and mitigation.
+Privacy: data collected for recommendations could be reused for other purposes. GDPR Article 5 requires specified, explicit purposes (European Parliament and Council, 2016). Mitigation: document and review purpose limitation.
+Bias and fairness: models trained on past viewing narrow what is shown (Ricci et al., 2015). Mitigation: regular diversity audits.
+Transparency: viewers and creatives cannot see why content is promoted. Mitigation: 'why am I seeing this' explanations.
+Creators' autonomy: algorithms can steer which projects are promoted and made (Napoli, 2014). Mitigation: creative sign-off.
+Social: filter bubbles and cultural diversity (Pariser, 2011; Helberger, 2019). Principles draw on Floridi et al. (2018).</a:t>
             </a:r>
             <a:endParaRPr lang="en-US" dirty="0"/>
           </a:p>
@@ -2204,7 +2248,7 @@
       </p:sp>
       <p:sp>
         <p:nvSpPr>
-          <p:cNvPr id="5" name="Shape 2"/>
+          <p:cNvPr id="4" name="Shape 2"/>
           <p:cNvSpPr/>
           <p:nvPr/>
         </p:nvSpPr>
@@ -2231,7 +2275,7 @@
       </p:sp>
       <p:sp>
         <p:nvSpPr>
-          <p:cNvPr id="6" name="Shape 3"/>
+          <p:cNvPr id="5" name="Shape 3"/>
           <p:cNvSpPr/>
           <p:nvPr/>
         </p:nvSpPr>
@@ -2256,7 +2300,7 @@
       </p:sp>
       <p:sp>
         <p:nvSpPr>
-          <p:cNvPr id="7" name="Text 4"/>
+          <p:cNvPr id="6" name="Text 4"/>
           <p:cNvSpPr txBox="1"/>
           <p:nvPr/>
         </p:nvSpPr>
@@ -2295,7 +2339,7 @@
       </p:sp>
       <p:sp>
         <p:nvSpPr>
-          <p:cNvPr id="8" name="Text 5"/>
+          <p:cNvPr id="7" name="Text 5"/>
           <p:cNvSpPr txBox="1"/>
           <p:nvPr/>
         </p:nvSpPr>
@@ -2334,7 +2378,7 @@
       </p:sp>
       <p:sp>
         <p:nvSpPr>
-          <p:cNvPr id="9" name="Text 6"/>
+          <p:cNvPr id="8" name="Text 6"/>
           <p:cNvSpPr txBox="1"/>
           <p:nvPr/>
         </p:nvSpPr>
@@ -2467,7 +2511,7 @@
       </p:sp>
       <p:sp>
         <p:nvSpPr>
-          <p:cNvPr id="10" name="Shape 7"/>
+          <p:cNvPr id="9" name="Shape 7"/>
           <p:cNvSpPr/>
           <p:nvPr/>
         </p:nvSpPr>
@@ -2494,7 +2538,7 @@
       </p:sp>
       <p:sp>
         <p:nvSpPr>
-          <p:cNvPr id="11" name="Shape 8"/>
+          <p:cNvPr id="10" name="Shape 8"/>
           <p:cNvSpPr/>
           <p:nvPr/>
         </p:nvSpPr>
@@ -2519,7 +2563,7 @@
       </p:sp>
       <p:sp>
         <p:nvSpPr>
-          <p:cNvPr id="12" name="Text 9"/>
+          <p:cNvPr id="11" name="Text 9"/>
           <p:cNvSpPr txBox="1"/>
           <p:nvPr/>
         </p:nvSpPr>
@@ -2558,7 +2602,7 @@
       </p:sp>
       <p:sp>
         <p:nvSpPr>
-          <p:cNvPr id="13" name="Text 10"/>
+          <p:cNvPr id="12" name="Text 10"/>
           <p:cNvSpPr txBox="1"/>
           <p:nvPr/>
         </p:nvSpPr>
@@ -2597,7 +2641,7 @@
       </p:sp>
       <p:sp>
         <p:nvSpPr>
-          <p:cNvPr id="14" name="Text 11"/>
+          <p:cNvPr id="13" name="Text 11"/>
           <p:cNvSpPr txBox="1"/>
           <p:nvPr/>
         </p:nvSpPr>
@@ -2730,7 +2774,7 @@
       </p:sp>
       <p:sp>
         <p:nvSpPr>
-          <p:cNvPr id="15" name="Shape 12"/>
+          <p:cNvPr id="14" name="Shape 12"/>
           <p:cNvSpPr/>
           <p:nvPr/>
         </p:nvSpPr>
@@ -2757,7 +2801,7 @@
       </p:sp>
       <p:sp>
         <p:nvSpPr>
-          <p:cNvPr id="16" name="Shape 13"/>
+          <p:cNvPr id="15" name="Shape 13"/>
           <p:cNvSpPr/>
           <p:nvPr/>
         </p:nvSpPr>
@@ -2782,7 +2826,7 @@
       </p:sp>
       <p:sp>
         <p:nvSpPr>
-          <p:cNvPr id="17" name="Text 14"/>
+          <p:cNvPr id="16" name="Text 14"/>
           <p:cNvSpPr txBox="1"/>
           <p:nvPr/>
         </p:nvSpPr>
@@ -2821,7 +2865,7 @@
       </p:sp>
       <p:sp>
         <p:nvSpPr>
-          <p:cNvPr id="18" name="Text 15"/>
+          <p:cNvPr id="17" name="Text 15"/>
           <p:cNvSpPr txBox="1"/>
           <p:nvPr/>
         </p:nvSpPr>
@@ -2860,7 +2904,7 @@
       </p:sp>
       <p:sp>
         <p:nvSpPr>
-          <p:cNvPr id="19" name="Text 16"/>
+          <p:cNvPr id="18" name="Text 16"/>
           <p:cNvSpPr txBox="1"/>
           <p:nvPr/>
         </p:nvSpPr>
@@ -2993,7 +3037,7 @@
       </p:sp>
       <p:sp>
         <p:nvSpPr>
-          <p:cNvPr id="20" name="Text 17"/>
+          <p:cNvPr id="19" name="Text 17"/>
           <p:cNvSpPr txBox="1"/>
           <p:nvPr/>
         </p:nvSpPr>
@@ -3156,7 +3200,7 @@
       </p:sp>
       <p:sp>
         <p:nvSpPr>
-          <p:cNvPr id="5" name="Text 2"/>
+          <p:cNvPr id="4" name="Text 2"/>
           <p:cNvSpPr txBox="1"/>
           <p:nvPr/>
         </p:nvSpPr>
@@ -3195,7 +3239,7 @@
       </p:sp>
       <p:sp>
         <p:nvSpPr>
-          <p:cNvPr id="6" name="Text 3"/>
+          <p:cNvPr id="5" name="Text 3"/>
           <p:cNvSpPr txBox="1"/>
           <p:nvPr/>
         </p:nvSpPr>
@@ -3234,7 +3278,7 @@
       </p:sp>
       <p:sp>
         <p:nvSpPr>
-          <p:cNvPr id="7" name="Text 4"/>
+          <p:cNvPr id="6" name="Text 4"/>
           <p:cNvSpPr txBox="1"/>
           <p:nvPr/>
         </p:nvSpPr>
@@ -3273,7 +3317,7 @@
       </p:sp>
       <p:sp>
         <p:nvSpPr>
-          <p:cNvPr id="8" name="Text 5"/>
+          <p:cNvPr id="7" name="Text 5"/>
           <p:cNvSpPr txBox="1"/>
           <p:nvPr/>
         </p:nvSpPr>
@@ -3312,7 +3356,7 @@
       </p:sp>
       <p:sp>
         <p:nvSpPr>
-          <p:cNvPr id="9" name="Text 6"/>
+          <p:cNvPr id="8" name="Text 6"/>
           <p:cNvSpPr txBox="1"/>
           <p:nvPr/>
         </p:nvSpPr>
@@ -3351,7 +3395,7 @@
       </p:sp>
       <p:sp>
         <p:nvSpPr>
-          <p:cNvPr id="10" name="Text 7"/>
+          <p:cNvPr id="9" name="Text 7"/>
           <p:cNvSpPr txBox="1"/>
           <p:nvPr/>
         </p:nvSpPr>
@@ -3390,7 +3434,7 @@
       </p:sp>
       <p:sp>
         <p:nvSpPr>
-          <p:cNvPr id="11" name="Text 8"/>
+          <p:cNvPr id="10" name="Text 8"/>
           <p:cNvSpPr txBox="1"/>
           <p:nvPr/>
         </p:nvSpPr>
@@ -3429,7 +3473,7 @@
       </p:sp>
       <p:sp>
         <p:nvSpPr>
-          <p:cNvPr id="12" name="Text 9"/>
+          <p:cNvPr id="11" name="Text 9"/>
           <p:cNvSpPr txBox="1"/>
           <p:nvPr/>
         </p:nvSpPr>
@@ -3517,7 +3561,7 @@
       </p:sp>
       <p:sp>
         <p:nvSpPr>
-          <p:cNvPr id="13" name="Shape 10"/>
+          <p:cNvPr id="12" name="Shape 10"/>
           <p:cNvSpPr/>
           <p:nvPr/>
         </p:nvSpPr>
@@ -3544,7 +3588,7 @@
       </p:sp>
       <p:sp>
         <p:nvSpPr>
-          <p:cNvPr id="14" name="Text 11"/>
+          <p:cNvPr id="13" name="Text 11"/>
           <p:cNvSpPr txBox="1"/>
           <p:nvPr/>
         </p:nvSpPr>
@@ -3693,7 +3737,7 @@
       </p:sp>
       <p:sp>
         <p:nvSpPr>
-          <p:cNvPr id="5" name="Text 2"/>
+          <p:cNvPr id="4" name="Text 2"/>
           <p:cNvSpPr txBox="1"/>
           <p:nvPr/>
         </p:nvSpPr>
@@ -4205,7 +4249,7 @@
       </p:sp>
       <p:sp>
         <p:nvSpPr>
-          <p:cNvPr id="5" name="Text 2"/>
+          <p:cNvPr id="4" name="Text 2"/>
           <p:cNvSpPr txBox="1"/>
           <p:nvPr/>
         </p:nvSpPr>
@@ -4244,7 +4288,7 @@
       </p:sp>
       <p:sp>
         <p:nvSpPr>
-          <p:cNvPr id="6" name="Text 3"/>
+          <p:cNvPr id="5" name="Text 3"/>
           <p:cNvSpPr txBox="1"/>
           <p:nvPr/>
         </p:nvSpPr>
@@ -4283,7 +4327,7 @@
       </p:sp>
       <p:sp>
         <p:nvSpPr>
-          <p:cNvPr id="7" name="Text 4"/>
+          <p:cNvPr id="6" name="Text 4"/>
           <p:cNvSpPr txBox="1"/>
           <p:nvPr/>
         </p:nvSpPr>
@@ -4322,7 +4366,7 @@
       </p:sp>
       <p:sp>
         <p:nvSpPr>
-          <p:cNvPr id="8" name="Text 5"/>
+          <p:cNvPr id="7" name="Text 5"/>
           <p:cNvSpPr txBox="1"/>
           <p:nvPr/>
         </p:nvSpPr>
@@ -4361,7 +4405,7 @@
       </p:sp>
       <p:sp>
         <p:nvSpPr>
-          <p:cNvPr id="9" name="Text 6"/>
+          <p:cNvPr id="8" name="Text 6"/>
           <p:cNvSpPr txBox="1"/>
           <p:nvPr/>
         </p:nvSpPr>
@@ -4400,7 +4444,7 @@
       </p:sp>
       <p:sp>
         <p:nvSpPr>
-          <p:cNvPr id="10" name="Text 7"/>
+          <p:cNvPr id="9" name="Text 7"/>
           <p:cNvSpPr txBox="1"/>
           <p:nvPr/>
         </p:nvSpPr>
@@ -4439,7 +4483,7 @@
       </p:sp>
       <p:sp>
         <p:nvSpPr>
-          <p:cNvPr id="11" name="Text 8"/>
+          <p:cNvPr id="10" name="Text 8"/>
           <p:cNvSpPr txBox="1"/>
           <p:nvPr/>
         </p:nvSpPr>
@@ -4478,7 +4522,7 @@
       </p:sp>
       <p:sp>
         <p:nvSpPr>
-          <p:cNvPr id="12" name="Text 9"/>
+          <p:cNvPr id="11" name="Text 9"/>
           <p:cNvSpPr txBox="1"/>
           <p:nvPr/>
         </p:nvSpPr>
@@ -4517,7 +4561,7 @@
       </p:sp>
       <p:sp>
         <p:nvSpPr>
-          <p:cNvPr id="13" name="Shape 10"/>
+          <p:cNvPr id="12" name="Shape 10"/>
           <p:cNvSpPr/>
           <p:nvPr/>
         </p:nvSpPr>
@@ -4544,7 +4588,7 @@
       </p:sp>
       <p:sp>
         <p:nvSpPr>
-          <p:cNvPr id="14" name="Text 11"/>
+          <p:cNvPr id="13" name="Text 11"/>
           <p:cNvSpPr txBox="1"/>
           <p:nvPr/>
         </p:nvSpPr>
@@ -4583,7 +4627,7 @@
       </p:sp>
       <p:sp>
         <p:nvSpPr>
-          <p:cNvPr id="15" name="Text 12"/>
+          <p:cNvPr id="14" name="Text 12"/>
           <p:cNvSpPr txBox="1"/>
           <p:nvPr/>
         </p:nvSpPr>
@@ -4622,7 +4666,7 @@
       </p:sp>
       <p:sp>
         <p:nvSpPr>
-          <p:cNvPr id="16" name="Text 13"/>
+          <p:cNvPr id="15" name="Text 13"/>
           <p:cNvSpPr txBox="1"/>
           <p:nvPr/>
         </p:nvSpPr>
@@ -4661,7 +4705,7 @@
       </p:sp>
       <p:sp>
         <p:nvSpPr>
-          <p:cNvPr id="17" name="Text 14"/>
+          <p:cNvPr id="16" name="Text 14"/>
           <p:cNvSpPr txBox="1"/>
           <p:nvPr/>
         </p:nvSpPr>
@@ -4810,7 +4854,7 @@
       </p:sp>
       <p:sp>
         <p:nvSpPr>
-          <p:cNvPr id="5" name="Text 2"/>
+          <p:cNvPr id="4" name="Text 2"/>
           <p:cNvSpPr txBox="1"/>
           <p:nvPr/>
         </p:nvSpPr>
@@ -4849,7 +4893,7 @@
       </p:sp>
       <p:sp>
         <p:nvSpPr>
-          <p:cNvPr id="6" name="Shape 3"/>
+          <p:cNvPr id="5" name="Shape 3"/>
           <p:cNvSpPr/>
           <p:nvPr/>
         </p:nvSpPr>
@@ -4876,7 +4920,7 @@
       </p:sp>
       <p:sp>
         <p:nvSpPr>
-          <p:cNvPr id="7" name="Text 4"/>
+          <p:cNvPr id="6" name="Text 4"/>
           <p:cNvSpPr txBox="1"/>
           <p:nvPr/>
         </p:nvSpPr>
@@ -4915,7 +4959,7 @@
       </p:sp>
       <p:sp>
         <p:nvSpPr>
-          <p:cNvPr id="8" name="Text 5"/>
+          <p:cNvPr id="7" name="Text 5"/>
           <p:cNvSpPr txBox="1"/>
           <p:nvPr/>
         </p:nvSpPr>
@@ -4954,7 +4998,7 @@
       </p:sp>
       <p:sp>
         <p:nvSpPr>
-          <p:cNvPr id="9" name="Shape 6"/>
+          <p:cNvPr id="8" name="Shape 6"/>
           <p:cNvSpPr/>
           <p:nvPr/>
         </p:nvSpPr>
@@ -4979,7 +5023,7 @@
       </p:sp>
       <p:sp>
         <p:nvSpPr>
-          <p:cNvPr id="10" name="Shape 7"/>
+          <p:cNvPr id="9" name="Shape 7"/>
           <p:cNvSpPr/>
           <p:nvPr/>
         </p:nvSpPr>
@@ -5006,7 +5050,7 @@
       </p:sp>
       <p:sp>
         <p:nvSpPr>
-          <p:cNvPr id="11" name="Text 8"/>
+          <p:cNvPr id="10" name="Text 8"/>
           <p:cNvSpPr txBox="1"/>
           <p:nvPr/>
         </p:nvSpPr>
@@ -5045,7 +5089,7 @@
       </p:sp>
       <p:sp>
         <p:nvSpPr>
-          <p:cNvPr id="12" name="Text 9"/>
+          <p:cNvPr id="11" name="Text 9"/>
           <p:cNvSpPr txBox="1"/>
           <p:nvPr/>
         </p:nvSpPr>
@@ -5084,7 +5128,7 @@
       </p:sp>
       <p:sp>
         <p:nvSpPr>
-          <p:cNvPr id="13" name="Shape 10"/>
+          <p:cNvPr id="12" name="Shape 10"/>
           <p:cNvSpPr/>
           <p:nvPr/>
         </p:nvSpPr>
@@ -5109,7 +5153,7 @@
       </p:sp>
       <p:sp>
         <p:nvSpPr>
-          <p:cNvPr id="14" name="Shape 11"/>
+          <p:cNvPr id="13" name="Shape 11"/>
           <p:cNvSpPr/>
           <p:nvPr/>
         </p:nvSpPr>
@@ -5136,7 +5180,7 @@
       </p:sp>
       <p:sp>
         <p:nvSpPr>
-          <p:cNvPr id="15" name="Text 12"/>
+          <p:cNvPr id="14" name="Text 12"/>
           <p:cNvSpPr txBox="1"/>
           <p:nvPr/>
         </p:nvSpPr>
@@ -5175,7 +5219,7 @@
       </p:sp>
       <p:sp>
         <p:nvSpPr>
-          <p:cNvPr id="16" name="Text 13"/>
+          <p:cNvPr id="15" name="Text 13"/>
           <p:cNvSpPr txBox="1"/>
           <p:nvPr/>
         </p:nvSpPr>
@@ -5214,7 +5258,7 @@
       </p:sp>
       <p:sp>
         <p:nvSpPr>
-          <p:cNvPr id="17" name="Text 14"/>
+          <p:cNvPr id="16" name="Text 14"/>
           <p:cNvSpPr txBox="1"/>
           <p:nvPr/>
         </p:nvSpPr>
@@ -5253,7 +5297,7 @@
       </p:sp>
       <p:sp>
         <p:nvSpPr>
-          <p:cNvPr id="18" name="Text 15"/>
+          <p:cNvPr id="17" name="Text 15"/>
           <p:cNvSpPr txBox="1"/>
           <p:nvPr/>
         </p:nvSpPr>
@@ -5459,7 +5503,7 @@
       </p:sp>
       <p:sp>
         <p:nvSpPr>
-          <p:cNvPr id="5" name="Text 2"/>
+          <p:cNvPr id="4" name="Text 2"/>
           <p:cNvSpPr txBox="1"/>
           <p:nvPr/>
         </p:nvSpPr>
@@ -5668,7 +5712,7 @@
       </p:sp>
       <p:sp>
         <p:nvSpPr>
-          <p:cNvPr id="6" name="Shape 3"/>
+          <p:cNvPr id="5" name="Shape 3"/>
           <p:cNvSpPr/>
           <p:nvPr/>
         </p:nvSpPr>
@@ -5693,7 +5737,7 @@
       </p:sp>
       <p:sp>
         <p:nvSpPr>
-          <p:cNvPr id="7" name="Text 4"/>
+          <p:cNvPr id="6" name="Text 4"/>
           <p:cNvSpPr txBox="1"/>
           <p:nvPr/>
         </p:nvSpPr>
@@ -5732,7 +5776,7 @@
       </p:sp>
       <p:sp>
         <p:nvSpPr>
-          <p:cNvPr id="8" name="Shape 5"/>
+          <p:cNvPr id="7" name="Shape 5"/>
           <p:cNvSpPr/>
           <p:nvPr/>
         </p:nvSpPr>
@@ -5757,7 +5801,7 @@
       </p:sp>
       <p:sp>
         <p:nvSpPr>
-          <p:cNvPr id="9" name="Text 6"/>
+          <p:cNvPr id="8" name="Text 6"/>
           <p:cNvSpPr txBox="1"/>
           <p:nvPr/>
         </p:nvSpPr>
@@ -5796,7 +5840,7 @@
       </p:sp>
       <p:sp>
         <p:nvSpPr>
-          <p:cNvPr id="10" name="Shape 7"/>
+          <p:cNvPr id="9" name="Shape 7"/>
           <p:cNvSpPr/>
           <p:nvPr/>
         </p:nvSpPr>
@@ -5821,7 +5865,7 @@
       </p:sp>
       <p:sp>
         <p:nvSpPr>
-          <p:cNvPr id="11" name="Text 8"/>
+          <p:cNvPr id="10" name="Text 8"/>
           <p:cNvSpPr txBox="1"/>
           <p:nvPr/>
         </p:nvSpPr>
@@ -5860,7 +5904,7 @@
       </p:sp>
       <p:sp>
         <p:nvSpPr>
-          <p:cNvPr id="12" name="Shape 9"/>
+          <p:cNvPr id="11" name="Shape 9"/>
           <p:cNvSpPr/>
           <p:nvPr/>
         </p:nvSpPr>
@@ -5885,7 +5929,7 @@
       </p:sp>
       <p:sp>
         <p:nvSpPr>
-          <p:cNvPr id="13" name="Text 10"/>
+          <p:cNvPr id="12" name="Text 10"/>
           <p:cNvSpPr txBox="1"/>
           <p:nvPr/>
         </p:nvSpPr>
@@ -5924,7 +5968,7 @@
       </p:sp>
       <p:sp>
         <p:nvSpPr>
-          <p:cNvPr id="14" name="Shape 11"/>
+          <p:cNvPr id="13" name="Shape 11"/>
           <p:cNvSpPr/>
           <p:nvPr/>
         </p:nvSpPr>
@@ -5951,7 +5995,7 @@
       </p:sp>
       <p:sp>
         <p:nvSpPr>
-          <p:cNvPr id="15" name="Text 12"/>
+          <p:cNvPr id="14" name="Text 12"/>
           <p:cNvSpPr txBox="1"/>
           <p:nvPr/>
         </p:nvSpPr>
@@ -5990,7 +6034,7 @@
       </p:sp>
       <p:sp>
         <p:nvSpPr>
-          <p:cNvPr id="16" name="Shape 13"/>
+          <p:cNvPr id="15" name="Shape 13"/>
           <p:cNvSpPr/>
           <p:nvPr/>
         </p:nvSpPr>
@@ -6017,7 +6061,7 @@
       </p:sp>
       <p:sp>
         <p:nvSpPr>
-          <p:cNvPr id="17" name="Text 14"/>
+          <p:cNvPr id="16" name="Text 14"/>
           <p:cNvSpPr txBox="1"/>
           <p:nvPr/>
         </p:nvSpPr>
@@ -6056,7 +6100,7 @@
       </p:sp>
       <p:sp>
         <p:nvSpPr>
-          <p:cNvPr id="18" name="Shape 15"/>
+          <p:cNvPr id="17" name="Shape 15"/>
           <p:cNvSpPr/>
           <p:nvPr/>
         </p:nvSpPr>
@@ -6083,7 +6127,7 @@
       </p:sp>
       <p:sp>
         <p:nvSpPr>
-          <p:cNvPr id="19" name="Text 16"/>
+          <p:cNvPr id="18" name="Text 16"/>
           <p:cNvSpPr txBox="1"/>
           <p:nvPr/>
         </p:nvSpPr>
@@ -6122,7 +6166,7 @@
       </p:sp>
       <p:sp>
         <p:nvSpPr>
-          <p:cNvPr id="20" name="Shape 17"/>
+          <p:cNvPr id="19" name="Shape 17"/>
           <p:cNvSpPr/>
           <p:nvPr/>
         </p:nvSpPr>
@@ -6149,7 +6193,7 @@
       </p:sp>
       <p:sp>
         <p:nvSpPr>
-          <p:cNvPr id="21" name="Text 18"/>
+          <p:cNvPr id="20" name="Text 18"/>
           <p:cNvSpPr txBox="1"/>
           <p:nvPr/>
         </p:nvSpPr>
@@ -6188,7 +6232,7 @@
       </p:sp>
       <p:sp>
         <p:nvSpPr>
-          <p:cNvPr id="22" name="Shape 19"/>
+          <p:cNvPr id="21" name="Shape 19"/>
           <p:cNvSpPr/>
           <p:nvPr/>
         </p:nvSpPr>
@@ -6215,7 +6259,7 @@
       </p:sp>
       <p:sp>
         <p:nvSpPr>
-          <p:cNvPr id="23" name="Text 20"/>
+          <p:cNvPr id="22" name="Text 20"/>
           <p:cNvSpPr txBox="1"/>
           <p:nvPr/>
         </p:nvSpPr>
@@ -6254,7 +6298,7 @@
       </p:sp>
       <p:sp>
         <p:nvSpPr>
-          <p:cNvPr id="24" name="Shape 21"/>
+          <p:cNvPr id="23" name="Shape 21"/>
           <p:cNvSpPr/>
           <p:nvPr/>
         </p:nvSpPr>
@@ -6281,7 +6325,7 @@
       </p:sp>
       <p:sp>
         <p:nvSpPr>
-          <p:cNvPr id="25" name="Text 22"/>
+          <p:cNvPr id="24" name="Text 22"/>
           <p:cNvSpPr txBox="1"/>
           <p:nvPr/>
         </p:nvSpPr>
@@ -6320,7 +6364,7 @@
       </p:sp>
       <p:sp>
         <p:nvSpPr>
-          <p:cNvPr id="26" name="Text 23"/>
+          <p:cNvPr id="25" name="Text 23"/>
           <p:cNvSpPr txBox="1"/>
           <p:nvPr/>
         </p:nvSpPr>
@@ -6469,7 +6513,7 @@
       </p:sp>
       <p:sp>
         <p:nvSpPr>
-          <p:cNvPr id="5" name="Shape 2"/>
+          <p:cNvPr id="4" name="Shape 2"/>
           <p:cNvSpPr/>
           <p:nvPr/>
         </p:nvSpPr>
@@ -6494,7 +6538,7 @@
       </p:sp>
       <p:sp>
         <p:nvSpPr>
-          <p:cNvPr id="6" name="Text 3"/>
+          <p:cNvPr id="5" name="Text 3"/>
           <p:cNvSpPr txBox="1"/>
           <p:nvPr/>
         </p:nvSpPr>
@@ -6533,7 +6577,7 @@
       </p:sp>
       <p:sp>
         <p:nvSpPr>
-          <p:cNvPr id="7" name="Shape 4"/>
+          <p:cNvPr id="6" name="Shape 4"/>
           <p:cNvSpPr/>
           <p:nvPr/>
         </p:nvSpPr>
@@ -6558,7 +6602,7 @@
       </p:sp>
       <p:sp>
         <p:nvSpPr>
-          <p:cNvPr id="8" name="Text 5"/>
+          <p:cNvPr id="7" name="Text 5"/>
           <p:cNvSpPr txBox="1"/>
           <p:nvPr/>
         </p:nvSpPr>
@@ -6611,7 +6655,7 @@
       </p:sp>
       <p:sp>
         <p:nvSpPr>
-          <p:cNvPr id="9" name="Shape 6"/>
+          <p:cNvPr id="8" name="Shape 6"/>
           <p:cNvSpPr/>
           <p:nvPr/>
         </p:nvSpPr>
@@ -6636,7 +6680,7 @@
       </p:sp>
       <p:sp>
         <p:nvSpPr>
-          <p:cNvPr id="10" name="Text 7"/>
+          <p:cNvPr id="9" name="Text 7"/>
           <p:cNvSpPr txBox="1"/>
           <p:nvPr/>
         </p:nvSpPr>
@@ -6689,7 +6733,7 @@
       </p:sp>
       <p:sp>
         <p:nvSpPr>
-          <p:cNvPr id="11" name="Shape 8"/>
+          <p:cNvPr id="10" name="Shape 8"/>
           <p:cNvSpPr/>
           <p:nvPr/>
         </p:nvSpPr>
@@ -6714,7 +6758,7 @@
       </p:sp>
       <p:sp>
         <p:nvSpPr>
-          <p:cNvPr id="12" name="Text 9"/>
+          <p:cNvPr id="11" name="Text 9"/>
           <p:cNvSpPr txBox="1"/>
           <p:nvPr/>
         </p:nvSpPr>
@@ -6767,7 +6811,7 @@
       </p:sp>
       <p:sp>
         <p:nvSpPr>
-          <p:cNvPr id="13" name="Shape 10"/>
+          <p:cNvPr id="12" name="Shape 10"/>
           <p:cNvSpPr/>
           <p:nvPr/>
         </p:nvSpPr>
@@ -6792,7 +6836,7 @@
       </p:sp>
       <p:sp>
         <p:nvSpPr>
-          <p:cNvPr id="14" name="Text 11"/>
+          <p:cNvPr id="13" name="Text 11"/>
           <p:cNvSpPr txBox="1"/>
           <p:nvPr/>
         </p:nvSpPr>
@@ -6831,7 +6875,7 @@
       </p:sp>
       <p:sp>
         <p:nvSpPr>
-          <p:cNvPr id="15" name="Shape 12"/>
+          <p:cNvPr id="14" name="Shape 12"/>
           <p:cNvSpPr/>
           <p:nvPr/>
         </p:nvSpPr>
@@ -6856,7 +6900,7 @@
       </p:sp>
       <p:sp>
         <p:nvSpPr>
-          <p:cNvPr id="16" name="Text 13"/>
+          <p:cNvPr id="15" name="Text 13"/>
           <p:cNvSpPr txBox="1"/>
           <p:nvPr/>
         </p:nvSpPr>
@@ -6909,7 +6953,7 @@
       </p:sp>
       <p:sp>
         <p:nvSpPr>
-          <p:cNvPr id="17" name="Shape 14"/>
+          <p:cNvPr id="16" name="Shape 14"/>
           <p:cNvSpPr/>
           <p:nvPr/>
         </p:nvSpPr>
@@ -6934,7 +6978,7 @@
       </p:sp>
       <p:sp>
         <p:nvSpPr>
-          <p:cNvPr id="18" name="Text 15"/>
+          <p:cNvPr id="17" name="Text 15"/>
           <p:cNvSpPr txBox="1"/>
           <p:nvPr/>
         </p:nvSpPr>
@@ -6987,7 +7031,7 @@
       </p:sp>
       <p:sp>
         <p:nvSpPr>
-          <p:cNvPr id="19" name="Shape 16"/>
+          <p:cNvPr id="18" name="Shape 16"/>
           <p:cNvSpPr/>
           <p:nvPr/>
         </p:nvSpPr>
@@ -7012,7 +7056,7 @@
       </p:sp>
       <p:sp>
         <p:nvSpPr>
-          <p:cNvPr id="20" name="Text 17"/>
+          <p:cNvPr id="19" name="Text 17"/>
           <p:cNvSpPr txBox="1"/>
           <p:nvPr/>
         </p:nvSpPr>
@@ -7065,7 +7109,7 @@
       </p:sp>
       <p:sp>
         <p:nvSpPr>
-          <p:cNvPr id="21" name="Shape 18"/>
+          <p:cNvPr id="20" name="Shape 18"/>
           <p:cNvSpPr/>
           <p:nvPr/>
         </p:nvSpPr>
@@ -7090,7 +7134,7 @@
       </p:sp>
       <p:sp>
         <p:nvSpPr>
-          <p:cNvPr id="22" name="Text 19"/>
+          <p:cNvPr id="21" name="Text 19"/>
           <p:cNvSpPr txBox="1"/>
           <p:nvPr/>
         </p:nvSpPr>
@@ -7143,7 +7187,7 @@
       </p:sp>
       <p:sp>
         <p:nvSpPr>
-          <p:cNvPr id="23" name="Shape 20"/>
+          <p:cNvPr id="22" name="Shape 20"/>
           <p:cNvSpPr/>
           <p:nvPr/>
         </p:nvSpPr>
@@ -7168,7 +7212,7 @@
       </p:sp>
       <p:sp>
         <p:nvSpPr>
-          <p:cNvPr id="24" name="Text 21"/>
+          <p:cNvPr id="23" name="Text 21"/>
           <p:cNvSpPr txBox="1"/>
           <p:nvPr/>
         </p:nvSpPr>
@@ -7221,7 +7265,7 @@
       </p:sp>
       <p:sp>
         <p:nvSpPr>
-          <p:cNvPr id="25" name="Text 22"/>
+          <p:cNvPr id="24" name="Text 22"/>
           <p:cNvSpPr txBox="1"/>
           <p:nvPr/>
         </p:nvSpPr>
@@ -7280,7 +7324,7 @@
       </p:sp>
       <p:sp>
         <p:nvSpPr>
-          <p:cNvPr id="26" name="Text 23"/>
+          <p:cNvPr id="25" name="Text 23"/>
           <p:cNvSpPr txBox="1"/>
           <p:nvPr/>
         </p:nvSpPr>
@@ -7429,7 +7473,7 @@
       </p:sp>
       <p:sp>
         <p:nvSpPr>
-          <p:cNvPr id="5" name="Text 2"/>
+          <p:cNvPr id="4" name="Text 2"/>
           <p:cNvSpPr txBox="1"/>
           <p:nvPr/>
         </p:nvSpPr>
@@ -7468,7 +7512,7 @@
       </p:sp>
       <p:sp>
         <p:nvSpPr>
-          <p:cNvPr id="6" name="Shape 3"/>
+          <p:cNvPr id="5" name="Shape 3"/>
           <p:cNvSpPr/>
           <p:nvPr/>
         </p:nvSpPr>
@@ -7495,7 +7539,7 @@
       </p:sp>
       <p:sp>
         <p:nvSpPr>
-          <p:cNvPr id="7" name="Text 4"/>
+          <p:cNvPr id="6" name="Text 4"/>
           <p:cNvSpPr txBox="1"/>
           <p:nvPr/>
         </p:nvSpPr>
@@ -7534,7 +7578,7 @@
       </p:sp>
       <p:sp>
         <p:nvSpPr>
-          <p:cNvPr id="8" name="Text 5"/>
+          <p:cNvPr id="7" name="Text 5"/>
           <p:cNvSpPr txBox="1"/>
           <p:nvPr/>
         </p:nvSpPr>
@@ -7607,7 +7651,7 @@
       </p:sp>
       <p:sp>
         <p:nvSpPr>
-          <p:cNvPr id="9" name="Shape 6"/>
+          <p:cNvPr id="8" name="Shape 6"/>
           <p:cNvSpPr/>
           <p:nvPr/>
         </p:nvSpPr>
@@ -7634,7 +7678,7 @@
       </p:sp>
       <p:sp>
         <p:nvSpPr>
-          <p:cNvPr id="10" name="Text 7"/>
+          <p:cNvPr id="9" name="Text 7"/>
           <p:cNvSpPr txBox="1"/>
           <p:nvPr/>
         </p:nvSpPr>
@@ -7673,7 +7717,7 @@
       </p:sp>
       <p:sp>
         <p:nvSpPr>
-          <p:cNvPr id="11" name="Text 8"/>
+          <p:cNvPr id="10" name="Text 8"/>
           <p:cNvSpPr txBox="1"/>
           <p:nvPr/>
         </p:nvSpPr>
@@ -7712,7 +7756,7 @@
       </p:sp>
       <p:sp>
         <p:nvSpPr>
-          <p:cNvPr id="12" name="Shape 9"/>
+          <p:cNvPr id="11" name="Shape 9"/>
           <p:cNvSpPr/>
           <p:nvPr/>
         </p:nvSpPr>
@@ -7739,7 +7783,7 @@
       </p:sp>
       <p:sp>
         <p:nvSpPr>
-          <p:cNvPr id="13" name="Text 10"/>
+          <p:cNvPr id="12" name="Text 10"/>
           <p:cNvSpPr txBox="1"/>
           <p:nvPr/>
         </p:nvSpPr>
@@ -7778,7 +7822,7 @@
       </p:sp>
       <p:sp>
         <p:nvSpPr>
-          <p:cNvPr id="14" name="Text 11"/>
+          <p:cNvPr id="13" name="Text 11"/>
           <p:cNvSpPr txBox="1"/>
           <p:nvPr/>
         </p:nvSpPr>
@@ -7817,7 +7861,7 @@
       </p:sp>
       <p:sp>
         <p:nvSpPr>
-          <p:cNvPr id="15" name="Shape 12"/>
+          <p:cNvPr id="14" name="Shape 12"/>
           <p:cNvSpPr/>
           <p:nvPr/>
         </p:nvSpPr>
@@ -7844,7 +7888,7 @@
       </p:sp>
       <p:sp>
         <p:nvSpPr>
-          <p:cNvPr id="16" name="Text 13"/>
+          <p:cNvPr id="15" name="Text 13"/>
           <p:cNvSpPr txBox="1"/>
           <p:nvPr/>
         </p:nvSpPr>
@@ -7883,7 +7927,7 @@
       </p:sp>
       <p:sp>
         <p:nvSpPr>
-          <p:cNvPr id="17" name="Text 14"/>
+          <p:cNvPr id="16" name="Text 14"/>
           <p:cNvSpPr txBox="1"/>
           <p:nvPr/>
         </p:nvSpPr>
@@ -7922,7 +7966,7 @@
       </p:sp>
       <p:sp>
         <p:nvSpPr>
-          <p:cNvPr id="18" name="Text 15"/>
+          <p:cNvPr id="17" name="Text 15"/>
           <p:cNvSpPr txBox="1"/>
           <p:nvPr/>
         </p:nvSpPr>
@@ -7961,7 +8005,7 @@
       </p:sp>
       <p:sp>
         <p:nvSpPr>
-          <p:cNvPr id="19" name="Text 16"/>
+          <p:cNvPr id="18" name="Text 16"/>
           <p:cNvSpPr txBox="1"/>
           <p:nvPr/>
         </p:nvSpPr>
@@ -8124,7 +8168,7 @@
       </p:sp>
       <p:sp>
         <p:nvSpPr>
-          <p:cNvPr id="5" name="Shape 2"/>
+          <p:cNvPr id="4" name="Shape 2"/>
           <p:cNvSpPr/>
           <p:nvPr/>
         </p:nvSpPr>
@@ -8149,7 +8193,7 @@
       </p:sp>
       <p:sp>
         <p:nvSpPr>
-          <p:cNvPr id="6" name="Text 3"/>
+          <p:cNvPr id="5" name="Text 3"/>
           <p:cNvSpPr txBox="1"/>
           <p:nvPr/>
         </p:nvSpPr>
@@ -8188,7 +8232,7 @@
       </p:sp>
       <p:sp>
         <p:nvSpPr>
-          <p:cNvPr id="7" name="Text 4"/>
+          <p:cNvPr id="6" name="Text 4"/>
           <p:cNvSpPr txBox="1"/>
           <p:nvPr/>
         </p:nvSpPr>
@@ -8227,7 +8271,7 @@
       </p:sp>
       <p:sp>
         <p:nvSpPr>
-          <p:cNvPr id="8" name="Shape 5"/>
+          <p:cNvPr id="7" name="Shape 5"/>
           <p:cNvSpPr/>
           <p:nvPr/>
         </p:nvSpPr>
@@ -8252,7 +8296,7 @@
       </p:sp>
       <p:sp>
         <p:nvSpPr>
-          <p:cNvPr id="9" name="Text 6"/>
+          <p:cNvPr id="8" name="Text 6"/>
           <p:cNvSpPr txBox="1"/>
           <p:nvPr/>
         </p:nvSpPr>
@@ -8291,7 +8335,7 @@
       </p:sp>
       <p:sp>
         <p:nvSpPr>
-          <p:cNvPr id="10" name="Text 7"/>
+          <p:cNvPr id="9" name="Text 7"/>
           <p:cNvSpPr txBox="1"/>
           <p:nvPr/>
         </p:nvSpPr>
@@ -8330,7 +8374,7 @@
       </p:sp>
       <p:sp>
         <p:nvSpPr>
-          <p:cNvPr id="11" name="Shape 8"/>
+          <p:cNvPr id="10" name="Shape 8"/>
           <p:cNvSpPr/>
           <p:nvPr/>
         </p:nvSpPr>
@@ -8355,7 +8399,7 @@
       </p:sp>
       <p:sp>
         <p:nvSpPr>
-          <p:cNvPr id="12" name="Text 9"/>
+          <p:cNvPr id="11" name="Text 9"/>
           <p:cNvSpPr txBox="1"/>
           <p:nvPr/>
         </p:nvSpPr>
@@ -8394,7 +8438,7 @@
       </p:sp>
       <p:sp>
         <p:nvSpPr>
-          <p:cNvPr id="13" name="Text 10"/>
+          <p:cNvPr id="12" name="Text 10"/>
           <p:cNvSpPr txBox="1"/>
           <p:nvPr/>
         </p:nvSpPr>
@@ -8433,7 +8477,7 @@
       </p:sp>
       <p:sp>
         <p:nvSpPr>
-          <p:cNvPr id="14" name="Shape 11"/>
+          <p:cNvPr id="13" name="Shape 11"/>
           <p:cNvSpPr/>
           <p:nvPr/>
         </p:nvSpPr>
@@ -8458,7 +8502,7 @@
       </p:sp>
       <p:sp>
         <p:nvSpPr>
-          <p:cNvPr id="15" name="Text 12"/>
+          <p:cNvPr id="14" name="Text 12"/>
           <p:cNvSpPr txBox="1"/>
           <p:nvPr/>
         </p:nvSpPr>
@@ -8497,7 +8541,7 @@
       </p:sp>
       <p:sp>
         <p:nvSpPr>
-          <p:cNvPr id="16" name="Text 13"/>
+          <p:cNvPr id="15" name="Text 13"/>
           <p:cNvSpPr txBox="1"/>
           <p:nvPr/>
         </p:nvSpPr>
@@ -8536,7 +8580,7 @@
       </p:sp>
       <p:sp>
         <p:nvSpPr>
-          <p:cNvPr id="17" name="Shape 14"/>
+          <p:cNvPr id="16" name="Shape 14"/>
           <p:cNvSpPr/>
           <p:nvPr/>
         </p:nvSpPr>
@@ -8561,7 +8605,7 @@
       </p:sp>
       <p:sp>
         <p:nvSpPr>
-          <p:cNvPr id="18" name="Text 15"/>
+          <p:cNvPr id="17" name="Text 15"/>
           <p:cNvSpPr txBox="1"/>
           <p:nvPr/>
         </p:nvSpPr>
@@ -8600,7 +8644,7 @@
       </p:sp>
       <p:sp>
         <p:nvSpPr>
-          <p:cNvPr id="19" name="Text 16"/>
+          <p:cNvPr id="18" name="Text 16"/>
           <p:cNvSpPr txBox="1"/>
           <p:nvPr/>
         </p:nvSpPr>
@@ -8639,7 +8683,7 @@
       </p:sp>
       <p:sp>
         <p:nvSpPr>
-          <p:cNvPr id="20" name="Shape 17"/>
+          <p:cNvPr id="19" name="Shape 17"/>
           <p:cNvSpPr/>
           <p:nvPr/>
         </p:nvSpPr>
@@ -8664,7 +8708,7 @@
       </p:sp>
       <p:sp>
         <p:nvSpPr>
-          <p:cNvPr id="21" name="Text 18"/>
+          <p:cNvPr id="20" name="Text 18"/>
           <p:cNvSpPr txBox="1"/>
           <p:nvPr/>
         </p:nvSpPr>
@@ -8703,7 +8747,7 @@
       </p:sp>
       <p:sp>
         <p:nvSpPr>
-          <p:cNvPr id="22" name="Text 19"/>
+          <p:cNvPr id="21" name="Text 19"/>
           <p:cNvSpPr txBox="1"/>
           <p:nvPr/>
         </p:nvSpPr>
@@ -8742,7 +8786,7 @@
       </p:sp>
       <p:sp>
         <p:nvSpPr>
-          <p:cNvPr id="23" name="Text 20"/>
+          <p:cNvPr id="22" name="Text 20"/>
           <p:cNvSpPr txBox="1"/>
           <p:nvPr/>
         </p:nvSpPr>
@@ -8781,7 +8825,7 @@
       </p:sp>
       <p:sp>
         <p:nvSpPr>
-          <p:cNvPr id="24" name="Text 21"/>
+          <p:cNvPr id="23" name="Text 21"/>
           <p:cNvSpPr txBox="1"/>
           <p:nvPr/>
         </p:nvSpPr>
@@ -8820,7 +8864,7 @@
       </p:sp>
       <p:sp>
         <p:nvSpPr>
-          <p:cNvPr id="25" name="Shape 22"/>
+          <p:cNvPr id="24" name="Shape 22"/>
           <p:cNvSpPr/>
           <p:nvPr/>
         </p:nvSpPr>
@@ -8847,7 +8891,7 @@
       </p:sp>
       <p:sp>
         <p:nvSpPr>
-          <p:cNvPr id="26" name="Text 23"/>
+          <p:cNvPr id="25" name="Text 23"/>
           <p:cNvSpPr txBox="1"/>
           <p:nvPr/>
         </p:nvSpPr>
@@ -8900,7 +8944,7 @@
       </p:sp>
       <p:sp>
         <p:nvSpPr>
-          <p:cNvPr id="27" name="Shape 24"/>
+          <p:cNvPr id="26" name="Shape 24"/>
           <p:cNvSpPr/>
           <p:nvPr/>
         </p:nvSpPr>
@@ -8927,7 +8971,7 @@
       </p:sp>
       <p:sp>
         <p:nvSpPr>
-          <p:cNvPr id="28" name="Text 25"/>
+          <p:cNvPr id="27" name="Text 25"/>
           <p:cNvSpPr txBox="1"/>
           <p:nvPr/>
         </p:nvSpPr>
@@ -8980,7 +9024,7 @@
       </p:sp>
       <p:sp>
         <p:nvSpPr>
-          <p:cNvPr id="29" name="Shape 26"/>
+          <p:cNvPr id="28" name="Shape 26"/>
           <p:cNvSpPr/>
           <p:nvPr/>
         </p:nvSpPr>
@@ -9007,7 +9051,7 @@
       </p:sp>
       <p:sp>
         <p:nvSpPr>
-          <p:cNvPr id="30" name="Text 27"/>
+          <p:cNvPr id="29" name="Text 27"/>
           <p:cNvSpPr txBox="1"/>
           <p:nvPr/>
         </p:nvSpPr>
@@ -9060,7 +9104,7 @@
       </p:sp>
       <p:sp>
         <p:nvSpPr>
-          <p:cNvPr id="31" name="Shape 28"/>
+          <p:cNvPr id="30" name="Shape 28"/>
           <p:cNvSpPr/>
           <p:nvPr/>
         </p:nvSpPr>
@@ -9087,7 +9131,7 @@
       </p:sp>
       <p:sp>
         <p:nvSpPr>
-          <p:cNvPr id="32" name="Text 29"/>
+          <p:cNvPr id="31" name="Text 29"/>
           <p:cNvSpPr txBox="1"/>
           <p:nvPr/>
         </p:nvSpPr>
@@ -9126,7 +9170,7 @@
       </p:sp>
       <p:sp>
         <p:nvSpPr>
-          <p:cNvPr id="33" name="Text 30"/>
+          <p:cNvPr id="32" name="Text 30"/>
           <p:cNvSpPr txBox="1"/>
           <p:nvPr/>
         </p:nvSpPr>
@@ -10403,7 +10447,7 @@
       </p:graphicFrame>
       <p:sp>
         <p:nvSpPr>
-          <p:cNvPr id="6" name="Text 2"/>
+          <p:cNvPr id="5" name="Text 2"/>
           <p:cNvSpPr txBox="1"/>
           <p:nvPr/>
         </p:nvSpPr>
@@ -10442,7 +10486,7 @@
       </p:sp>
       <p:sp>
         <p:nvSpPr>
-          <p:cNvPr id="7" name="Text 3"/>
+          <p:cNvPr id="6" name="Text 3"/>
           <p:cNvSpPr txBox="1"/>
           <p:nvPr/>
         </p:nvSpPr>
@@ -10495,7 +10539,7 @@
       </p:sp>
       <p:sp>
         <p:nvSpPr>
-          <p:cNvPr id="8" name="Text 4"/>
+          <p:cNvPr id="7" name="Text 4"/>
           <p:cNvSpPr txBox="1"/>
           <p:nvPr/>
         </p:nvSpPr>
@@ -10534,7 +10578,7 @@
       </p:sp>
       <p:sp>
         <p:nvSpPr>
-          <p:cNvPr id="9" name="Shape 5"/>
+          <p:cNvPr id="8" name="Shape 5"/>
           <p:cNvSpPr/>
           <p:nvPr/>
         </p:nvSpPr>
@@ -10561,7 +10605,7 @@
       </p:sp>
       <p:sp>
         <p:nvSpPr>
-          <p:cNvPr id="10" name="Text 6"/>
+          <p:cNvPr id="9" name="Text 6"/>
           <p:cNvSpPr txBox="1"/>
           <p:nvPr/>
         </p:nvSpPr>
@@ -10614,7 +10658,7 @@
       </p:sp>
       <p:sp>
         <p:nvSpPr>
-          <p:cNvPr id="11" name="Shape 7"/>
+          <p:cNvPr id="10" name="Shape 7"/>
           <p:cNvSpPr/>
           <p:nvPr/>
         </p:nvSpPr>
@@ -10641,7 +10685,7 @@
       </p:sp>
       <p:sp>
         <p:nvSpPr>
-          <p:cNvPr id="12" name="Text 8"/>
+          <p:cNvPr id="11" name="Text 8"/>
           <p:cNvSpPr txBox="1"/>
           <p:nvPr/>
         </p:nvSpPr>
@@ -10694,7 +10738,7 @@
       </p:sp>
       <p:sp>
         <p:nvSpPr>
-          <p:cNvPr id="13" name="Shape 9"/>
+          <p:cNvPr id="12" name="Shape 9"/>
           <p:cNvSpPr/>
           <p:nvPr/>
         </p:nvSpPr>
@@ -10721,7 +10765,7 @@
       </p:sp>
       <p:sp>
         <p:nvSpPr>
-          <p:cNvPr id="14" name="Text 10"/>
+          <p:cNvPr id="13" name="Text 10"/>
           <p:cNvSpPr txBox="1"/>
           <p:nvPr/>
         </p:nvSpPr>
@@ -10774,7 +10818,7 @@
       </p:sp>
       <p:sp>
         <p:nvSpPr>
-          <p:cNvPr id="15" name="Shape 11"/>
+          <p:cNvPr id="14" name="Shape 11"/>
           <p:cNvSpPr/>
           <p:nvPr/>
         </p:nvSpPr>
@@ -10801,7 +10845,7 @@
       </p:sp>
       <p:sp>
         <p:nvSpPr>
-          <p:cNvPr id="16" name="Text 12"/>
+          <p:cNvPr id="15" name="Text 12"/>
           <p:cNvSpPr txBox="1"/>
           <p:nvPr/>
         </p:nvSpPr>
@@ -12640,7 +12684,7 @@
       </p:graphicFrame>
       <p:sp>
         <p:nvSpPr>
-          <p:cNvPr id="6" name="Text 2"/>
+          <p:cNvPr id="5" name="Text 2"/>
           <p:cNvSpPr txBox="1"/>
           <p:nvPr/>
         </p:nvSpPr>

</xml_diff>

<commit_message>
Fix slide gaps and upgrade speaker notes
Co-Authored-By: Claude Sonnet 5.5 <noreply@anthropic.com>
Claude-Session: https://claude.ai/code/session_01Ha62b6Wcst3n47bFqEFLKV
</commit_message>
<xml_diff>
--- a/Earning-the-Signal_revised.pptx
+++ b/Earning-the-Signal_revised.pptx
@@ -513,10 +513,11 @@
           <a:p>
             <a:r>
               <a:rPr lang="en-US" dirty="0"/>
-              <a:t>Introduce yourself as Apple TV+'s Digital Transformation Consultant and give your SRN.
-Purpose: show how a machine-learning recommendation engine could help Apple TV+ use data without limiting creativity.
-Structure: Task 1 is the technology, Task 2 is the impact on creative teams, Task 3 is strategy, ethics and recommendations.
-Aim for about 30 seconds on this slide.</a:t>
+              <a:t>[About 0:30]
+Good morning. I'm presenting as Apple TV+'s Digital Transformation Consultant, SRN [add SRN].
+Purpose: to show the leadership team how a machine-learning recommendation engine could help Apple TV+ use data without limiting creativity.
+Structure: technology (Task 1), impact on creative teams (Task 2), and strategy, ethics and recommendations (Task 3).
+Next: why this matters now.</a:t>
             </a:r>
             <a:endParaRPr lang="en-US" dirty="0"/>
           </a:p>
@@ -604,11 +605,13 @@
           <a:p>
             <a:r>
               <a:rPr lang="en-US" dirty="0"/>
-              <a:t>Three recommendations, each with action, owner, evidence and the slide it comes from.
+              <a:t>[About 0:50]
+Three recommendations, each with action, owner, evidence and the slide it comes from.
 1. Creative-team pilot in Kotter-style steps. Owner: creative leadership with the data team. Evidence: Kotter (1995), Napoli (2014). From slides 6 and 7.
 2. Explanation feature for recommendations. Owner: marketing with product and technology. Evidence: Floridi et al. (2018), Apple Inc. (2025). From slides 4 and 9.
 3. Governance review of purpose limitation and diversity auditing. Owner: operations (legal and compliance). Evidence: GDPR Article 5, Ricci et al. (2015). From slides 5 and 9.
-Do first: the pilot. It tackles the central challenge and builds the evidence the other two depend on.</a:t>
+Sequence: pilot first, because it tackles the central challenge and builds evidence for the other two; the governance review runs alongside it.
+Next: summary.</a:t>
             </a:r>
             <a:endParaRPr lang="en-US" dirty="0"/>
           </a:p>
@@ -696,10 +699,11 @@
           <a:p>
             <a:r>
               <a:rPr lang="en-US" dirty="0"/>
-              <a:t>Task 1: a machine-learning recommendation engine helps match a small catalogue to many viewers, but it protects Apple TV+'s position rather than creating a lead.
-Task 2: creative teams are most affected. A Kotter-style change plan can protect originality while they adopt data.
+              <a:t>[About 0:40]
+Task 1: a machine-learning recommendation engine helps match a small catalogue to many viewers, but it protects Apple TV+'s position rather than creating a lead.
+Task 2: creative teams, the group I assessed, can protect originality while adopting data if a Kotter-style change plan is used.
 Task 3: rivals can copy the technology, so advantage depends on ecosystem, creative judgement and ethical safeguards.
-Restate the three recommendations in one line each, then close: used with creative teams at its side, the engine can help Apple TV+ keep subscribers without giving up its originality.</a:t>
+Close: used with creative teams at its side, the engine can help Apple TV+ keep subscribers without giving up the originality it is known for.</a:t>
             </a:r>
             <a:endParaRPr lang="en-US" dirty="0"/>
           </a:p>
@@ -787,7 +791,7 @@
           <a:p>
             <a:r>
               <a:rPr lang="en-US" dirty="0"/>
-              <a:t>Reference list in alphabetical Harvard style. Not presented; provided for information.</a:t>
+              <a:t>Reference list in alphabetical Harvard style. Provided for information; not presented.</a:t>
             </a:r>
             <a:endParaRPr lang="en-US" dirty="0"/>
           </a:p>
@@ -875,12 +879,13 @@
           <a:p>
             <a:r>
               <a:rPr lang="en-US" dirty="0"/>
-              <a:t>Apple TV+ is an original-content subscription service. It competes on the quality of its programmes, not the size of its library, so every title matters more.
-Its strategy is the Apple ecosystem: content sits across iPhone, iPad and other Apple devices.
-Our challenge, taken from the brief: using data to improve recommendations without limiting creativity.
-Why it matters: retention, competition with Netflix, Prime Video and Disney+, and the tension between creative teams and data-driven teams inside the organisation.
-Stat: Antenna (2024) reports 37.2% of Apple TV+ gross additions were returning subscribers who had cancelled within the prior 12 months, the highest serial-churn rate in the industry. Industry churn across major US services also rose from 5.1% to 6.3% between November 2022 and November 2023.
-Link to cost: Reichheld (2003) shows keeping a customer is cheaper than winning a new one, so churn matters financially.</a:t>
+              <a:t>[About 1:00]
+Apple TV+ is an original-content service. It competes on the quality of its programmes, not the size of its library, so every title matters more. Its strategy is the Apple ecosystem: content integrated across iPhone, iPad and other devices (Apple brief).
+The challenge I chose from the brief: using data to improve recommendations without limiting creativity.
+Why it matters: retention, competition with Netflix, Prime Video and Disney+, and the tension between creative and data-driven teams.
+Evidence: Antenna (2024) reports 37.2% of Apple TV+ gross additions were returning subscribers who had cancelled within the prior 12 months, the highest serial-churn rate in the industry. Industry-wide, monthly churn across major US services rose from 5.1% to 6.3% between November 2022 and November 2023 (Antenna, as reported by ABC News).
+So what: Reichheld (2003) shows keeping a customer is cheaper than winning a new one, so churn is a cost problem for leadership, not just a marketing metric.
+Next: the technology I propose.</a:t>
             </a:r>
             <a:endParaRPr lang="en-US" dirty="0"/>
           </a:p>
@@ -968,11 +973,12 @@
           <a:p>
             <a:r>
               <a:rPr lang="en-US" dirty="0"/>
-              <a:t>Plain-language definition: a machine-learning recommendation engine learns from what viewers do and predicts what each viewer will want next.
-Resnick and Varian (1997) describe recommender systems as helping people choose among many options by using the patterns of other people's choices.
-Walk the diagram left to right. Input: viewing history, searches and behaviour signals such as pauses and rewinds. Process: machine learning finds patterns. Output: a personalised home screen.
-Example: Netflix is the best-documented case. Gomez-Uribe and Hunt (2015) describe personalised rows and titles and estimate the system is worth over $1 billion a year in retained subscribers.
-Apple's own privacy documentation says data is collected to tailor features and offer personalised recommendations (Apple Inc., 2025).</a:t>
+              <a:t>[About 0:50]
+In plain terms: a machine-learning recommendation engine learns from what viewers do and predicts what each viewer will want next. Resnick and Varian (1997) describe recommender systems as helping people choose among many options using patterns in other people's choices.
+Walk the diagram left to right. Input: viewing history, search queries and behaviour signals such as pauses and rewinds. Process: machine learning finds patterns. Output: a personalised home screen.
+Evidence: Netflix is the best-documented case. Gomez-Uribe and Hunt (2015) estimate its recommender is worth over $1 billion a year in retained subscribers. Note this is Netflix, not Apple, so it shows the potential rather than guaranteeing the result.
+Apple's own privacy documentation says data is collected "to tailor features and offer personalised recommendations" (Apple Inc., 2025).
+Next: how it helps with our challenge.</a:t>
             </a:r>
             <a:endParaRPr lang="en-US" dirty="0"/>
           </a:p>
@@ -1060,11 +1066,13 @@
           <a:p>
             <a:r>
               <a:rPr lang="en-US" dirty="0"/>
-              <a:t>Matching at scale: Apple TV+ has a small, high-quality catalogue. The engine matches it to millions of different viewers so good originals are found, not buried. This is how the engine helps with the challenge.
+              <a:t>[About 0:50]
+How it helps: Apple TV+ has a small, high-quality catalogue. The engine matches it to millions of different viewers, so good originals are found rather than buried.
 Porter's Five Forces (Porter, 2008): two forces change most.
 Rivalry: better discovery raises the value of each subscription, but Netflix, Prime Video and Disney+ run similar engines, so it protects our position rather than creating a lead.
-Buyer power: switching costs are low. A profile that has learned a viewer's taste adds a small cost to leaving.
-Creativity side: the engine can steer which content is promoted. This is where creative teams' concern comes from, and it leads into Task 2.</a:t>
+Buyer power: switching costs are low. The high serial-churn figure on slide 2 is evidence that subscribers leave and return easily. A profile that has learned someone's taste adds only a small cost to leaving.
+The creativity side: the engine can steer which content is promoted. That is where creative teams' concern comes from.
+Next: weighing benefits against limitations.</a:t>
             </a:r>
             <a:endParaRPr lang="en-US" dirty="0"/>
           </a:p>
@@ -1152,10 +1160,12 @@
           <a:p>
             <a:r>
               <a:rPr lang="en-US" dirty="0"/>
-              <a:t>Benefits, each sourced: discovery (Gracenote, 2025: 49% of viewers say they are likely to cancel if they cannot find something to watch), engagement and retention (Gomez-Uribe and Hunt, 2015; Reichheld, 2003).
-Limitations: narrowing recommendations and data quality (Ricci, Rokach and Shapira, 2015), reduced diversity (Helberger, 2019), possible loss of creative originality (Napoli, 2014), and privacy, governance and bias risks when AI is scaled (Mokoena and Obagbuwa, 2025, a review of AI in music streaming).
-Most important for Apple TV+: discovery on the benefit side, because a small catalogue only pays off if each show is found; creative originality on the limitation side, because Apple competes on quality.
-Conclusion: personalisation is necessary but not sufficient. Its benefits depend on managing these limits.</a:t>
+              <a:t>[About 1:00]
+Benefits, each sourced. Discovery: Gracenote (2025) found 49% of viewers say they are likely to cancel if they cannot find something to watch. Engagement and retention: Gomez-Uribe and Hunt (2015) and Reichheld (2003).
+Limitations. Narrowing and data quality: Ricci, Rokach and Shapira (2015). Reduced diversity: Helberger (2019). Possible loss of creative originality: Napoli (2014). Privacy, governance and bias when AI is scaled: Mokoena and Obagbuwa (2025).
+Weigh them: for Apple TV+ the most important benefit is discovery, because a small catalogue only pays off if each show is found. The most important limitation is creative originality, because Apple competes on quality.
+Conclusion: personalisation is necessary but not sufficient. Its benefits depend on managing these limits.
+Next: what this means for the people who make the content.</a:t>
             </a:r>
             <a:endParaRPr lang="en-US" dirty="0"/>
           </a:p>
@@ -1243,12 +1253,11 @@
           <a:p>
             <a:r>
               <a:rPr lang="en-US" dirty="0"/>
-              <a:t>Chosen stakeholder group: creative teams, meaning writers, producers and content developers.
-Their concern, from the brief: too much reliance on data could affect originality.
-Structure: who decides what gets made. Data should inform commissioning, not replace it.
-Culture: creative autonomy versus data-driven decisions. Teams need to see data as a tool, not a verdict (Napoli, 2014).
-Process: green-lighting and pitches. Add a data check to pitches but keep creative sign-off at the final step.
-TAM (Davis, 1989): would they find it useful and easy to use? Useful if it shows which audiences a pitch could reach; easy only if insights are in plain language and built into the pitch workflow.</a:t>
+              <a:t>[About 1:00]
+Personalisation at this scale does not only change what customers see; it also changes how creative teams decide what gets made.
+Stakeholder group I chose: creative teams, meaning writers, producers and content developers. Their concern, from the brief: too much reliance on data could affect originality. Structure, culture and process influence one another. Structure: who decides what gets made. Culture: creative autonomy versus data-driven decisions; if teams see data as a verdict, they will resist (Napoli, 2014). Process: pitches and green-lighting. If the process keeps creative sign-off final, the culture is more likely to accept the tool.
+TAM (Davis, 1989): is it useful and easy to use? Useful if it shows which audiences a pitch could reach; easy only if insights are in plain language and built into the pitch workflow.
+Next: the barriers and how to manage them.</a:t>
             </a:r>
             <a:endParaRPr lang="en-US" dirty="0"/>
           </a:p>
@@ -1336,9 +1345,11 @@
           <a:p>
             <a:r>
               <a:rPr lang="en-US" dirty="0"/>
-              <a:t>Barriers: fear of losing creative control, distrust of algorithms, and skills gaps. Responses: keep creative sign-off final and publish rules for data use; show why content is promoted so creatives can see how data influences decisions; train people on real projects (Vial, 2019).
-Change model: Kotter (1995), condensed to six steps for Apple TV+. Urgency (churn and rivals), coalition (creative champions plus data leads), vision (data informs, creatives decide), pilot on one slate of originals and share early wins, extend into pitches and green-lighting, embed in how Apple TV+ commissions.
-Digital confidence actions: training, pilots, creative champions and feedback channels into the model team.</a:t>
+              <a:t>[About 1:00]
+Barriers: fear of losing creative control, distrust of algorithms, and skills gaps. The main barrier is visibility: creative teams cannot see how data influences decisions.
+Responses: keep creative sign-off final and publish rules for data use; show why content is promoted so creatives can see the reasoning; train people on real projects (Vial, 2019).
+Change model: Kotter (1995), condensed from eight steps to six for Apple TV+. Urgency from churn and rivals; a coalition of creative champions and data leads; a vision that data informs and creatives decide; a pilot on one slate of originals with early wins shared; extension into pitches and green-lighting; and embedding in how Apple TV+ commissions.
+Next: does this give lasting advantage?</a:t>
             </a:r>
             <a:endParaRPr lang="en-US" dirty="0"/>
           </a:p>
@@ -1426,13 +1437,15 @@
           <a:p>
             <a:r>
               <a:rPr lang="en-US" dirty="0"/>
-              <a:t>VRIO (Barney, 1991) applied honestly.
-Valuable: yes. Better discovery supports retention and engagement, but scaling AI brings privacy, governance and bias risks.
-Rare: no. Streaming rivals already run recommenders and the technique is widely documented.
-Hard to imitate: partly. Models are copyable; Apple's ecosystem data and quality-focused catalogue are harder to copy.
-Organised: not yet. Creative and data teams are not aligned and there are no shared rules for how data shapes commissioning.
+              <a:t>[About 1:00]
+VRIO (Barney, 1991), applied honestly.
+Valuable: yes. Better discovery supports retention and agility, but scaling AI brings privacy, governance and bias risks.
+Rare: no. Streaming rivals already run recommenders and the technique is widely documented (Ricci et al., 2015).
+Hard to imitate: partly. Models are copyable. Apple's ecosystem data and quality-focused catalogue are harder to copy; this is my judgement, not a measured finding.
+Organised to exploit: not yet. The brief shows creative, marketing and operations teams hold different views, so there are no shared rules for how data shapes commissioning. This is my inference from the brief.
 Verdict: competitive parity, not sustained advantage. As models converge, accuracy alone differentiates little.
-Continuous improvement: A/B testing, creative input into the goals the model optimises, and regular data and model refresh. Ansoff (1957): this is market penetration, deepening retention in existing markets.</a:t>
+Continuous improvement: A/B testing gives agility; creative input into the goals the model optimises supports innovation; regular data and model refresh keeps it current. Ansoff (1957): this is market penetration, deepening retention in existing markets, rather than a new product.
+Next: the risks that come with it.</a:t>
             </a:r>
             <a:endParaRPr lang="en-US" dirty="0"/>
           </a:p>
@@ -1520,12 +1533,13 @@
           <a:p>
             <a:r>
               <a:rPr lang="en-US" dirty="0"/>
-              <a:t>Five issues, each with a principle and mitigation.
-Privacy: data collected for recommendations could be reused for other purposes. GDPR Article 5 requires specified, explicit purposes (European Parliament and Council, 2016). Mitigation: document and review purpose limitation.
+              <a:t>[About 0:50]
+Risks, ranked by impact for Apple TV+, with a principle and mitigation for each.
+Privacy: data collected for recommendations could be reused for other purposes. GDPR Article 5 requires specified, explicit purposes (European Parliament and Council, 2016) and applies to subscribers in the EU. Mitigation: document and review purpose limitation. This also protects Apple's brand.
 Bias and fairness: models trained on past viewing narrow what is shown (Ricci et al., 2015). Mitigation: regular diversity audits.
 Transparency: viewers and creatives cannot see why content is promoted. Mitigation: 'why am I seeing this' explanations.
-Creators' autonomy: algorithms can steer which projects are promoted and made (Napoli, 2014). Mitigation: creative sign-off.
-Social: filter bubbles and cultural diversity (Pariser, 2011; Helberger, 2019). Principles draw on Floridi et al. (2018).</a:t>
+Creators' autonomy: algorithms can steer which projects are promoted and made (Napoli, 2014). Mitigation: keep creative sign-off.
+Next: what I recommend.</a:t>
             </a:r>
             <a:endParaRPr lang="en-US" dirty="0"/>
           </a:p>
@@ -3348,7 +3362,7 @@
                 <a:ea typeface="Calibri" pitchFamily="34" charset="-122"/>
                 <a:cs typeface="Calibri" pitchFamily="34" charset="-120"/>
               </a:rPr>
-              <a:t>Creative teams are the group most affected; a Kotter-style change plan can protect originality while they adopt data.</a:t>
+              <a:t>Creative teams, the group assessed, can protect originality while adopting data if a Kotter-style change plan is used.</a:t>
             </a:r>
             <a:endParaRPr lang="en-US" sz="1400" dirty="0"/>
           </a:p>
@@ -4877,7 +4891,7 @@
               <a:buNone/>
             </a:pPr>
             <a:r>
-              <a:rPr lang="en-US" sz="1500" dirty="0">
+              <a:rPr lang="en-US" sz="1600" dirty="0">
                 <a:solidFill>
                   <a:srgbClr val="27314D"/>
                 </a:solidFill>
@@ -4887,7 +4901,7 @@
               </a:rPr>
               <a:t>A machine-learning recommendation engine learns from what viewers do and predicts what each viewer will want to watch next. Recommender systems help people choose among many options by drawing on patterns in collective behaviour (Resnick and Varian, 1997).</a:t>
             </a:r>
-            <a:endParaRPr lang="en-US" sz="1500" dirty="0"/>
+            <a:endParaRPr lang="en-US" sz="1600" dirty="0"/>
           </a:p>
         </p:txBody>
       </p:sp>
@@ -4899,12 +4913,12 @@
         </p:nvSpPr>
         <p:spPr>
           <a:xfrm>
-            <a:off x="548640" y="2468880"/>
-            <a:ext cx="3108960" cy="1828800"/>
+            <a:off x="548640" y="2377440"/>
+            <a:ext cx="3108960" cy="2103120"/>
           </a:xfrm>
           <a:prstGeom prst="roundRect">
             <a:avLst>
-              <a:gd name="adj" fmla="val 4000"/>
+              <a:gd name="adj" fmla="val 3478"/>
             </a:avLst>
           </a:prstGeom>
           <a:solidFill>
@@ -4926,7 +4940,7 @@
         </p:nvSpPr>
         <p:spPr>
           <a:xfrm>
-            <a:off x="731520" y="2560320"/>
+            <a:off x="731520" y="2514600"/>
             <a:ext cx="2743200" cy="411480"/>
           </a:xfrm>
           <a:prstGeom prst="rect">
@@ -4943,7 +4957,7 @@
               <a:buNone/>
             </a:pPr>
             <a:r>
-              <a:rPr lang="en-US" sz="1700" b="1" dirty="0">
+              <a:rPr lang="en-US" sz="1800" b="1" dirty="0">
                 <a:solidFill>
                   <a:srgbClr val="27314D"/>
                 </a:solidFill>
@@ -4953,7 +4967,7 @@
               </a:rPr>
               <a:t>Input</a:t>
             </a:r>
-            <a:endParaRPr lang="en-US" sz="1700" dirty="0"/>
+            <a:endParaRPr lang="en-US" sz="1800" dirty="0"/>
           </a:p>
         </p:txBody>
       </p:sp>
@@ -4966,7 +4980,7 @@
         <p:spPr>
           <a:xfrm>
             <a:off x="731520" y="3017520"/>
-            <a:ext cx="2743200" cy="1188720"/>
+            <a:ext cx="2743200" cy="1371600"/>
           </a:xfrm>
           <a:prstGeom prst="rect">
             <a:avLst/>
@@ -4982,7 +4996,7 @@
               <a:buNone/>
             </a:pPr>
             <a:r>
-              <a:rPr lang="en-US" sz="1400" dirty="0">
+              <a:rPr lang="en-US" sz="1500" dirty="0">
                 <a:solidFill>
                   <a:srgbClr val="27314D"/>
                 </a:solidFill>
@@ -4992,7 +5006,7 @@
               </a:rPr>
               <a:t>Viewing history, searches, and behaviour signals such as pauses and rewinds</a:t>
             </a:r>
-            <a:endParaRPr lang="en-US" sz="1400" dirty="0"/>
+            <a:endParaRPr lang="en-US" sz="1500" dirty="0"/>
           </a:p>
         </p:txBody>
       </p:sp>
@@ -5004,7 +5018,7 @@
         </p:nvSpPr>
         <p:spPr>
           <a:xfrm>
-            <a:off x="3794760" y="3200400"/>
+            <a:off x="3794760" y="3246120"/>
             <a:ext cx="640080" cy="365760"/>
           </a:xfrm>
           <a:prstGeom prst="rightArrow">
@@ -5029,12 +5043,12 @@
         </p:nvSpPr>
         <p:spPr>
           <a:xfrm>
-            <a:off x="4526280" y="2468880"/>
-            <a:ext cx="3108960" cy="1828800"/>
+            <a:off x="4526280" y="2377440"/>
+            <a:ext cx="3108960" cy="2103120"/>
           </a:xfrm>
           <a:prstGeom prst="roundRect">
             <a:avLst>
-              <a:gd name="adj" fmla="val 4000"/>
+              <a:gd name="adj" fmla="val 3478"/>
             </a:avLst>
           </a:prstGeom>
           <a:solidFill>
@@ -5056,7 +5070,7 @@
         </p:nvSpPr>
         <p:spPr>
           <a:xfrm>
-            <a:off x="4709160" y="2560320"/>
+            <a:off x="4709160" y="2514600"/>
             <a:ext cx="2743200" cy="411480"/>
           </a:xfrm>
           <a:prstGeom prst="rect">
@@ -5073,7 +5087,7 @@
               <a:buNone/>
             </a:pPr>
             <a:r>
-              <a:rPr lang="en-US" sz="1700" b="1" dirty="0">
+              <a:rPr lang="en-US" sz="1800" b="1" dirty="0">
                 <a:solidFill>
                   <a:srgbClr val="FFFFFF"/>
                 </a:solidFill>
@@ -5083,7 +5097,7 @@
               </a:rPr>
               <a:t>Process</a:t>
             </a:r>
-            <a:endParaRPr lang="en-US" sz="1700" dirty="0"/>
+            <a:endParaRPr lang="en-US" sz="1800" dirty="0"/>
           </a:p>
         </p:txBody>
       </p:sp>
@@ -5096,7 +5110,7 @@
         <p:spPr>
           <a:xfrm>
             <a:off x="4709160" y="3017520"/>
-            <a:ext cx="2743200" cy="1188720"/>
+            <a:ext cx="2743200" cy="1371600"/>
           </a:xfrm>
           <a:prstGeom prst="rect">
             <a:avLst/>
@@ -5112,7 +5126,7 @@
               <a:buNone/>
             </a:pPr>
             <a:r>
-              <a:rPr lang="en-US" sz="1400" dirty="0">
+              <a:rPr lang="en-US" sz="1500" dirty="0">
                 <a:solidFill>
                   <a:srgbClr val="FFFFFF"/>
                 </a:solidFill>
@@ -5122,7 +5136,7 @@
               </a:rPr>
               <a:t>Machine learning finds patterns and predicts what each viewer wants next</a:t>
             </a:r>
-            <a:endParaRPr lang="en-US" sz="1400" dirty="0"/>
+            <a:endParaRPr lang="en-US" sz="1500" dirty="0"/>
           </a:p>
         </p:txBody>
       </p:sp>
@@ -5134,7 +5148,7 @@
         </p:nvSpPr>
         <p:spPr>
           <a:xfrm>
-            <a:off x="7772400" y="3200400"/>
+            <a:off x="7772400" y="3246120"/>
             <a:ext cx="640080" cy="365760"/>
           </a:xfrm>
           <a:prstGeom prst="rightArrow">
@@ -5159,12 +5173,12 @@
         </p:nvSpPr>
         <p:spPr>
           <a:xfrm>
-            <a:off x="8503920" y="2468880"/>
-            <a:ext cx="3108960" cy="1828800"/>
+            <a:off x="8503920" y="2377440"/>
+            <a:ext cx="3108960" cy="2103120"/>
           </a:xfrm>
           <a:prstGeom prst="roundRect">
             <a:avLst>
-              <a:gd name="adj" fmla="val 4000"/>
+              <a:gd name="adj" fmla="val 3478"/>
             </a:avLst>
           </a:prstGeom>
           <a:solidFill>
@@ -5186,7 +5200,7 @@
         </p:nvSpPr>
         <p:spPr>
           <a:xfrm>
-            <a:off x="8686800" y="2560320"/>
+            <a:off x="8686800" y="2514600"/>
             <a:ext cx="2743200" cy="411480"/>
           </a:xfrm>
           <a:prstGeom prst="rect">
@@ -5203,7 +5217,7 @@
               <a:buNone/>
             </a:pPr>
             <a:r>
-              <a:rPr lang="en-US" sz="1700" b="1" dirty="0">
+              <a:rPr lang="en-US" sz="1800" b="1" dirty="0">
                 <a:solidFill>
                   <a:srgbClr val="27314D"/>
                 </a:solidFill>
@@ -5213,7 +5227,7 @@
               </a:rPr>
               <a:t>Output</a:t>
             </a:r>
-            <a:endParaRPr lang="en-US" sz="1700" dirty="0"/>
+            <a:endParaRPr lang="en-US" sz="1800" dirty="0"/>
           </a:p>
         </p:txBody>
       </p:sp>
@@ -5226,7 +5240,7 @@
         <p:spPr>
           <a:xfrm>
             <a:off x="8686800" y="3017520"/>
-            <a:ext cx="2743200" cy="1188720"/>
+            <a:ext cx="2743200" cy="1371600"/>
           </a:xfrm>
           <a:prstGeom prst="rect">
             <a:avLst/>
@@ -5242,7 +5256,7 @@
               <a:buNone/>
             </a:pPr>
             <a:r>
-              <a:rPr lang="en-US" sz="1400" dirty="0">
+              <a:rPr lang="en-US" sz="1500" dirty="0">
                 <a:solidFill>
                   <a:srgbClr val="27314D"/>
                 </a:solidFill>
@@ -5252,7 +5266,7 @@
               </a:rPr>
               <a:t>A personalised home screen and “what to watch next” suggestions</a:t>
             </a:r>
-            <a:endParaRPr lang="en-US" sz="1400" dirty="0"/>
+            <a:endParaRPr lang="en-US" sz="1500" dirty="0"/>
           </a:p>
         </p:txBody>
       </p:sp>
@@ -5303,8 +5317,8 @@
         </p:nvSpPr>
         <p:spPr>
           <a:xfrm>
-            <a:off x="548640" y="4663440"/>
-            <a:ext cx="11064240" cy="1463040"/>
+            <a:off x="548640" y="4846320"/>
+            <a:ext cx="11064240" cy="1280160"/>
           </a:xfrm>
           <a:prstGeom prst="rect">
             <a:avLst/>
@@ -5318,12 +5332,12 @@
           <a:p>
             <a:pPr indent="0" marL="0">
               <a:spcAft>
-                <a:spcPts val="600"/>
+                <a:spcPts val="800"/>
               </a:spcAft>
               <a:buNone/>
             </a:pPr>
             <a:r>
-              <a:rPr lang="en-US" sz="1400" b="1" dirty="0">
+              <a:rPr lang="en-US" sz="1500" b="1" dirty="0">
                 <a:solidFill>
                   <a:srgbClr val="1E2761"/>
                 </a:solidFill>
@@ -5335,12 +5349,12 @@
             </a:r>
             <a:pPr indent="0" marL="0">
               <a:spcAft>
-                <a:spcPts val="600"/>
+                <a:spcPts val="800"/>
               </a:spcAft>
               <a:buNone/>
             </a:pPr>
             <a:r>
-              <a:rPr lang="en-US" sz="1400" dirty="0">
+              <a:rPr lang="en-US" sz="1500" dirty="0">
                 <a:solidFill>
                   <a:srgbClr val="27314D"/>
                 </a:solidFill>
@@ -5350,17 +5364,17 @@
               </a:rPr>
               <a:t>Netflix personalises rows and titles for each member, and estimates the system is worth over $1 billion a year in retained subscribers (Gomez-Uribe and Hunt, 2015).</a:t>
             </a:r>
-            <a:endParaRPr lang="en-US" sz="1400" dirty="0"/>
+            <a:endParaRPr lang="en-US" sz="1500" dirty="0"/>
           </a:p>
           <a:p>
             <a:pPr indent="0" marL="0">
               <a:spcAft>
-                <a:spcPts val="600"/>
+                <a:spcPts val="800"/>
               </a:spcAft>
               <a:buNone/>
             </a:pPr>
             <a:r>
-              <a:rPr lang="en-US" sz="1400" b="1" dirty="0">
+              <a:rPr lang="en-US" sz="1500" b="1" dirty="0">
                 <a:solidFill>
                   <a:srgbClr val="1E2761"/>
                 </a:solidFill>
@@ -5372,12 +5386,12 @@
             </a:r>
             <a:pPr indent="0" marL="0">
               <a:spcAft>
-                <a:spcPts val="600"/>
+                <a:spcPts val="800"/>
               </a:spcAft>
               <a:buNone/>
             </a:pPr>
             <a:r>
-              <a:rPr lang="en-US" sz="1400" dirty="0">
+              <a:rPr lang="en-US" sz="1500" dirty="0">
                 <a:solidFill>
                   <a:srgbClr val="27314D"/>
                 </a:solidFill>
@@ -5387,7 +5401,7 @@
               </a:rPr>
               <a:t>viewing and activity data is collected “to tailor features and offer personalised recommendations” (Apple Inc., 2025).</a:t>
             </a:r>
-            <a:endParaRPr lang="en-US" sz="1400" dirty="0"/>
+            <a:endParaRPr lang="en-US" sz="1500" dirty="0"/>
           </a:p>
         </p:txBody>
       </p:sp>
@@ -5510,7 +5524,7 @@
         <p:spPr>
           <a:xfrm>
             <a:off x="548640" y="1371600"/>
-            <a:ext cx="6035040" cy="4754880"/>
+            <a:ext cx="6035040" cy="3657600"/>
           </a:xfrm>
           <a:prstGeom prst="rect">
             <a:avLst/>
@@ -5526,7 +5540,7 @@
               <a:buNone/>
             </a:pPr>
             <a:r>
-              <a:rPr lang="en-US" sz="1400" b="1" dirty="0">
+              <a:rPr lang="en-US" sz="1500" b="1" dirty="0">
                 <a:solidFill>
                   <a:srgbClr val="1E2761"/>
                 </a:solidFill>
@@ -5536,14 +5550,14 @@
               </a:rPr>
               <a:t>Matching at scale</a:t>
             </a:r>
-            <a:endParaRPr lang="en-US" sz="1400" dirty="0"/>
-          </a:p>
-          <a:p>
-            <a:pPr indent="0" marL="0">
-              <a:buNone/>
-            </a:pPr>
-            <a:r>
-              <a:rPr lang="en-US" sz="1400" dirty="0">
+            <a:endParaRPr lang="en-US" sz="1500" dirty="0"/>
+          </a:p>
+          <a:p>
+            <a:pPr indent="0" marL="0">
+              <a:buNone/>
+            </a:pPr>
+            <a:r>
+              <a:rPr lang="en-US" sz="1500" dirty="0">
                 <a:solidFill>
                   <a:srgbClr val="27314D"/>
                 </a:solidFill>
@@ -5553,7 +5567,7 @@
               </a:rPr>
               <a:t>The engine matches a small, high-quality catalogue to millions of different viewers, so good original content is found rather than buried.</a:t>
             </a:r>
-            <a:endParaRPr lang="en-US" sz="1400" dirty="0"/>
+            <a:endParaRPr lang="en-US" sz="1500" dirty="0"/>
           </a:p>
           <a:p>
             <a:pPr indent="0" marL="0">
@@ -5570,14 +5584,14 @@
               </a:rPr>
               <a:t> </a:t>
             </a:r>
-            <a:endParaRPr lang="en-US" sz="1400" dirty="0"/>
-          </a:p>
-          <a:p>
-            <a:pPr indent="0" marL="0">
-              <a:buNone/>
-            </a:pPr>
-            <a:r>
-              <a:rPr lang="en-US" sz="1400" b="1" dirty="0">
+            <a:endParaRPr lang="en-US" sz="1500" dirty="0"/>
+          </a:p>
+          <a:p>
+            <a:pPr indent="0" marL="0">
+              <a:buNone/>
+            </a:pPr>
+            <a:r>
+              <a:rPr lang="en-US" sz="1500" b="1" dirty="0">
                 <a:solidFill>
                   <a:srgbClr val="1E2761"/>
                 </a:solidFill>
@@ -5587,14 +5601,14 @@
               </a:rPr>
               <a:t>Rivalry with Netflix, Prime Video and Disney+</a:t>
             </a:r>
-            <a:endParaRPr lang="en-US" sz="1400" dirty="0"/>
-          </a:p>
-          <a:p>
-            <a:pPr indent="0" marL="0">
-              <a:buNone/>
-            </a:pPr>
-            <a:r>
-              <a:rPr lang="en-US" sz="1400" dirty="0">
+            <a:endParaRPr lang="en-US" sz="1500" dirty="0"/>
+          </a:p>
+          <a:p>
+            <a:pPr indent="0" marL="0">
+              <a:buNone/>
+            </a:pPr>
+            <a:r>
+              <a:rPr lang="en-US" sz="1500" dirty="0">
                 <a:solidFill>
                   <a:srgbClr val="27314D"/>
                 </a:solidFill>
@@ -5604,7 +5618,7 @@
               </a:rPr>
               <a:t>Better discovery raises the value of each subscription, but rivals run similar engines, so it protects position rather than creating a lead.</a:t>
             </a:r>
-            <a:endParaRPr lang="en-US" sz="1400" dirty="0"/>
+            <a:endParaRPr lang="en-US" sz="1500" dirty="0"/>
           </a:p>
           <a:p>
             <a:pPr indent="0" marL="0">
@@ -5621,14 +5635,14 @@
               </a:rPr>
               <a:t> </a:t>
             </a:r>
-            <a:endParaRPr lang="en-US" sz="1400" dirty="0"/>
-          </a:p>
-          <a:p>
-            <a:pPr indent="0" marL="0">
-              <a:buNone/>
-            </a:pPr>
-            <a:r>
-              <a:rPr lang="en-US" sz="1400" b="1" dirty="0">
+            <a:endParaRPr lang="en-US" sz="1500" dirty="0"/>
+          </a:p>
+          <a:p>
+            <a:pPr indent="0" marL="0">
+              <a:buNone/>
+            </a:pPr>
+            <a:r>
+              <a:rPr lang="en-US" sz="1500" b="1" dirty="0">
                 <a:solidFill>
                   <a:srgbClr val="1E2761"/>
                 </a:solidFill>
@@ -5638,14 +5652,14 @@
               </a:rPr>
               <a:t>Buyer switching power</a:t>
             </a:r>
-            <a:endParaRPr lang="en-US" sz="1400" dirty="0"/>
-          </a:p>
-          <a:p>
-            <a:pPr indent="0" marL="0">
-              <a:buNone/>
-            </a:pPr>
-            <a:r>
-              <a:rPr lang="en-US" sz="1400" dirty="0">
+            <a:endParaRPr lang="en-US" sz="1500" dirty="0"/>
+          </a:p>
+          <a:p>
+            <a:pPr indent="0" marL="0">
+              <a:buNone/>
+            </a:pPr>
+            <a:r>
+              <a:rPr lang="en-US" sz="1500" dirty="0">
                 <a:solidFill>
                   <a:srgbClr val="27314D"/>
                 </a:solidFill>
@@ -5655,7 +5669,7 @@
               </a:rPr>
               <a:t>Switching costs are low. A profile that has learned a viewer’s taste adds a small cost to leaving.</a:t>
             </a:r>
-            <a:endParaRPr lang="en-US" sz="1400" dirty="0"/>
+            <a:endParaRPr lang="en-US" sz="1500" dirty="0"/>
           </a:p>
           <a:p>
             <a:pPr indent="0" marL="0">
@@ -5672,14 +5686,14 @@
               </a:rPr>
               <a:t> </a:t>
             </a:r>
-            <a:endParaRPr lang="en-US" sz="1400" dirty="0"/>
-          </a:p>
-          <a:p>
-            <a:pPr indent="0" marL="0">
-              <a:buNone/>
-            </a:pPr>
-            <a:r>
-              <a:rPr lang="en-US" sz="1400" b="1" dirty="0">
+            <a:endParaRPr lang="en-US" sz="1500" dirty="0"/>
+          </a:p>
+          <a:p>
+            <a:pPr indent="0" marL="0">
+              <a:buNone/>
+            </a:pPr>
+            <a:r>
+              <a:rPr lang="en-US" sz="1500" b="1" dirty="0">
                 <a:solidFill>
                   <a:srgbClr val="F96167"/>
                 </a:solidFill>
@@ -5689,14 +5703,14 @@
               </a:rPr>
               <a:t>The creativity side</a:t>
             </a:r>
-            <a:endParaRPr lang="en-US" sz="1400" dirty="0"/>
-          </a:p>
-          <a:p>
-            <a:pPr indent="0" marL="0">
-              <a:buNone/>
-            </a:pPr>
-            <a:r>
-              <a:rPr lang="en-US" sz="1400" dirty="0">
+            <a:endParaRPr lang="en-US" sz="1500" dirty="0"/>
+          </a:p>
+          <a:p>
+            <a:pPr indent="0" marL="0">
+              <a:buNone/>
+            </a:pPr>
+            <a:r>
+              <a:rPr lang="en-US" sz="1500" dirty="0">
                 <a:solidFill>
                   <a:srgbClr val="27314D"/>
                 </a:solidFill>
@@ -5706,7 +5720,7 @@
               </a:rPr>
               <a:t>The engine can steer which content is promoted. This is where creative teams’ concern comes from.</a:t>
             </a:r>
-            <a:endParaRPr lang="en-US" sz="1400" dirty="0"/>
+            <a:endParaRPr lang="en-US" sz="1500" dirty="0"/>
           </a:p>
         </p:txBody>
       </p:sp>
@@ -10531,7 +10545,7 @@
                 <a:ea typeface="Calibri" pitchFamily="34" charset="-122"/>
                 <a:cs typeface="Calibri" pitchFamily="34" charset="-120"/>
               </a:rPr>
-              <a:t>competitive parity, not sustained advantage. The recommender is a necessary baseline; advantage comes from pairing it with Apple’s ecosystem and creative judgement.</a:t>
+              <a:t>competitive parity, not sustained advantage. The recommender supports retention and agility but is only a baseline; advantage comes from pairing it with Apple’s ecosystem and creative judgement.</a:t>
             </a:r>
             <a:endParaRPr lang="en-US" sz="1400" dirty="0"/>
           </a:p>
@@ -10636,7 +10650,7 @@
                 <a:ea typeface="Calibri" pitchFamily="34" charset="-122"/>
                 <a:cs typeface="Calibri" pitchFamily="34" charset="-120"/>
               </a:rPr>
-              <a:t>Test: </a:t>
+              <a:t>Test (agility): </a:t>
             </a:r>
             <a:pPr indent="0" marL="0">
               <a:buNone/>
@@ -10716,7 +10730,7 @@
                 <a:ea typeface="Calibri" pitchFamily="34" charset="-122"/>
                 <a:cs typeface="Calibri" pitchFamily="34" charset="-120"/>
               </a:rPr>
-              <a:t>Creative input: </a:t>
+              <a:t>Creative input (innovation): </a:t>
             </a:r>
             <a:pPr indent="0" marL="0">
               <a:buNone/>

</xml_diff>

<commit_message>
Consultant voice on slides, final speaker notes (about 3,450 words)
Co-Authored-By: Claude Sonnet 5.5 <noreply@anthropic.com>
Claude-Session: https://claude.ai/code/session_01Ha62b6Wcst3n47bFqEFLKV
</commit_message>
<xml_diff>
--- a/Earning-the-Signal_revised.pptx
+++ b/Earning-the-Signal_revised.pptx
@@ -513,11 +513,10 @@
           <a:p>
             <a:r>
               <a:rPr lang="en-US" dirty="0"/>
-              <a:t>[About 0:30]
-Good morning. I'm presenting as Apple TV+'s Digital Transformation Consultant, SRN [add SRN].
-Purpose: to show the leadership team how a machine-learning recommendation engine could help Apple TV+ use data without limiting creativity.
-Structure: technology (Task 1), impact on creative teams (Task 2), and strategy, ethics and recommendations (Task 3).
-Next: why this matters now.</a:t>
+              <a:t>Good morning, and thank you for your time. I am your Digital Transformation Consultant, and today I will set out how a machine-learning recommendation engine could help Apple TV+ use data to improve what your subscribers watch, without limiting the creativity that defines the service. [SRN: add SRN.]
+The presentation has three parts. First, the technology: how it works, how it addresses your challenge, and its benefits and limitations. Second, the impact on your creative teams, and how to manage the change. Third, the strategic implications, including whether it can give you lasting advantage, the ethical and risk issues, and three recommendations.
+At the end I will ask you to approve three actions, and I will tell you which should come first.
+Everything I present draws on published research and industry sources, which are listed on the final slide. Where a point is my own judgement and not a measured finding, I will say so.</a:t>
             </a:r>
             <a:endParaRPr lang="en-US" dirty="0"/>
           </a:p>
@@ -605,13 +604,13 @@
           <a:p>
             <a:r>
               <a:rPr lang="en-US" dirty="0"/>
-              <a:t>[About 0:50]
-Three recommendations, each with action, owner, evidence and the slide it comes from.
-1. Creative-team pilot in Kotter-style steps. Owner: creative leadership with the data team. Evidence: Kotter (1995), Napoli (2014). From slides 6 and 7.
-2. Explanation feature for recommendations. Owner: marketing with product and technology. Evidence: Floridi et al. (2018), Apple Inc. (2025). From slides 4 and 9.
-3. Governance review of purpose limitation and diversity auditing. Owner: operations (legal and compliance). Evidence: GDPR Article 5, Ricci et al. (2015). From slides 5 and 9.
-Sequence: pilot first, because it tackles the central challenge and builds evidence for the other two; the governance review runs alongside it.
-Next: summary.</a:t>
+              <a:t>I recommend three actions. Each has an owner, evidence, and a link back to the analysis.
+Recommendation one: run a creative-team pilot, using Kotter-style steps. The owner would be your creative leadership, supported by the data team. The evidence is Kotter (1995) on managing change and Napoli (2014) on the effects of algorithms on media production. It follows from the analysis on slides 6 and 7. Success means creative-team trust in the tool, and use of the data check in pitches, after one slate.
+Recommendation two: add an explanation feature for recommendations. The owner would be marketing, working with product and technology teams. The evidence is Floridi et al. (2018) on explicability, and your own privacy documentation (Apple Inc., 2025). It follows from slides 4 and 9. Success means how many viewers use the feature.
+Recommendation three: set up a governance review of purpose limitation and diversity auditing. The owner would be operations, covering legal and compliance. The evidence is GDPR Article 5 (European Parliament and Council, 2016) and Ricci, Rokach and Shapira (2015) on narrowing. It follows from slides 5 and 9. Success means audit results each quarter.
+What should come first? The creative-team pilot. It tackles your central challenge of using data without limiting creativity, and it builds the evidence the other two depend on. The governance review should run alongside it, because the pilot will use viewer data and the rules need to be in place.
+That is what I am asking you to approve today.
+As a suggested sequence, the pilot design and the governance review would begin together, with the pilot running on one slate before any wider roll-out. The explanation feature would follow, informed by what the pilot teaches you about how viewers and creatives respond to seeing the reasoning behind a recommendation. Each stage reports back to leadership, so you can decide at each point whether to extend, adjust or pause.</a:t>
             </a:r>
             <a:endParaRPr lang="en-US" dirty="0"/>
           </a:p>
@@ -699,11 +698,14 @@
           <a:p>
             <a:r>
               <a:rPr lang="en-US" dirty="0"/>
-              <a:t>[About 0:40]
-Task 1: a machine-learning recommendation engine helps match a small catalogue to many viewers, but it protects Apple TV+'s position rather than creating a lead.
-Task 2: creative teams, the group I assessed, can protect originality while adopting data if a Kotter-style change plan is used.
-Task 3: rivals can copy the technology, so advantage depends on ecosystem, creative judgement and ethical safeguards.
-Close: used with creative teams at its side, the engine can help Apple TV+ keep subscribers without giving up the originality it is known for.</a:t>
+              <a:t>To bring this together.
+On technology, a machine-learning recommendation engine helps match your small catalogue to many viewers. But your rivals have similar technology, so it protects your position rather than creating a lead.
+On people, your creative teams can protect originality while adopting data, provided you use a structured change plan like Kotter's and keep creative sign-off final.
+On strategy, rivals can copy the technology, so lasting advantage depends on your ecosystem, your creative judgement and strong ethical safeguards.
+My three recommendations, in one line each: run a pilot with your creative teams, add explanations for why content is recommended, and review purpose limitation and diversity audits regularly.
+Used with creative teams at its side, the recommendation engine can help Apple TV+ keep its subscribers without giving up the originality that sets you apart.
+The central point is that data and creativity do not have to be opposed. With the right governance, a clear change plan and creative teams involved from the start, the technology can support your strategy and not cut across it.
+Thank you. I am happy to take questions.</a:t>
             </a:r>
             <a:endParaRPr lang="en-US" dirty="0"/>
           </a:p>
@@ -879,13 +881,13 @@
           <a:p>
             <a:r>
               <a:rPr lang="en-US" dirty="0"/>
-              <a:t>[About 1:00]
-Apple TV+ is an original-content service. It competes on the quality of its programmes, not the size of its library, so every title matters more. Its strategy is the Apple ecosystem: content integrated across iPhone, iPad and other devices (Apple brief).
-The challenge I chose from the brief: using data to improve recommendations without limiting creativity.
-Why it matters: retention, competition with Netflix, Prime Video and Disney+, and the tension between creative and data-driven teams.
-Evidence: Antenna (2024) reports 37.2% of Apple TV+ gross additions were returning subscribers who had cancelled within the prior 12 months, the highest serial-churn rate in the industry. Industry-wide, monthly churn across major US services rose from 5.1% to 6.3% between November 2022 and November 2023 (Antenna, as reported by ABC News).
-So what: Reichheld (2003) shows keeping a customer is cheaper than winning a new one, so churn is a cost problem for leadership, not just a marketing metric.
-Next: the technology I propose.</a:t>
+              <a:t>Let me start with where Apple TV+ stands. You offer original films, series and documentaries to a global audience, and you compete on the quality of that content, not on library size. That makes every title count for more. When a service has fewer titles, a programme that viewers never find is a bigger loss.
+Quality-led positioning also raises the stakes for how that content is surfaced. A subscriber who opens the app and sees nothing of interest will not blame the catalogue size. They will simply conclude that the service has little for them, and that is a retention risk.
+Your wider strategy places Apple TV+ inside the Apple ecosystem, with content integrated across iPhone, iPad and other Apple products. Subscribers expect a seamless experience, and a viewer who starts a series on one device expects the service to remember them on the next.
+The challenge I have chosen to address is using data to improve recommendations without limiting creativity. It matters for three reasons. First, retention. Second, competition with Netflix, Prime Video and Disney+. Third, a tension inside the organisation: your creative teams are concerned that too much reliance on data could affect originality, while marketing supports data-driven insight but knows that customers can be sensitive to pricing and content changes.
+The data on this slide shows why retention is urgent. Antenna (2024) reports that 37.2% of Apple TV+'s gross subscriber additions were returning subscribers who had cancelled within the prior 12 months, the highest serial-churn rate in the industry. For wider context, monthly churn across major US streaming services rose from 5.1% in November 2022 to 6.3% in November 2023, as reported by ABC News using Antenna data. That industry figure is background and is not specific to Apple TV+.
+The cost is real. Reichheld (2003) shows that keeping an existing customer is cheaper than winning a new one, so churn is a financial problem for you, not only a marketing metric.
+Next, the technology I recommend.</a:t>
             </a:r>
             <a:endParaRPr lang="en-US" dirty="0"/>
           </a:p>
@@ -973,12 +975,14 @@
           <a:p>
             <a:r>
               <a:rPr lang="en-US" dirty="0"/>
-              <a:t>[About 0:50]
-In plain terms: a machine-learning recommendation engine learns from what viewers do and predicts what each viewer will want next. Resnick and Varian (1997) describe recommender systems as helping people choose among many options using patterns in other people's choices.
-Walk the diagram left to right. Input: viewing history, search queries and behaviour signals such as pauses and rewinds. Process: machine learning finds patterns. Output: a personalised home screen.
-Evidence: Netflix is the best-documented case. Gomez-Uribe and Hunt (2015) estimate its recommender is worth over $1 billion a year in retained subscribers. Note this is Netflix, not Apple, so it shows the potential rather than guaranteeing the result.
-Apple's own privacy documentation says data is collected "to tailor features and offer personalised recommendations" (Apple Inc., 2025).
-Next: how it helps with our challenge.</a:t>
+              <a:t>The technology I recommend is a machine-learning recommendation engine. In plain terms, it is software that learns from what your subscribers do and predicts what each will want to watch next. Resnick and Varian (1997) describe recommender systems as helping people choose among many options by drawing on the patterns in other people's choices.
+Figure 1 shows the flow. On the input side, the engine takes in viewing history, search queries and behavioural signals such as pauses and rewinds. In the process stage, machine learning finds patterns in that data and predicts what a viewer is likely to want. The output is a personalised home screen and "what to watch next" suggestions.
+I chose this technology for two reasons. It speaks directly to your challenge, and it fits your ecosystem strategy. Your subscribers move between devices, so the more consistently the service understands them, the more seamless the experience becomes.
+I also considered where your challenge actually sits. It sits in the link between your content and each viewer, and that is the point where a recommendation engine operates. Technologies that change how content is produced would not address it. This one works on data you already collect, which makes it practical to start with.
+The best-documented example is Netflix. Gomez-Uribe and Hunt (2015) describe how Netflix personalises rows and titles for each member and estimate that its recommender is worth over a billion dollars a year in retained subscribers. I want to be careful with that. It is evidence about Netflix, not Apple TV+, so it shows what is possible, not what you will achieve.
+It is also worth noting that machine-learning recommendation is now an established technology, but it is still developing, particularly in how it handles context and explanation. That is why the way you deploy it matters more than the fact that you deploy it.
+You are already open about this use of data. Apple's privacy documentation says viewing and activity data is collected "to tailor features and offer personalised recommendations" (Apple Inc., 2025). So this technology builds on a stated practice and does not introduce a hidden one.
+Next, how it helps with your challenge.</a:t>
             </a:r>
             <a:endParaRPr lang="en-US" dirty="0"/>
           </a:p>
@@ -1066,13 +1070,14 @@
           <a:p>
             <a:r>
               <a:rPr lang="en-US" dirty="0"/>
-              <a:t>[About 0:50]
-How it helps: Apple TV+ has a small, high-quality catalogue. The engine matches it to millions of different viewers, so good originals are found rather than buried.
-Porter's Five Forces (Porter, 2008): two forces change most.
-Rivalry: better discovery raises the value of each subscription, but Netflix, Prime Video and Disney+ run similar engines, so it protects our position rather than creating a lead.
-Buyer power: switching costs are low. The high serial-churn figure on slide 2 is evidence that subscribers leave and return easily. A profile that has learned someone's taste adds only a small cost to leaving.
-The creativity side: the engine can steer which content is promoted. That is where creative teams' concern comes from.
-Next: weighing benefits against limitations.</a:t>
+              <a:t>The engine helps by matching content to viewers at scale. You have a small, high-quality catalogue. The engine can match it to millions of different subscribers, so good originals are found and not buried. The flow on the left shows the chain: viewing data feeds the engine, the engine builds a tailored home screen, and that supports retention against rivals.
+The ecosystem strengthens this. Because your subscribers use several Apple devices, the engine has more signals to learn from and more places to put a relevant suggestion in front of them. Marketing also benefits, because it can see which content is resonating, although I recommend that this insight informs promotion without replacing editorial judgement.
+To test the strategic effect, I used Porter's Five Forces (Porter, 2008), shown in Figure 2. The recommender changes two forces most.
+The first is rivalry with Netflix, Prime Video and Disney+. Better discovery raises the value of each subscription, which helps you. But those rivals run similar engines, so the technology protects your position rather than giving you a lead.
+The second is buyer power, meaning how easily subscribers can switch. Switching costs are low, and the serial-churn figure on slide 2 shows subscribers leaving and returning easily (Antenna, 2024). A profile that has learned someone's taste adds a small cost to leaving, so the engine nudges switching costs up, but it does not solve the problem.
+Now the creativity side, which I know is your leadership's main concern. The same engine that matches content can also steer which content is promoted. If it mainly promotes what is already popular or familiar, it could crowd out new and unusual ideas, and over time influence what gets commissioned. That is where your creative teams' concern comes from, and I take it seriously.
+My message is that the technology is worth using, but the creative concern needs to be managed deliberately. I come back to how in the next section.
+Next, the benefits and limitations side by side.</a:t>
             </a:r>
             <a:endParaRPr lang="en-US" dirty="0"/>
           </a:p>
@@ -1160,12 +1165,14 @@
           <a:p>
             <a:r>
               <a:rPr lang="en-US" dirty="0"/>
-              <a:t>[About 1:00]
-Benefits, each sourced. Discovery: Gracenote (2025) found 49% of viewers say they are likely to cancel if they cannot find something to watch. Engagement and retention: Gomez-Uribe and Hunt (2015) and Reichheld (2003).
-Limitations. Narrowing and data quality: Ricci, Rokach and Shapira (2015). Reduced diversity: Helberger (2019). Possible loss of creative originality: Napoli (2014). Privacy, governance and bias when AI is scaled: Mokoena and Obagbuwa (2025).
-Weigh them: for Apple TV+ the most important benefit is discovery, because a small catalogue only pays off if each show is found. The most important limitation is creative originality, because Apple competes on quality.
-Conclusion: personalisation is necessary but not sufficient. Its benefits depend on managing these limits.
-Next: what this means for the people who make the content.</a:t>
+              <a:t>Table 1 sets out three benefits and five limitations, each with a source.
+The benefits. First, discovery: Gracenote (2025) found that 49% of viewers say they are likely to cancel a streaming service if they cannot find something to watch. Second, engagement: Gomez-Uribe and Hunt (2015) describe how personalised rows and titles increase viewing. Third, retention: better discovery reduces cancellations, which connects to Reichheld (2003) on the cost of losing customers.
+The limitations. Narrowing: models reinforce what viewers have already watched, so recommendations narrow over time (Ricci, Rokach and Shapira, 2015). Reduced diversity: personalised feeds can limit exposure to varied content (Helberger, 2019). Possible loss of creative originality: data-led promotion can favour familiar formats over new ideas (Napoli, 2014). Data quality: the output depends on the quality of the data and signals behind it (Ricci, Rokach and Shapira, 2015). And privacy and governance: scaling AI adds privacy risk, governance demands and algorithmic bias that can limit content diversity (Mokoena and Obagbuwa, 2025).
+For Apple TV+, the benefit that matters most is discovery, because a small catalogue only pays off if each show is found. The limitation that matters most is creative originality, because quality is your point of difference.
+I should be open about the strength of this evidence. The Gracenote figure is stated intent, not recorded cancellations. Gomez-Uribe and Hunt (2015) describes Netflix. And Mokoena and Obagbuwa (2025) is a review of AI in music streaming, so I use it for its findings on risks, not as proof about video services.
+My conclusion is that personalisation is necessary but not sufficient. Its benefits depend on managing these limits.
+There is also an interaction between the two lists that is worth noting. Narrowing, if left unchecked, can undermine the very discovery benefit that justifies the investment, because viewers see more of the same and less of what is new. That is why the limitations are not an afterthought. They are part of whether the benefit lasts.
+Next, what this means for the people who make your content.</a:t>
             </a:r>
             <a:endParaRPr lang="en-US" dirty="0"/>
           </a:p>
@@ -1253,11 +1260,17 @@
           <a:p>
             <a:r>
               <a:rPr lang="en-US" dirty="0"/>
-              <a:t>[About 1:00]
-Personalisation at this scale does not only change what customers see; it also changes how creative teams decide what gets made.
-Stakeholder group I chose: creative teams, meaning writers, producers and content developers. Their concern, from the brief: too much reliance on data could affect originality. Structure, culture and process influence one another. Structure: who decides what gets made. Culture: creative autonomy versus data-driven decisions; if teams see data as a verdict, they will resist (Napoli, 2014). Process: pitches and green-lighting. If the process keeps creative sign-off final, the culture is more likely to accept the tool.
-TAM (Davis, 1989): is it useful and easy to use? Useful if it shows which audiences a pitch could reach; easy only if insights are in plain language and built into the pitch workflow.
-Next: the barriers and how to manage them.</a:t>
+              <a:t>Personalisation at this scale does not only change what subscribers see. It also changes how your creative teams decide what gets made.
+I have focused on your creative teams: writers, producers and content developers. I chose them because they are the group most directly exposed to this technology, and because their concern is clear: too much reliance on data could affect originality.
+I looked at three areas, structure, culture and process, and the important point is that they influence each other.
+Structure is about who decides what gets made. Data should inform commissioning, not replace the judgement of your commissioning executives and creators.
+Culture is about creative autonomy versus data-driven decisions. If teams see data as a verdict on their ideas, they will resist it. If they see it as a tool, they are more likely to use it. Napoli (2014) discusses how algorithms are shaping media production and audiences, which is exactly the context creative teams are worried about.
+Process covers green-lighting and content pitches. I propose adding a data check to pitches while keeping creative sign-off at the final step.
+The three are linked. If the process keeps creative sign-off final, the culture is more likely to accept the tool. If the culture accepts it, the structure can use data without conflict. If decisions drift towards data, culture suffers and resistance grows. So any change to one has to take account of the others.
+I also looked at adoption through the Technology Acceptance Model (Davis, 1989), which asks whether people find a tool useful and easy to use. Your creative teams would find it useful if it shows which audiences a pitch could reach. They would find it easy to use only if insights come in plain language and fit the existing pitch workflow. If either is missing, adoption will be weak.
+So their concern is addressed by design: creative sign-off stays final, data is input and not instruction, and the tool fits how they already work.
+I recognise that marketing and operations also have views on this change. Marketing supports data-driven insight, and operations focus on service reliability, legal requirements and supporting employees. I have focused on creative teams because their concern goes to the heart of your challenge, but the governance review in my third recommendation also addresses the operations perspective.
+Next, the barriers and how to manage the change.</a:t>
             </a:r>
             <a:endParaRPr lang="en-US" dirty="0"/>
           </a:p>
@@ -1345,11 +1358,14 @@
           <a:p>
             <a:r>
               <a:rPr lang="en-US" dirty="0"/>
-              <a:t>[About 1:00]
-Barriers: fear of losing creative control, distrust of algorithms, and skills gaps. The main barrier is visibility: creative teams cannot see how data influences decisions.
-Responses: keep creative sign-off final and publish rules for data use; show why content is promoted so creatives can see the reasoning; train people on real projects (Vial, 2019).
-Change model: Kotter (1995), condensed from eight steps to six for Apple TV+. Urgency from churn and rivals; a coalition of creative champions and data leads; a vision that data informs and creatives decide; a pilot on one slate of originals with early wins shared; extension into pitches and green-lighting; and embedding in how Apple TV+ commissions.
-Next: does this give lasting advantage?</a:t>
+              <a:t>This slide covers the barriers, how to manage them, and the change plan.
+I see three main barriers. The first is fear of losing creative control. The response is to keep creative sign-off final and publish clear rules for how data is used. The second is distrust of algorithms. The core issue is visibility: creative teams cannot see how data influences decisions. The response is to show why content is promoted, so creatives can follow the reasoning. The third is skills gaps. The response is training built around real projects, in line with Vial (2019) on the capabilities organisations need for digital transformation.
+For the change plan I recommend Kotter (1995), condensed from eight steps to six for Apple TV+ and shown in Figure 4. Step one, urgency: churn and rivals make better discovery pressing. Step two, a coalition of creative champions and data leads. Step three, a vision that data informs and creatives decide. Step four, a pilot on one slate of originals, with early wins shared. Step five, extending the approach into pitches and green-lighting. Step six, embedding it in how you commission.
+To build digital confidence, I recommend four actions: training for writers and producers, pilots on a small slate of originals, creative champions on each team, and feedback channels into the model team. The feedback channels let creatives shape the system and not just receive it.
+To know whether it is working, I suggest three pilot measures: a creative-team survey on trust in the tool, the number of pitches using the data check, and whether discovery of original titles improves. Because Apple TV+ is a global platform, I would extend it region by region once the pilot has shown results.
+This is a change in how people work, so the plan is designed to bring creative teams into shaping the technology.
+Some resistance is natural and should be expected. Treating it as useful feedback and not as an obstacle is part of what makes change last. Kotter (1995) stresses the value of early visible wins, which is why the pilot is small and focused. A successful first slate gives sceptical colleagues evidence in place of assurances.
+Next, whether it gives you lasting advantage.</a:t>
             </a:r>
             <a:endParaRPr lang="en-US" dirty="0"/>
           </a:p>
@@ -1437,15 +1453,17 @@
           <a:p>
             <a:r>
               <a:rPr lang="en-US" dirty="0"/>
-              <a:t>[About 1:00]
-VRIO (Barney, 1991), applied honestly.
-Valuable: yes. Better discovery supports retention and agility, but scaling AI brings privacy, governance and bias risks.
-Rare: no. Streaming rivals already run recommenders and the technique is widely documented (Ricci et al., 2015).
-Hard to imitate: partly. Models are copyable. Apple's ecosystem data and quality-focused catalogue are harder to copy; this is my judgement, not a measured finding.
-Organised to exploit: not yet. The brief shows creative, marketing and operations teams hold different views, so there are no shared rules for how data shapes commissioning. This is my inference from the brief.
-Verdict: competitive parity, not sustained advantage. As models converge, accuracy alone differentiates little.
-Continuous improvement: A/B testing gives agility; creative input into the goals the model optimises supports innovation; regular data and model refresh keeps it current. Ansoff (1957): this is market penetration, deepening retention in existing markets, rather than a new product.
-Next: the risks that come with it.</a:t>
+              <a:t>The strategic question is whether this technology gives you a sustained competitive advantage. I applied the VRIO framework (Barney, 1991), shown in Table 2, and I have tried to be direct about where it falls short.
+Valuable: yes. Better discovery supports retention and agility, meaning the ability to test and adjust quickly. But scaling AI brings privacy, governance and bias risks (Mokoena and Obagbuwa, 2025).
+Rare: no. Your rivals already run recommendation engines, and the technique is widely documented (Ricci, Rokach and Shapira, 2015).
+Hard to imitate: partly. The models can be copied. Your ecosystem data and quality-focused catalogue are harder to copy. That is my judgement and not a measured finding.
+Organised to exploit: not yet. From what I understand, creative, marketing and operations teams hold different views, and there are no shared rules yet for how data shapes commissioning. That is my assessment of where you are today.
+My verdict is competitive parity, not sustained advantage. As machine-learning capabilities converge across the market, accuracy alone differentiates very little. The recommender is a necessary baseline, and advantage comes from pairing it with your ecosystem and your creative judgement.
+I would also add that engagement does not automatically produce retention. A subscriber can watch a lot and still cancel if the service does not feel worth the price. That is my own reasoning, and it is another reason accuracy alone will not win.
+To keep improving, I recommend four things. First, A/B test changes against retention, which supports agility. Second, bring creatives into the model, helping to set the goals it optimises, which supports innovation. Third, refresh data and models regularly so the system does not go stale. Fourth, in Ansoff's terms (Ansoff, 1957), this is market penetration: deepening retention in your existing markets, not launching a new product.
+Technology alone will not win. The organisation has to be ready to use it.
+In practice, that means the continuous improvement actions should run on a regular cycle, with results reported to leadership. If testing shows a change improves retention but reduces the variety of what is promoted, creative leadership should have the right to adjust the model's goals. That keeps agility and originality working together.
+Next, the risks.</a:t>
             </a:r>
             <a:endParaRPr lang="en-US" dirty="0"/>
           </a:p>
@@ -1533,13 +1551,16 @@
           <a:p>
             <a:r>
               <a:rPr lang="en-US" dirty="0"/>
-              <a:t>[About 0:50]
-Risks, ranked by impact for Apple TV+, with a principle and mitigation for each.
-Privacy: data collected for recommendations could be reused for other purposes. GDPR Article 5 requires specified, explicit purposes (European Parliament and Council, 2016) and applies to subscribers in the EU. Mitigation: document and review purpose limitation. This also protects Apple's brand.
-Bias and fairness: models trained on past viewing narrow what is shown (Ricci et al., 2015). Mitigation: regular diversity audits.
-Transparency: viewers and creatives cannot see why content is promoted. Mitigation: 'why am I seeing this' explanations.
-Creators' autonomy: algorithms can steer which projects are promoted and made (Napoli, 2014). Mitigation: keep creative sign-off.
-Next: what I recommend.</a:t>
+              <a:t>Table 3 sets out five issues. For each I show why it matters, the ethical principle involved, and a mitigation. I have ordered them by likely impact on Apple TV+.
+Privacy comes first. Data collected for recommendations could be reused for other purposes. GDPR Article 5 requires personal data to be collected for specified, explicit purposes (European Parliament and Council, 2016), and it applies to your subscribers in the EU. The mitigation is to document the purpose and review it regularly. This also protects your brand.
+Bias and fairness. Models trained on past viewing narrow what subscribers are shown (Ricci, Rokach and Shapira, 2015). The principle is fairness, and the mitigation is regular diversity-of-recommendation audits.
+Transparency. Viewers and creatives cannot see why content is promoted. The principle is transparency, and the mitigation is "why am I seeing this" explanations for both groups.
+Creators' autonomy. Algorithms can steer which projects are promoted and made (Napoli, 2014). The principle is autonomy, and the mitigation is to keep creative sign-off, using data to inform and not to decide.
+Finally, the social issue of cultural diversity and filter bubbles. Personalised feeds can reduce exposure to varied content (Pariser, 2011; Helberger, 2019). The principle is diversity, and the mitigation is to set minimum exposure for varied and local content.
+These principles draw on the ethical framework in Floridi et al. (2018), which includes autonomy, fairness and explicability.
+These risks are manageable, but only if the controls are built in from the start.
+I have put privacy first because it carries legal exposure and could affect trust in your brand. Bias, transparency and autonomy are closely linked to the creative concern at the heart of this challenge. The social issue of diversity is longer term, but it affects the kind of content culture the service helps to shape.
+Next, my recommendations.</a:t>
             </a:r>
             <a:endParaRPr lang="en-US" dirty="0"/>
           </a:p>
@@ -2254,7 +2275,7 @@
                 <a:ea typeface="Calibri" pitchFamily="34" charset="-122"/>
                 <a:cs typeface="Calibri" pitchFamily="34" charset="-120"/>
               </a:rPr>
-              <a:t>Task 3</a:t>
+              <a:t>Strategy</a:t>
             </a:r>
             <a:endParaRPr lang="en-US" sz="1100" dirty="0"/>
           </a:p>
@@ -3245,7 +3266,7 @@
                 <a:ea typeface="Calibri" pitchFamily="34" charset="-122"/>
                 <a:cs typeface="Calibri" pitchFamily="34" charset="-120"/>
               </a:rPr>
-              <a:t>Task 1</a:t>
+              <a:t>Technology</a:t>
             </a:r>
             <a:endParaRPr lang="en-US" sz="1500" dirty="0"/>
           </a:p>
@@ -3362,7 +3383,7 @@
                 <a:ea typeface="Calibri" pitchFamily="34" charset="-122"/>
                 <a:cs typeface="Calibri" pitchFamily="34" charset="-120"/>
               </a:rPr>
-              <a:t>Creative teams, the group assessed, can protect originality while adopting data if a Kotter-style change plan is used.</a:t>
+              <a:t>Creative teams, the group analysed, can protect originality while adopting data if a Kotter-style change plan is used.</a:t>
             </a:r>
             <a:endParaRPr lang="en-US" sz="1400" dirty="0"/>
           </a:p>
@@ -4450,7 +4471,7 @@
                 <a:ea typeface="Calibri" pitchFamily="34" charset="-122"/>
                 <a:cs typeface="Calibri" pitchFamily="34" charset="-120"/>
               </a:rPr>
-              <a:t>Our challenge</a:t>
+              <a:t>The challenge</a:t>
             </a:r>
             <a:endParaRPr lang="en-US" sz="1500" dirty="0"/>
           </a:p>
@@ -4860,7 +4881,7 @@
                 <a:ea typeface="Calibri" pitchFamily="34" charset="-122"/>
                 <a:cs typeface="Calibri" pitchFamily="34" charset="-120"/>
               </a:rPr>
-              <a:t>Task 1</a:t>
+              <a:t>Technology</a:t>
             </a:r>
             <a:endParaRPr lang="en-US" sz="1100" dirty="0"/>
           </a:p>
@@ -5509,7 +5530,7 @@
                 <a:ea typeface="Calibri" pitchFamily="34" charset="-122"/>
                 <a:cs typeface="Calibri" pitchFamily="34" charset="-120"/>
               </a:rPr>
-              <a:t>Task 1</a:t>
+              <a:t>Technology</a:t>
             </a:r>
             <a:endParaRPr lang="en-US" sz="1100" dirty="0"/>
           </a:p>
@@ -6519,7 +6540,7 @@
                 <a:ea typeface="Calibri" pitchFamily="34" charset="-122"/>
                 <a:cs typeface="Calibri" pitchFamily="34" charset="-120"/>
               </a:rPr>
-              <a:t>Task 1</a:t>
+              <a:t>Technology</a:t>
             </a:r>
             <a:endParaRPr lang="en-US" sz="1100" dirty="0"/>
           </a:p>
@@ -7479,7 +7500,7 @@
                 <a:ea typeface="Calibri" pitchFamily="34" charset="-122"/>
                 <a:cs typeface="Calibri" pitchFamily="34" charset="-120"/>
               </a:rPr>
-              <a:t>Task 2</a:t>
+              <a:t>People and change</a:t>
             </a:r>
             <a:endParaRPr lang="en-US" sz="1100" dirty="0"/>
           </a:p>
@@ -8174,7 +8195,7 @@
                 <a:ea typeface="Calibri" pitchFamily="34" charset="-122"/>
                 <a:cs typeface="Calibri" pitchFamily="34" charset="-120"/>
               </a:rPr>
-              <a:t>Task 2</a:t>
+              <a:t>People and change</a:t>
             </a:r>
             <a:endParaRPr lang="en-US" sz="1100" dirty="0"/>
           </a:p>
@@ -9392,7 +9413,7 @@
                 <a:ea typeface="Calibri" pitchFamily="34" charset="-122"/>
                 <a:cs typeface="Calibri" pitchFamily="34" charset="-120"/>
               </a:rPr>
-              <a:t>Task 3</a:t>
+              <a:t>Strategy</a:t>
             </a:r>
             <a:endParaRPr lang="en-US" sz="1100" dirty="0"/>
           </a:p>
@@ -11014,7 +11035,7 @@
                 <a:ea typeface="Calibri" pitchFamily="34" charset="-122"/>
                 <a:cs typeface="Calibri" pitchFamily="34" charset="-120"/>
               </a:rPr>
-              <a:t>Task 3</a:t>
+              <a:t>Strategy</a:t>
             </a:r>
             <a:endParaRPr lang="en-US" sz="1100" dirty="0"/>
           </a:p>

</xml_diff>

<commit_message>
Expand speaker notes with critical analysis tied to theory and sources
Co-Authored-By: Claude Sonnet 5.5 <noreply@anthropic.com>
Claude-Session: https://claude.ai/code/session_01Ha62b6Wcst3n47bFqEFLKV
</commit_message>
<xml_diff>
--- a/Earning-the-Signal_revised.pptx
+++ b/Earning-the-Signal_revised.pptx
@@ -515,8 +515,9 @@
               <a:rPr lang="en-US" dirty="0"/>
               <a:t>Good morning, and thank you for your time. I am your Digital Transformation Consultant, and today I will set out how a machine-learning recommendation engine could help Apple TV+ use data to improve what your subscribers watch, without limiting the creativity that defines the service. [SRN: add SRN.]
 The presentation has three parts. First, the technology: how it works, how it addresses your challenge, and its benefits and limitations. Second, the impact on your creative teams, and how to manage the change. Third, the strategic implications, including whether it can give you lasting advantage, the ethical and risk issues, and three recommendations.
-At the end I will ask you to approve three actions, and I will tell you which should come first.
-Everything I present draws on published research and industry sources, which are listed on the final slide. Where a point is my own judgement and not a measured finding, I will say so.</a:t>
+I use established frameworks where each one answers a specific question. Porter's Five Forces tests the competitive effect. The Technology Acceptance Model tests whether creative teams will adopt the tool. Kotter's change model structures the change. VRIO tests whether the advantage lasts. Ansoff places the move strategically, and the ethical framework in Floridi and colleagues tests the risks.
+Everything I present draws on published research and industry sources, which are listed on the final slide. Where a point is my own judgement and not a measured finding, I will say so.
+At the end I will ask you to approve three actions, and I will tell you which should come first.</a:t>
             </a:r>
             <a:endParaRPr lang="en-US" dirty="0"/>
           </a:p>
@@ -604,13 +605,14 @@
           <a:p>
             <a:r>
               <a:rPr lang="en-US" dirty="0"/>
-              <a:t>I recommend three actions. Each has an owner, evidence, and a link back to the analysis.
-Recommendation one: run a creative-team pilot, using Kotter-style steps. The owner would be your creative leadership, supported by the data team. The evidence is Kotter (1995) on managing change and Napoli (2014) on the effects of algorithms on media production. It follows from the analysis on slides 6 and 7. Success means creative-team trust in the tool, and use of the data check in pitches, after one slate.
-Recommendation two: add an explanation feature for recommendations. The owner would be marketing, working with product and technology teams. The evidence is Floridi et al. (2018) on explicability, and your own privacy documentation (Apple Inc., 2025). It follows from slides 4 and 9. Success means how many viewers use the feature.
-Recommendation three: set up a governance review of purpose limitation and diversity auditing. The owner would be operations, covering legal and compliance. The evidence is GDPR Article 5 (European Parliament and Council, 2016) and Ricci, Rokach and Shapira (2015) on narrowing. It follows from slides 5 and 9. Success means audit results each quarter.
+              <a:t>I recommend three actions. Each has an owner, evidence, and a link back to the analysis, and each is a practical response to a specific finding.
+Recommendation one: run a creative-team pilot, using Kotter-style steps. The owner would be your creative leadership, supported by the data team. The evidence is Kotter (1995) on managing change and Napoli (2014) on how algorithms can reshape media production. It follows from the analysis on slides 6 and 7. It responds to the barrier of fear of losing control and to the finding that usefulness drives adoption (Davis, 1989). Success means creative-team trust in the tool, and use of the data check in pitches, after one slate.
+Recommendation two: add an explanation feature for recommendations. The owner would be marketing, working with product and technology teams. The evidence is Floridi et al. (2018) on explicability, and your own privacy documentation (Apple Inc., 2025). It follows from slides 4 and 9. It responds to distrust of algorithms and to the transparency risk. Success means how many viewers use the feature. I would be open about its limits: an explanation is a simplified account of a complex model.
+Recommendation three: set up a governance review of purpose limitation and diversity auditing. The owner would be operations, covering legal and compliance. The evidence is GDPR Article 5 (European Parliament and Council, 2016) and Ricci, Rokach and Shapira (2015) on narrowing. It follows from slides 5 and 9. It responds to the privacy and bias risks, and it also supports the VRIO finding that you are not yet organised to exploit the technology. Success means audit results each quarter.
 What should come first? The creative-team pilot. It tackles your central challenge of using data without limiting creativity, and it builds the evidence the other two depend on. The governance review should run alongside it, because the pilot will use viewer data and the rules need to be in place.
-That is what I am asking you to approve today.
-As a suggested sequence, the pilot design and the governance review would begin together, with the pilot running on one slate before any wider roll-out. The explanation feature would follow, informed by what the pilot teaches you about how viewers and creatives respond to seeing the reasoning behind a recommendation. Each stage reports back to leadership, so you can decide at each point whether to extend, adjust or pause.</a:t>
+As a suggested sequence, the pilot design and the governance review would begin together, with the pilot running on one slate before any wider roll-out. The explanation feature would follow, informed by what the pilot teaches you about how viewers and creatives respond to seeing the reasoning behind a recommendation. Each stage reports back to leadership, so you can decide at each point whether to extend, adjust or pause.
+There are risks to implementation itself. A pilot on one slate may not generalise to every region, and creative teams may see the pilot as a first step towards control. That is why the pilot's rules, including creative sign-off, should be published at the start.
+That is what I am asking you to approve today.</a:t>
             </a:r>
             <a:endParaRPr lang="en-US" dirty="0"/>
           </a:p>
@@ -699,12 +701,12 @@
             <a:r>
               <a:rPr lang="en-US" dirty="0"/>
               <a:t>To bring this together.
-On technology, a machine-learning recommendation engine helps match your small catalogue to many viewers. But your rivals have similar technology, so it protects your position rather than creating a lead.
-On people, your creative teams can protect originality while adopting data, provided you use a structured change plan like Kotter's and keep creative sign-off final.
-On strategy, rivals can copy the technology, so lasting advantage depends on your ecosystem, your creative judgement and strong ethical safeguards.
+On technology, a machine-learning recommendation engine helps match your small catalogue to many viewers. Through Porter's lens, it protects your position against Netflix, Prime Video and Disney+ rather than creating a lead. The benefits are real, but so are the limits, especially narrowing and the risk to originality.
+On people, your creative teams can protect originality while adopting data. Technology acceptance depends first on usefulness (Davis, 1989), and change lasts when it follows a structured plan like Kotter's (1995), with creative sign-off kept final.
+On strategy, rivals can copy the technology, so under VRIO it gives parity, and lasting advantage depends on your ecosystem, your creative judgement and strong ethical safeguards (Barney, 1991; Floridi et al., 2018).
 My three recommendations, in one line each: run a pilot with your creative teams, add explanations for why content is recommended, and review purpose limitation and diversity audits regularly.
+The central point is that data and creativity do not have to be opposed. With the right governance, a clear change plan and creative teams involved from the start, the technology can support your strategy and not cut across it.
 Used with creative teams at its side, the recommendation engine can help Apple TV+ keep its subscribers without giving up the originality that sets you apart.
-The central point is that data and creativity do not have to be opposed. With the right governance, a clear change plan and creative teams involved from the start, the technology can support your strategy and not cut across it.
 Thank you. I am happy to take questions.</a:t>
             </a:r>
             <a:endParaRPr lang="en-US" dirty="0"/>
@@ -883,10 +885,12 @@
               <a:rPr lang="en-US" dirty="0"/>
               <a:t>Let me start with where Apple TV+ stands. You offer original films, series and documentaries to a global audience, and you compete on the quality of that content, not on library size. That makes every title count for more. When a service has fewer titles, a programme that viewers never find is a bigger loss.
 Quality-led positioning also raises the stakes for how that content is surfaced. A subscriber who opens the app and sees nothing of interest will not blame the catalogue size. They will simply conclude that the service has little for them, and that is a retention risk.
-Your wider strategy places Apple TV+ inside the Apple ecosystem, with content integrated across iPhone, iPad and other Apple products. Subscribers expect a seamless experience, and a viewer who starts a series on one device expects the service to remember them on the next.
+Your wider strategy places Apple TV+ inside the Apple ecosystem, with content integrated across iPhone, iPad and other Apple products. This matters for the analysis because the technology operates within your organisation and across your products and devices. Subscribers expect a seamless experience, and a viewer who starts a series on one device expects the service to remember them on the next.
+I find it useful to read this through the lens of digital transformation. Vial (2019) describes digital transformation as a process in which digital technologies create disruption that prompts organisations to respond strategically. Streaming competition and subscriber volatility are that disruption, and a recommendation engine is one strategic response.
 The challenge I have chosen to address is using data to improve recommendations without limiting creativity. It matters for three reasons. First, retention. Second, competition with Netflix, Prime Video and Disney+. Third, a tension inside the organisation: your creative teams are concerned that too much reliance on data could affect originality, while marketing supports data-driven insight but knows that customers can be sensitive to pricing and content changes.
 The data on this slide shows why retention is urgent. Antenna (2024) reports that 37.2% of Apple TV+'s gross subscriber additions were returning subscribers who had cancelled within the prior 12 months, the highest serial-churn rate in the industry. For wider context, monthly churn across major US streaming services rose from 5.1% in November 2022 to 6.3% in November 2023, as reported by ABC News using Antenna data. That industry figure is background and is not specific to Apple TV+.
-The cost is real. Reichheld (2003) shows that keeping an existing customer is cheaper than winning a new one, so churn is a financial problem for you, not only a marketing metric.
+A critical point on how to read this. Serial churn tells us that subscribers move in and out easily. It does not tell us why. My reading, which is an inference and not a finding, is that with a quality-led, smaller catalogue, many subscribers may join for a particular series and leave once they finish it. If that is right, better recommendations help, but they cannot fully replace a steady flow of new content that gives people a reason to stay.
+The cost is real. Reichheld (2003) links customer loyalty to growth, and keeping existing customers is generally cheaper than winning new ones, so churn is a financial problem for you, not only a marketing metric.
 Next, the technology I recommend.</a:t>
             </a:r>
             <a:endParaRPr lang="en-US" dirty="0"/>
@@ -977,11 +981,12 @@
               <a:rPr lang="en-US" dirty="0"/>
               <a:t>The technology I recommend is a machine-learning recommendation engine. In plain terms, it is software that learns from what your subscribers do and predicts what each will want to watch next. Resnick and Varian (1997) describe recommender systems as helping people choose among many options by drawing on the patterns in other people's choices.
 Figure 1 shows the flow. On the input side, the engine takes in viewing history, search queries and behavioural signals such as pauses and rewinds. In the process stage, machine learning finds patterns in that data and predicts what a viewer is likely to want. The output is a personalised home screen and "what to watch next" suggestions.
-I chose this technology for two reasons. It speaks directly to your challenge, and it fits your ecosystem strategy. Your subscribers move between devices, so the more consistently the service understands them, the more seamless the experience becomes.
-I also considered where your challenge actually sits. It sits in the link between your content and each viewer, and that is the point where a recommendation engine operates. Technologies that change how content is produced would not address it. This one works on data you already collect, which makes it practical to start with.
-The best-documented example is Netflix. Gomez-Uribe and Hunt (2015) describe how Netflix personalises rows and titles for each member and estimate that its recommender is worth over a billion dollars a year in retained subscribers. I want to be careful with that. It is evidence about Netflix, not Apple TV+, so it shows what is possible, not what you will achieve.
-It is also worth noting that machine-learning recommendation is now an established technology, but it is still developing, particularly in how it handles context and explanation. That is why the way you deploy it matters more than the fact that you deploy it.
+In practice, recommender systems usually combine approaches: learning from the behaviour of similar viewers, and learning from the characteristics of the content itself (Ricci, Rokach and Shapira, 2015). That distinction matters for Apple TV+, and I will return to it as a limitation.
+I chose this technology for two reasons. It speaks directly to your challenge, and it fits your ecosystem strategy. Your subscribers move between devices, so the more consistently the service understands them, the more seamless the experience becomes. I also considered where your challenge actually sits. It sits in the link between your content and each viewer, and that is the point where a recommendation engine operates. Technologies that change how content is produced would not address it. This one works on data you already collect, which makes it practical to start with.
+The best-documented example is Netflix. Gomez-Uribe and Hunt (2015) describe how Netflix personalises rows and titles for each member and estimate that its recommender is worth over a billion dollars a year in retained subscribers. I want to be careful with that. It is evidence about Netflix, not Apple TV+, so it shows what is possible, not what you will achieve. Netflix has a much larger catalogue and a much larger volume of viewing data, so the same method may behave differently with a smaller library.
+That leads to a critical point specific to your situation. Recommenders learn from viewing history, but a new original has little or none when it launches. This is the well-known cold-start problem in recommender research (Ricci, Rokach and Shapira, 2015). Because your strategy depends on a steady flow of high-quality originals, the cold-start issue could affect you more than a service with a large back catalogue. This is my application of the research to your case, and it is one reason creative input into the system matters.
 You are already open about this use of data. Apple's privacy documentation says viewing and activity data is collected "to tailor features and offer personalised recommendations" (Apple Inc., 2025). So this technology builds on a stated practice and does not introduce a hidden one.
+Machine-learning recommendation is now an established technology, but it is still developing, particularly in how it handles context and explanation. That is why the way you deploy it matters more than the fact that you deploy it.
 Next, how it helps with your challenge.</a:t>
             </a:r>
             <a:endParaRPr lang="en-US" dirty="0"/>
@@ -1072,9 +1077,10 @@
               <a:rPr lang="en-US" dirty="0"/>
               <a:t>The engine helps by matching content to viewers at scale. You have a small, high-quality catalogue. The engine can match it to millions of different subscribers, so good originals are found and not buried. The flow on the left shows the chain: viewing data feeds the engine, the engine builds a tailored home screen, and that supports retention against rivals.
 The ecosystem strengthens this. Because your subscribers use several Apple devices, the engine has more signals to learn from and more places to put a relevant suggestion in front of them. Marketing also benefits, because it can see which content is resonating, although I recommend that this insight informs promotion without replacing editorial judgement.
-To test the strategic effect, I used Porter's Five Forces (Porter, 2008), shown in Figure 2. The recommender changes two forces most.
-The first is rivalry with Netflix, Prime Video and Disney+. Better discovery raises the value of each subscription, which helps you. But those rivals run similar engines, so the technology protects your position rather than giving you a lead.
-The second is buyer power, meaning how easily subscribers can switch. Switching costs are low, and the serial-churn figure on slide 2 shows subscribers leaving and returning easily (Antenna, 2024). A profile that has learned someone's taste adds a small cost to leaving, so the engine nudges switching costs up, but it does not solve the problem.
+To test the strategic effect, I used Porter's Five Forces (Porter, 2008), shown in Figure 2. Porter's argument is that industry structure, meaning the combination of the five forces, determines how much profit is available to firms. So the right question is not whether the technology is impressive, but whether it changes any of those forces in your favour.
+The first force I highlight is rivalry with Netflix, Prime Video and Disney+. Better discovery raises the value of each subscription, which helps you. But rivalry is most intense where competitors offer similar things, and those rivals run similar engines. So the technology protects your position rather than giving you a lead.
+The second is buyer power, meaning how easily subscribers can switch. Porter notes that buyers have more power when switching costs are low. They are low here, and the serial-churn figure on slide 2 shows subscribers leaving and returning easily (Antenna, 2024). A profile that has learned someone's taste adds a small cost to leaving, so the engine nudges switching costs up, but it does not solve the problem.
+I have focused on these two forces because they are where the engine has the clearest effect. I do not claim it changes the threat of new entrants, supplier power or substitutes in any major way. For example, competition for viewers' time from other forms of entertainment is outside what a recommender can influence.
 Now the creativity side, which I know is your leadership's main concern. The same engine that matches content can also steer which content is promoted. If it mainly promotes what is already popular or familiar, it could crowd out new and unusual ideas, and over time influence what gets commissioned. That is where your creative teams' concern comes from, and I take it seriously.
 My message is that the technology is worth using, but the creative concern needs to be managed deliberately. I come back to how in the next section.
 Next, the benefits and limitations side by side.</a:t>
@@ -1166,12 +1172,12 @@
             <a:r>
               <a:rPr lang="en-US" dirty="0"/>
               <a:t>Table 1 sets out three benefits and five limitations, each with a source.
-The benefits. First, discovery: Gracenote (2025) found that 49% of viewers say they are likely to cancel a streaming service if they cannot find something to watch. Second, engagement: Gomez-Uribe and Hunt (2015) describe how personalised rows and titles increase viewing. Third, retention: better discovery reduces cancellations, which connects to Reichheld (2003) on the cost of losing customers.
+The benefits. First, discovery: Gracenote (2025) found that 49% of viewers say they are likely to cancel a streaming service if they cannot find something to watch. Second, engagement: Gomez-Uribe and Hunt (2015) describe how personalised rows and titles increase viewing. Third, retention: better discovery reduces cancellations, which connects to Reichheld (2003) on the link between loyalty and growth.
 The limitations. Narrowing: models reinforce what viewers have already watched, so recommendations narrow over time (Ricci, Rokach and Shapira, 2015). Reduced diversity: personalised feeds can limit exposure to varied content (Helberger, 2019). Possible loss of creative originality: data-led promotion can favour familiar formats over new ideas (Napoli, 2014). Data quality: the output depends on the quality of the data and signals behind it (Ricci, Rokach and Shapira, 2015). And privacy and governance: scaling AI adds privacy risk, governance demands and algorithmic bias that can limit content diversity (Mokoena and Obagbuwa, 2025).
 For Apple TV+, the benefit that matters most is discovery, because a small catalogue only pays off if each show is found. The limitation that matters most is creative originality, because quality is your point of difference.
-I should be open about the strength of this evidence. The Gracenote figure is stated intent, not recorded cancellations. Gomez-Uribe and Hunt (2015) describes Netflix. And Mokoena and Obagbuwa (2025) is a review of AI in music streaming, so I use it for its findings on risks, not as proof about video services.
+I should be open about the strength of this evidence. The Gracenote figure is stated intent, not recorded cancellations, so it shows what viewers say they would do. Gomez-Uribe and Hunt (2015) describes Netflix. Helberger (2019) writes about news recommenders, so applying it to entertainment is my inference. The filter-bubble idea popularised by Pariser (2011) is a useful concept, but it is from a popular book and is debated, so I use it to frame the risk and not as proof of its size. And Mokoena and Obagbuwa (2025) is a review of AI in music streaming, so I use it for its findings on risks, not as proof about video services.
+There is also an interaction between the two lists. Narrowing, if left unchecked, can undermine the very discovery benefit that justifies the investment, because viewers see more of the same and less of what is new. The limitations are not an afterthought. They are part of whether the benefit lasts.
 My conclusion is that personalisation is necessary but not sufficient. Its benefits depend on managing these limits.
-There is also an interaction between the two lists that is worth noting. Narrowing, if left unchecked, can undermine the very discovery benefit that justifies the investment, because viewers see more of the same and less of what is new. That is why the limitations are not an afterthought. They are part of whether the benefit lasts.
 Next, what this means for the people who make your content.</a:t>
             </a:r>
             <a:endParaRPr lang="en-US" dirty="0"/>
@@ -1262,12 +1268,14 @@
               <a:rPr lang="en-US" dirty="0"/>
               <a:t>Personalisation at this scale does not only change what subscribers see. It also changes how your creative teams decide what gets made.
 I have focused on your creative teams: writers, producers and content developers. I chose them because they are the group most directly exposed to this technology, and because their concern is clear: too much reliance on data could affect originality.
-I looked at three areas, structure, culture and process, and the important point is that they influence each other.
+I looked at four things that influence one another: structure, culture, processes, and how the technology is managed. That mutual influence is the key point.
 Structure is about who decides what gets made. Data should inform commissioning, not replace the judgement of your commissioning executives and creators.
-Culture is about creative autonomy versus data-driven decisions. If teams see data as a verdict on their ideas, they will resist it. If they see it as a tool, they are more likely to use it. Napoli (2014) discusses how algorithms are shaping media production and audiences, which is exactly the context creative teams are worried about.
+Culture is about creative autonomy versus data-driven decisions. Napoli (2014) takes an institutional theory perspective on algorithmic media production. The insight is that algorithms do not only support decisions, they can reshape the norms and routines in which decisions are made. For creative teams, that is the real worry: not one recommendation, but a gradual change in what counts as a good idea. If teams see data as a verdict on their ideas, they will resist it. If they see it as a tool, they are more likely to use it.
 Process covers green-lighting and content pitches. I propose adding a data check to pitches while keeping creative sign-off at the final step.
-The three are linked. If the process keeps creative sign-off final, the culture is more likely to accept the tool. If the culture accepts it, the structure can use data without conflict. If decisions drift towards data, culture suffers and resistance grows. So any change to one has to take account of the others.
-I also looked at adoption through the Technology Acceptance Model (Davis, 1989), which asks whether people find a tool useful and easy to use. Your creative teams would find it useful if it shows which audiences a pitch could reach. They would find it easy to use only if insights come in plain language and fit the existing pitch workflow. If either is missing, adoption will be weak.
+Management ties these together through governance: clear rules on how data is used and who can override the model.
+The four are linked. If the process keeps creative sign-off final, the culture is more likely to accept the tool. If the culture accepts it, the structure can use data without conflict. If decisions drift towards data, culture suffers and resistance grows. So any change to one has to take account of the others.
+I also looked at adoption through the Technology Acceptance Model (Davis, 1989), which holds that people's intention to use a technology depends on perceived usefulness and perceived ease of use, with usefulness the stronger influence. Your creative teams would find it useful if it shows which audiences a pitch could reach. They would find it easy to use only if insights come in plain language and fit the existing pitch workflow. Because usefulness matters most, the first step is to show creatives value in their own terms, not to train them on a dashboard.
+Here is a critical limit of that model. TAM focuses on individual perceptions of usefulness and ease of use. It says less about professional identity, power and trust. If creatives resist because they feel their craft is being second-guessed, a simpler interface will not fix it. That is why I pair TAM with a change model and governance that protect creative sign-off.
 So their concern is addressed by design: creative sign-off stays final, data is input and not instruction, and the tool fits how they already work.
 I recognise that marketing and operations also have views on this change. Marketing supports data-driven insight, and operations focus on service reliability, legal requirements and supporting employees. I have focused on creative teams because their concern goes to the heart of your challenge, but the governance review in my third recommendation also addresses the operations perspective.
 Next, the barriers and how to manage the change.</a:t>
@@ -1359,11 +1367,12 @@
             <a:r>
               <a:rPr lang="en-US" dirty="0"/>
               <a:t>This slide covers the barriers, how to manage them, and the change plan.
-I see three main barriers. The first is fear of losing creative control. The response is to keep creative sign-off final and publish clear rules for how data is used. The second is distrust of algorithms. The core issue is visibility: creative teams cannot see how data influences decisions. The response is to show why content is promoted, so creatives can follow the reasoning. The third is skills gaps. The response is training built around real projects, in line with Vial (2019) on the capabilities organisations need for digital transformation.
-For the change plan I recommend Kotter (1995), condensed from eight steps to six for Apple TV+ and shown in Figure 4. Step one, urgency: churn and rivals make better discovery pressing. Step two, a coalition of creative champions and data leads. Step three, a vision that data informs and creatives decide. Step four, a pilot on one slate of originals, with early wins shared. Step five, extending the approach into pitches and green-lighting. Step six, embedding it in how you commission.
+I see three main barriers. The first is fear of losing creative control. The response is to keep creative sign-off final and publish clear rules for how data is used. The second is distrust of algorithms. The core issue is visibility: creative teams cannot see how data influences decisions. The response is to show why content is promoted, so creatives can follow the reasoning. The third is skills gaps. The response is training built around real projects.
+These barriers are typical of digital transformation. Vial (2019) identifies structural changes and organisational barriers, including resistance and capability gaps, as central parts of how organisations transform. So I treat the barriers as a design problem to plan for, not a surprise.
+For the change plan I recommend Kotter (1995), condensed from eight steps to six for Apple TV+ and shown in Figure 4. Kotter argues that transformations fail when organisations skip steps or declare victory too early. Step one, urgency: churn and rivals make better discovery pressing. Step two, a coalition of creative champions and data leads. Step three, a vision that data informs and creatives decide. Step four, a pilot on one slate of originals, with early wins shared. Step five, extending the approach into pitches and green-lighting. Step six, embedding it in how you commission.
+A critical note on the model. Kotter's steps are sequential and fairly top-down, which can sit awkwardly with creative organisations that value autonomy. I address this by putting creative champions in the coalition and building feedback channels into the plan, so the change is shaped with creatives and not only delivered to them.
 To build digital confidence, I recommend four actions: training for writers and producers, pilots on a small slate of originals, creative champions on each team, and feedback channels into the model team. The feedback channels let creatives shape the system and not just receive it.
 To know whether it is working, I suggest three pilot measures: a creative-team survey on trust in the tool, the number of pitches using the data check, and whether discovery of original titles improves. Because Apple TV+ is a global platform, I would extend it region by region once the pilot has shown results.
-This is a change in how people work, so the plan is designed to bring creative teams into shaping the technology.
 Some resistance is natural and should be expected. Treating it as useful feedback and not as an obstacle is part of what makes change last. Kotter (1995) stresses the value of early visible wins, which is why the pilot is small and focused. A successful first slate gives sceptical colleagues evidence in place of assurances.
 Next, whether it gives you lasting advantage.</a:t>
             </a:r>
@@ -1453,16 +1462,17 @@
           <a:p>
             <a:r>
               <a:rPr lang="en-US" dirty="0"/>
-              <a:t>The strategic question is whether this technology gives you a sustained competitive advantage. I applied the VRIO framework (Barney, 1991), shown in Table 2, and I have tried to be direct about where it falls short.
+              <a:t>The strategic question is whether this technology gives you a sustained competitive advantage. I applied the VRIO framework, which builds on the resource-based view developed by Barney (1991), as shown in Table 2. The idea is that a resource gives lasting advantage only if it is valuable, rare, difficult to imitate, and the organisation is set up to exploit it. I have tried to be direct about where it falls short.
 Valuable: yes. Better discovery supports retention and agility, meaning the ability to test and adjust quickly. But scaling AI brings privacy, governance and bias risks (Mokoena and Obagbuwa, 2025).
 Rare: no. Your rivals already run recommendation engines, and the technique is widely documented (Ricci, Rokach and Shapira, 2015).
 Hard to imitate: partly. The models can be copied. Your ecosystem data and quality-focused catalogue are harder to copy. That is my judgement and not a measured finding.
 Organised to exploit: not yet. From what I understand, creative, marketing and operations teams hold different views, and there are no shared rules yet for how data shapes commissioning. That is my assessment of where you are today.
-My verdict is competitive parity, not sustained advantage. As machine-learning capabilities converge across the market, accuracy alone differentiates very little. The recommender is a necessary baseline, and advantage comes from pairing it with your ecosystem and your creative judgement.
+My verdict is competitive parity, not sustained advantage. In resource-based terms, a resource that is valuable but not rare gives parity. As machine-learning capabilities converge across the market, accuracy alone differentiates very little. The recommender is a necessary baseline, and advantage comes from pairing it with your ecosystem and your creative judgement.
 I would also add that engagement does not automatically produce retention. A subscriber can watch a lot and still cancel if the service does not feel worth the price. That is my own reasoning, and it is another reason accuracy alone will not win.
-To keep improving, I recommend four things. First, A/B test changes against retention, which supports agility. Second, bring creatives into the model, helping to set the goals it optimises, which supports innovation. Third, refresh data and models regularly so the system does not go stale. Fourth, in Ansoff's terms (Ansoff, 1957), this is market penetration: deepening retention in your existing markets, not launching a new product.
+This links back to your goals of agility, innovation and customer retention. Retention is the direct benefit. Agility comes from being able to test and adjust quickly. Innovation comes from giving creatives a role in shaping what the model optimises for, so it supports new ideas and not only familiar ones.
+To keep improving, I recommend four things. First, A/B test changes against retention, which supports agility. Second, bring creatives into the model, helping to set the goals it optimises, which supports innovation. Third, refresh data and models regularly so the system does not go stale. Fourth, in Ansoff's terms (Ansoff, 1957), this is market penetration: deepening retention in your existing markets, not launching a new product. Ansoff's matrix treats penetration as the lowest-risk growth direction, which suits a first step. Its limit is that it depends on how much room your existing markets have to grow, so later moves such as new personalised features across the ecosystem could be product development.
+In practice, the continuous improvement actions should run on a regular cycle, with results reported to leadership. If testing shows a change improves retention but reduces the variety of what is promoted, creative leadership should have the right to adjust the model's goals. That keeps agility and originality working together.
 Technology alone will not win. The organisation has to be ready to use it.
-In practice, that means the continuous improvement actions should run on a regular cycle, with results reported to leadership. If testing shows a change improves retention but reduces the variety of what is promoted, creative leadership should have the right to adjust the model's goals. That keeps agility and originality working together.
 Next, the risks.</a:t>
             </a:r>
             <a:endParaRPr lang="en-US" dirty="0"/>
@@ -1552,14 +1562,15 @@
             <a:r>
               <a:rPr lang="en-US" dirty="0"/>
               <a:t>Table 3 sets out five issues. For each I show why it matters, the ethical principle involved, and a mitigation. I have ordered them by likely impact on Apple TV+.
-Privacy comes first. Data collected for recommendations could be reused for other purposes. GDPR Article 5 requires personal data to be collected for specified, explicit purposes (European Parliament and Council, 2016), and it applies to your subscribers in the EU. The mitigation is to document the purpose and review it regularly. This also protects your brand.
-Bias and fairness. Models trained on past viewing narrow what subscribers are shown (Ricci, Rokach and Shapira, 2015). The principle is fairness, and the mitigation is regular diversity-of-recommendation audits.
-Transparency. Viewers and creatives cannot see why content is promoted. The principle is transparency, and the mitigation is "why am I seeing this" explanations for both groups.
+I use the AI4People framework from Floridi et al. (2018) to anchor the principles. It proposes five principles for a good AI society: beneficence, non-maleficence, autonomy, justice and explicability. I map each issue to the closest one.
+Privacy comes first. Data collected for recommendations could be reused for other purposes. GDPR Article 5 sets out principles including lawfulness, fairness and transparency, purpose limitation, and data minimisation (European Parliament and Council, 2016), and it applies to your subscribers in the EU. The mitigation is to document the purpose and review it regularly. This also protects your brand. In Floridi's terms, this is about avoiding harm.
+Bias and fairness. Models trained on past viewing narrow what subscribers are shown (Ricci, Rokach and Shapira, 2015). The principle is fairness, in Floridi's terms justice, and the mitigation is regular diversity-of-recommendation audits.
+Transparency. Viewers and creatives cannot see why content is promoted. The principle is transparency, which Floridi calls explicability, and the mitigation is "why am I seeing this" explanations for both groups.
 Creators' autonomy. Algorithms can steer which projects are promoted and made (Napoli, 2014). The principle is autonomy, and the mitigation is to keep creative sign-off, using data to inform and not to decide.
-Finally, the social issue of cultural diversity and filter bubbles. Personalised feeds can reduce exposure to varied content (Pariser, 2011; Helberger, 2019). The principle is diversity, and the mitigation is to set minimum exposure for varied and local content.
-These principles draw on the ethical framework in Floridi et al. (2018), which includes autonomy, fairness and explicability.
+Finally, the social issue of cultural diversity and filter bubbles. Personalised feeds can reduce exposure to varied content (Pariser, 2011; Helberger, 2019). The principle is diversity, which sits within beneficence and justice, and the mitigation is to set minimum exposure for varied and local content.
+I want to be critical about the mitigations, because they involve trade-offs. Data minimisation protects privacy but can reduce the data that makes recommendations accurate. Minimum exposure rules protect diversity, but they could be seen as limiting viewer choice. And explanations build trust, but complex machine-learning models are hard to explain simply, so an explanation may be a useful approximation and not the full reason. These tensions are why I recommend governance and review, not a one-off fix.
+I have put privacy first because it carries legal exposure and could affect trust in your brand. Bias, transparency and autonomy are closely linked to the creative concern at the heart of this challenge. The social issue of diversity is longer term, but it affects the kind of content culture the service helps to shape.
 These risks are manageable, but only if the controls are built in from the start.
-I have put privacy first because it carries legal exposure and could affect trust in your brand. Bias, transparency and autonomy are closely linked to the creative concern at the heart of this challenge. The social issue of diversity is longer term, but it affects the kind of content culture the service helps to shape.
 Next, my recommendations.</a:t>
             </a:r>
             <a:endParaRPr lang="en-US" dirty="0"/>

</xml_diff>

<commit_message>
Condense speaker notes to about 3,350 words
Co-Authored-By: Claude Sonnet 5.5 <noreply@anthropic.com>
Claude-Session: https://claude.ai/code/session_01Ha62b6Wcst3n47bFqEFLKV
</commit_message>
<xml_diff>
--- a/Earning-the-Signal_revised.pptx
+++ b/Earning-the-Signal_revised.pptx
@@ -514,10 +514,9 @@
             <a:r>
               <a:rPr lang="en-US" dirty="0"/>
               <a:t>Good morning, and thank you for your time. I am your Digital Transformation Consultant, and today I will set out how a machine-learning recommendation engine could help Apple TV+ use data to improve what your subscribers watch, without limiting the creativity that defines the service. [SRN: add SRN.]
-The presentation has three parts. First, the technology: how it works, how it addresses your challenge, and its benefits and limitations. Second, the impact on your creative teams, and how to manage the change. Third, the strategic implications, including whether it can give you lasting advantage, the ethical and risk issues, and three recommendations.
-I use established frameworks where each one answers a specific question. Porter's Five Forces tests the competitive effect. The Technology Acceptance Model tests whether creative teams will adopt the tool. Kotter's change model structures the change. VRIO tests whether the advantage lasts. Ansoff places the move strategically, and the ethical framework in Floridi and colleagues tests the risks.
-Everything I present draws on published research and industry sources, which are listed on the final slide. Where a point is my own judgement and not a measured finding, I will say so.
-At the end I will ask you to approve three actions, and I will tell you which should come first.</a:t>
+The presentation has three parts. First, the technology: how it works, how it addresses your challenge, and its benefits and limitations. Second, the impact on your creative teams and how to manage the change. Third, the strategic implications, including whether it can give you lasting advantage, the ethical and risk issues, and three recommendations.
+I use established frameworks where each answers a specific question: Porter's Five Forces for competitive effect, the Technology Acceptance Model for adoption, Kotter for change, VRIO for lasting advantage, and the ethical framework in Floridi et al. for risk. All sources are listed on the final slide. Where a point is my own judgement, I will say so.
+At the end I will ask you to approve three actions and tell you which should come first.</a:t>
             </a:r>
             <a:endParaRPr lang="en-US" dirty="0"/>
           </a:p>
@@ -605,13 +604,12 @@
           <a:p>
             <a:r>
               <a:rPr lang="en-US" dirty="0"/>
-              <a:t>I recommend three actions. Each has an owner, evidence, and a link back to the analysis, and each is a practical response to a specific finding.
-Recommendation one: run a creative-team pilot, using Kotter-style steps. The owner would be your creative leadership, supported by the data team. The evidence is Kotter (1995) on managing change and Napoli (2014) on how algorithms can reshape media production. It follows from the analysis on slides 6 and 7. It responds to the barrier of fear of losing control and to the finding that usefulness drives adoption (Davis, 1989). Success means creative-team trust in the tool, and use of the data check in pitches, after one slate.
-Recommendation two: add an explanation feature for recommendations. The owner would be marketing, working with product and technology teams. The evidence is Floridi et al. (2018) on explicability, and your own privacy documentation (Apple Inc., 2025). It follows from slides 4 and 9. It responds to distrust of algorithms and to the transparency risk. Success means how many viewers use the feature. I would be open about its limits: an explanation is a simplified account of a complex model.
-Recommendation three: set up a governance review of purpose limitation and diversity auditing. The owner would be operations, covering legal and compliance. The evidence is GDPR Article 5 (European Parliament and Council, 2016) and Ricci, Rokach and Shapira (2015) on narrowing. It follows from slides 5 and 9. It responds to the privacy and bias risks, and it also supports the VRIO finding that you are not yet organised to exploit the technology. Success means audit results each quarter.
-What should come first? The creative-team pilot. It tackles your central challenge of using data without limiting creativity, and it builds the evidence the other two depend on. The governance review should run alongside it, because the pilot will use viewer data and the rules need to be in place.
-As a suggested sequence, the pilot design and the governance review would begin together, with the pilot running on one slate before any wider roll-out. The explanation feature would follow, informed by what the pilot teaches you about how viewers and creatives respond to seeing the reasoning behind a recommendation. Each stage reports back to leadership, so you can decide at each point whether to extend, adjust or pause.
-There are risks to implementation itself. A pilot on one slate may not generalise to every region, and creative teams may see the pilot as a first step towards control. That is why the pilot's rules, including creative sign-off, should be published at the start.
+              <a:t>I recommend three actions. Each has an owner, evidence and a link back to the analysis, and each responds to a specific finding.
+One: run a creative-team pilot in Kotter-style steps. The owner would be your creative leadership, supported by the data team. The evidence is Kotter (1995) on managing change and Napoli (2014) on how algorithms can reshape media production. It follows from slides 6 and 7, and responds to fear of losing control and to the finding that usefulness drives adoption (Davis, 1989). Success means creative-team trust in the tool, and use of the data check in pitches, after one slate.
+Two: add an explanation feature for recommendations. The owner would be marketing, with product and technology teams. The evidence is Floridi et al. (2018) on explicability and your own privacy documentation (Apple Inc., 2025). It follows from slides 4 and 9, and responds to distrust of algorithms and the transparency risk. Success means how many viewers use it.
+Three: set up a governance review of purpose limitation and diversity auditing. The owner would be operations, covering legal and compliance. The evidence is GDPR Article 5 (European Parliament and Council, 2016) and Ricci, Rokach and Shapira (2015) on narrowing. It follows from slides 5 and 9, and also supports the VRIO finding that you are not yet organised to exploit the technology. Success means quarterly audit results.
+What comes first? The creative-team pilot. It tackles your central challenge of using data without limiting creativity, and it builds the evidence the other two depend on. The governance review should run alongside it, because the pilot will use viewer data. The explanation feature follows, informed by what the pilot shows. Each stage reports back to leadership, so you can extend, adjust or pause.
+There are risks in implementation itself. A pilot on one slate may not generalise to every region, and creatives may see it as a first step towards control, so the pilot's rules, including creative sign-off, should be published at the start.
 That is what I am asking you to approve today.</a:t>
             </a:r>
             <a:endParaRPr lang="en-US" dirty="0"/>
@@ -702,11 +700,10 @@
               <a:rPr lang="en-US" dirty="0"/>
               <a:t>To bring this together.
 On technology, a machine-learning recommendation engine helps match your small catalogue to many viewers. Through Porter's lens, it protects your position against Netflix, Prime Video and Disney+ rather than creating a lead. The benefits are real, but so are the limits, especially narrowing and the risk to originality.
-On people, your creative teams can protect originality while adopting data. Technology acceptance depends first on usefulness (Davis, 1989), and change lasts when it follows a structured plan like Kotter's (1995), with creative sign-off kept final.
-On strategy, rivals can copy the technology, so under VRIO it gives parity, and lasting advantage depends on your ecosystem, your creative judgement and strong ethical safeguards (Barney, 1991; Floridi et al., 2018).
-My three recommendations, in one line each: run a pilot with your creative teams, add explanations for why content is recommended, and review purpose limitation and diversity audits regularly.
-The central point is that data and creativity do not have to be opposed. With the right governance, a clear change plan and creative teams involved from the start, the technology can support your strategy and not cut across it.
-Used with creative teams at its side, the recommendation engine can help Apple TV+ keep its subscribers without giving up the originality that sets you apart.
+On people, your creative teams can protect originality while adopting data. Adoption depends first on usefulness (Davis, 1989), and change lasts when it follows a structured plan like Kotter's (1995), with creative sign-off kept final.
+On strategy, rivals can copy the technology, so under VRIO it gives parity. Lasting advantage depends on your ecosystem, your creative judgement and strong ethical safeguards (Barney, 1991; Floridi et al., 2018).
+My three recommendations: run a pilot with your creative teams, add explanations for why content is recommended, and review purpose limitation and diversity audits regularly.
+Data and creativity do not have to be opposed. Used with creative teams at its side, the recommendation engine can help Apple TV+ keep its subscribers without giving up the originality that sets you apart.
 Thank you. I am happy to take questions.</a:t>
             </a:r>
             <a:endParaRPr lang="en-US" dirty="0"/>
@@ -883,14 +880,13 @@
           <a:p>
             <a:r>
               <a:rPr lang="en-US" dirty="0"/>
-              <a:t>Let me start with where Apple TV+ stands. You offer original films, series and documentaries to a global audience, and you compete on the quality of that content, not on library size. That makes every title count for more. When a service has fewer titles, a programme that viewers never find is a bigger loss.
-Quality-led positioning also raises the stakes for how that content is surfaced. A subscriber who opens the app and sees nothing of interest will not blame the catalogue size. They will simply conclude that the service has little for them, and that is a retention risk.
-Your wider strategy places Apple TV+ inside the Apple ecosystem, with content integrated across iPhone, iPad and other Apple products. This matters for the analysis because the technology operates within your organisation and across your products and devices. Subscribers expect a seamless experience, and a viewer who starts a series on one device expects the service to remember them on the next.
-I find it useful to read this through the lens of digital transformation. Vial (2019) describes digital transformation as a process in which digital technologies create disruption that prompts organisations to respond strategically. Streaming competition and subscriber volatility are that disruption, and a recommendation engine is one strategic response.
-The challenge I have chosen to address is using data to improve recommendations without limiting creativity. It matters for three reasons. First, retention. Second, competition with Netflix, Prime Video and Disney+. Third, a tension inside the organisation: your creative teams are concerned that too much reliance on data could affect originality, while marketing supports data-driven insight but knows that customers can be sensitive to pricing and content changes.
-The data on this slide shows why retention is urgent. Antenna (2024) reports that 37.2% of Apple TV+'s gross subscriber additions were returning subscribers who had cancelled within the prior 12 months, the highest serial-churn rate in the industry. For wider context, monthly churn across major US streaming services rose from 5.1% in November 2022 to 6.3% in November 2023, as reported by ABC News using Antenna data. That industry figure is background and is not specific to Apple TV+.
-A critical point on how to read this. Serial churn tells us that subscribers move in and out easily. It does not tell us why. My reading, which is an inference and not a finding, is that with a quality-led, smaller catalogue, many subscribers may join for a particular series and leave once they finish it. If that is right, better recommendations help, but they cannot fully replace a steady flow of new content that gives people a reason to stay.
-The cost is real. Reichheld (2003) links customer loyalty to growth, and keeping existing customers is generally cheaper than winning new ones, so churn is a financial problem for you, not only a marketing metric.
+              <a:t>Let me start with where Apple TV+ stands. You offer original films, series and documentaries to a global audience, and you compete on the quality of that content, not on library size. That makes every title count for more. A programme that viewers never find is a bigger loss when the catalogue is small, and a subscriber who sees nothing of interest will conclude the service has little for them. That is a retention risk.
+Your strategy places Apple TV+ inside the Apple ecosystem, with content integrated across iPhone, iPad and other Apple products. So the technology operates within your organisation and across your devices, and subscribers expect the service to remember them as they move between screens.
+Vial (2019) describes digital transformation as a process where digital technologies create disruption that prompts a strategic response. Streaming competition and subscriber volatility are that disruption, and a recommendation engine is one response.
+The challenge I have chosen is using data to improve recommendations without limiting creativity. It matters for three reasons: retention, competition with Netflix, Prime Video and Disney+, and a tension inside the organisation. Your creative teams worry that too much reliance on data could affect originality, while marketing supports data-driven insight but knows customers can be sensitive to pricing and content changes.
+The evidence shows why retention is urgent. Antenna (2024) reports that 37.2% of Apple TV+'s gross subscriber additions were returning subscribers who had cancelled within the prior 12 months, the highest serial-churn rate in the industry. As background, monthly churn across major US streaming services rose from 5.1% in November 2022 to 6.3% in November 2023, as reported by ABC News using Antenna data. That industry figure is not specific to Apple TV+.
+A critical point: serial churn shows that subscribers move in and out easily, but not why. My inference is that with a smaller, quality-led catalogue, many subscribers join for one series and leave when it ends. If so, better recommendations help but cannot replace a steady flow of new content.
+Reichheld (2003) links customer loyalty to growth, and keeping customers is generally cheaper than winning new ones, so churn is a financial issue for you and not only a marketing metric.
 Next, the technology I recommend.</a:t>
             </a:r>
             <a:endParaRPr lang="en-US" dirty="0"/>
@@ -980,13 +976,11 @@
             <a:r>
               <a:rPr lang="en-US" dirty="0"/>
               <a:t>The technology I recommend is a machine-learning recommendation engine. In plain terms, it is software that learns from what your subscribers do and predicts what each will want to watch next. Resnick and Varian (1997) describe recommender systems as helping people choose among many options by drawing on the patterns in other people's choices.
-Figure 1 shows the flow. On the input side, the engine takes in viewing history, search queries and behavioural signals such as pauses and rewinds. In the process stage, machine learning finds patterns in that data and predicts what a viewer is likely to want. The output is a personalised home screen and "what to watch next" suggestions.
-In practice, recommender systems usually combine approaches: learning from the behaviour of similar viewers, and learning from the characteristics of the content itself (Ricci, Rokach and Shapira, 2015). That distinction matters for Apple TV+, and I will return to it as a limitation.
-I chose this technology for two reasons. It speaks directly to your challenge, and it fits your ecosystem strategy. Your subscribers move between devices, so the more consistently the service understands them, the more seamless the experience becomes. I also considered where your challenge actually sits. It sits in the link between your content and each viewer, and that is the point where a recommendation engine operates. Technologies that change how content is produced would not address it. This one works on data you already collect, which makes it practical to start with.
-The best-documented example is Netflix. Gomez-Uribe and Hunt (2015) describe how Netflix personalises rows and titles for each member and estimate that its recommender is worth over a billion dollars a year in retained subscribers. I want to be careful with that. It is evidence about Netflix, not Apple TV+, so it shows what is possible, not what you will achieve. Netflix has a much larger catalogue and a much larger volume of viewing data, so the same method may behave differently with a smaller library.
-That leads to a critical point specific to your situation. Recommenders learn from viewing history, but a new original has little or none when it launches. This is the well-known cold-start problem in recommender research (Ricci, Rokach and Shapira, 2015). Because your strategy depends on a steady flow of high-quality originals, the cold-start issue could affect you more than a service with a large back catalogue. This is my application of the research to your case, and it is one reason creative input into the system matters.
-You are already open about this use of data. Apple's privacy documentation says viewing and activity data is collected "to tailor features and offer personalised recommendations" (Apple Inc., 2025). So this technology builds on a stated practice and does not introduce a hidden one.
-Machine-learning recommendation is now an established technology, but it is still developing, particularly in how it handles context and explanation. That is why the way you deploy it matters more than the fact that you deploy it.
+Figure 1 shows the flow. The inputs are viewing history, search queries and behavioural signals such as pauses and rewinds. Machine learning finds patterns in that data and predicts what a viewer is likely to want. The output is a personalised home screen and "what to watch next" suggestions. In practice, such systems often combine learning from similar viewers with learning from the characteristics of the content itself (Ricci, Rokach and Shapira, 2015).
+I chose this technology because it speaks directly to your challenge, which sits in the link between your content and each viewer, and because it fits your ecosystem strategy. 
+The best-documented example is Netflix. Gomez-Uribe and Hunt (2015) describe personalised rows and titles for each member and estimate that its recommender is worth over a billion dollars a year in retained subscribers. I want to be careful here. That is evidence about Netflix, so it shows what is possible and not what you will achieve.
+A critical point specific to you: recommenders learn from viewing history, but a new original has little or none at launch. This is the cold-start problem in recommender research (Ricci, Rokach and Shapira, 2015). Because your strategy relies on a steady flow of high-quality originals, it could affect you more than a service with a large back catalogue. That is my application of the research to your case, and it is one reason creative input into the system matters.
+You are already open about this use of data. Apple's privacy documentation says viewing and activity data is collected "to tailor features and offer personalised recommendations" (Apple Inc., 2025).
 Next, how it helps with your challenge.</a:t>
             </a:r>
             <a:endParaRPr lang="en-US" dirty="0"/>
@@ -1075,15 +1069,13 @@
           <a:p>
             <a:r>
               <a:rPr lang="en-US" dirty="0"/>
-              <a:t>The engine helps by matching content to viewers at scale. You have a small, high-quality catalogue. The engine can match it to millions of different subscribers, so good originals are found and not buried. The flow on the left shows the chain: viewing data feeds the engine, the engine builds a tailored home screen, and that supports retention against rivals.
-The ecosystem strengthens this. Because your subscribers use several Apple devices, the engine has more signals to learn from and more places to put a relevant suggestion in front of them. Marketing also benefits, because it can see which content is resonating, although I recommend that this insight informs promotion without replacing editorial judgement.
-To test the strategic effect, I used Porter's Five Forces (Porter, 2008), shown in Figure 2. Porter's argument is that industry structure, meaning the combination of the five forces, determines how much profit is available to firms. So the right question is not whether the technology is impressive, but whether it changes any of those forces in your favour.
-The first force I highlight is rivalry with Netflix, Prime Video and Disney+. Better discovery raises the value of each subscription, which helps you. But rivalry is most intense where competitors offer similar things, and those rivals run similar engines. So the technology protects your position rather than giving you a lead.
-The second is buyer power, meaning how easily subscribers can switch. Porter notes that buyers have more power when switching costs are low. They are low here, and the serial-churn figure on slide 2 shows subscribers leaving and returning easily (Antenna, 2024). A profile that has learned someone's taste adds a small cost to leaving, so the engine nudges switching costs up, but it does not solve the problem.
-I have focused on these two forces because they are where the engine has the clearest effect. I do not claim it changes the threat of new entrants, supplier power or substitutes in any major way. For example, competition for viewers' time from other forms of entertainment is outside what a recommender can influence.
-Now the creativity side, which I know is your leadership's main concern. The same engine that matches content can also steer which content is promoted. If it mainly promotes what is already popular or familiar, it could crowd out new and unusual ideas, and over time influence what gets commissioned. That is where your creative teams' concern comes from, and I take it seriously.
-My message is that the technology is worth using, but the creative concern needs to be managed deliberately. I come back to how in the next section.
-Next, the benefits and limitations side by side.</a:t>
+              <a:t>The engine helps by matching content to viewers at scale. You have a small, high-quality catalogue, and the engine can match it to millions of different subscribers so good originals are found and not buried.
+To test the strategic effect, I used Porter's Five Forces (Porter, 2008), shown in Figure 2. Porter's argument is that industry structure determines how much profit is available, so the question is whether the technology changes any of the forces in your favour.
+First, rivalry with Netflix, Prime Video and Disney+. Better discovery raises the value of each subscription. But rivalry is most intense where competitors offer similar things, and those rivals run similar engines. So the technology protects your position rather than giving you a lead.
+Second, buyer power. Porter notes that buyers have more power when switching costs are low. They are low here, and the serial-churn figure on slide 2 shows subscribers leaving and returning easily (Antenna, 2024). A profile that has learned someone's taste adds a small cost to leaving, but it does not solve the problem.
+Now the creativity side, which I know is your leadership's main concern. The same engine that matches content can steer which content is promoted. If it mainly promotes what is already popular or familiar, it could crowd out new ideas and, over time, influence what gets commissioned. That is where your creative teams' concern comes from, and I take it seriously.
+My message is that the technology is worth using, but the creative concern needs to be managed deliberately. I address how in the next section.
+Next, the benefits and limitations.</a:t>
             </a:r>
             <a:endParaRPr lang="en-US" dirty="0"/>
           </a:p>
@@ -1172,13 +1164,12 @@
             <a:r>
               <a:rPr lang="en-US" dirty="0"/>
               <a:t>Table 1 sets out three benefits and five limitations, each with a source.
-The benefits. First, discovery: Gracenote (2025) found that 49% of viewers say they are likely to cancel a streaming service if they cannot find something to watch. Second, engagement: Gomez-Uribe and Hunt (2015) describe how personalised rows and titles increase viewing. Third, retention: better discovery reduces cancellations, which connects to Reichheld (2003) on the link between loyalty and growth.
-The limitations. Narrowing: models reinforce what viewers have already watched, so recommendations narrow over time (Ricci, Rokach and Shapira, 2015). Reduced diversity: personalised feeds can limit exposure to varied content (Helberger, 2019). Possible loss of creative originality: data-led promotion can favour familiar formats over new ideas (Napoli, 2014). Data quality: the output depends on the quality of the data and signals behind it (Ricci, Rokach and Shapira, 2015). And privacy and governance: scaling AI adds privacy risk, governance demands and algorithmic bias that can limit content diversity (Mokoena and Obagbuwa, 2025).
+The benefits. Discovery: Gracenote (2025) found that 49% of viewers say they are likely to cancel a streaming service if they cannot find something to watch. Engagement: Gomez-Uribe and Hunt (2015) describe how personalised rows and titles increase viewing. Retention: better discovery reduces cancellations, which connects to Reichheld (2003) on loyalty and growth.
+The limitations. Narrowing: models reinforce what viewers have already watched (Ricci, Rokach and Shapira, 2015). Reduced diversity: personalised feeds can limit exposure to varied content (Helberger, 2019). Possible loss of creative originality: data-led promotion can favour familiar formats (Napoli, 2014). Data quality: the output depends on the data behind it (Ricci, Rokach and Shapira, 2015). And privacy and governance: scaling AI adds privacy risk, governance demands and bias that can limit content diversity (Mokoena and Obagbuwa, 2025).
 For Apple TV+, the benefit that matters most is discovery, because a small catalogue only pays off if each show is found. The limitation that matters most is creative originality, because quality is your point of difference.
-I should be open about the strength of this evidence. The Gracenote figure is stated intent, not recorded cancellations, so it shows what viewers say they would do. Gomez-Uribe and Hunt (2015) describes Netflix. Helberger (2019) writes about news recommenders, so applying it to entertainment is my inference. The filter-bubble idea popularised by Pariser (2011) is a useful concept, but it is from a popular book and is debated, so I use it to frame the risk and not as proof of its size. And Mokoena and Obagbuwa (2025) is a review of AI in music streaming, so I use it for its findings on risks, not as proof about video services.
-There is also an interaction between the two lists. Narrowing, if left unchecked, can undermine the very discovery benefit that justifies the investment, because viewers see more of the same and less of what is new. The limitations are not an afterthought. They are part of whether the benefit lasts.
-My conclusion is that personalisation is necessary but not sufficient. Its benefits depend on managing these limits.
-Next, what this means for the people who make your content.</a:t>
+I should be open about the strength of the evidence. The Gracenote figure is stated intent and not recorded cancellations. Gomez-Uribe and Hunt (2015) describes Netflix. Helberger (2019) writes about news recommenders, so applying it to entertainment is my inference. Pariser's filter-bubble idea (2011) is a useful concept but comes from a popular book and is debated, so I use it to frame the risk and not to size it. And Mokoena and Obagbuwa (2025) reviews AI in music streaming, so I use it for its findings on risk.
+The two lists also interact. Narrowing, left unchecked, undermines the discovery benefit that justifies the investment. My conclusion is that personalisation is necessary but not sufficient. Its benefits depend on managing these limits.
+Next, the people who make your content.</a:t>
             </a:r>
             <a:endParaRPr lang="en-US" dirty="0"/>
           </a:p>
@@ -1267,17 +1258,14 @@
             <a:r>
               <a:rPr lang="en-US" dirty="0"/>
               <a:t>Personalisation at this scale does not only change what subscribers see. It also changes how your creative teams decide what gets made.
-I have focused on your creative teams: writers, producers and content developers. I chose them because they are the group most directly exposed to this technology, and because their concern is clear: too much reliance on data could affect originality.
-I looked at four things that influence one another: structure, culture, processes, and how the technology is managed. That mutual influence is the key point.
-Structure is about who decides what gets made. Data should inform commissioning, not replace the judgement of your commissioning executives and creators.
-Culture is about creative autonomy versus data-driven decisions. Napoli (2014) takes an institutional theory perspective on algorithmic media production. The insight is that algorithms do not only support decisions, they can reshape the norms and routines in which decisions are made. For creative teams, that is the real worry: not one recommendation, but a gradual change in what counts as a good idea. If teams see data as a verdict on their ideas, they will resist it. If they see it as a tool, they are more likely to use it.
-Process covers green-lighting and content pitches. I propose adding a data check to pitches while keeping creative sign-off at the final step.
-Management ties these together through governance: clear rules on how data is used and who can override the model.
-The four are linked. If the process keeps creative sign-off final, the culture is more likely to accept the tool. If the culture accepts it, the structure can use data without conflict. If decisions drift towards data, culture suffers and resistance grows. So any change to one has to take account of the others.
-I also looked at adoption through the Technology Acceptance Model (Davis, 1989), which holds that people's intention to use a technology depends on perceived usefulness and perceived ease of use, with usefulness the stronger influence. Your creative teams would find it useful if it shows which audiences a pitch could reach. They would find it easy to use only if insights come in plain language and fit the existing pitch workflow. Because usefulness matters most, the first step is to show creatives value in their own terms, not to train them on a dashboard.
-Here is a critical limit of that model. TAM focuses on individual perceptions of usefulness and ease of use. It says less about professional identity, power and trust. If creatives resist because they feel their craft is being second-guessed, a simpler interface will not fix it. That is why I pair TAM with a change model and governance that protect creative sign-off.
-So their concern is addressed by design: creative sign-off stays final, data is input and not instruction, and the tool fits how they already work.
-I recognise that marketing and operations also have views on this change. Marketing supports data-driven insight, and operations focus on service reliability, legal requirements and supporting employees. I have focused on creative teams because their concern goes to the heart of your challenge, but the governance review in my third recommendation also addresses the operations perspective.
+I have focused on your creative teams: writers, producers and content developers. They are the group most directly exposed to this technology, and their concern is clear: too much reliance on data could affect originality.
+I looked at four things that influence one another: structure, culture, processes and management.
+Structure is about who decides what gets made. Data should inform commissioning, not replace the judgement of your executives and creators.
+Culture is creative autonomy versus data-driven decisions. Napoli (2014) takes an institutional theory perspective on algorithmic media production. The insight is that algorithms do not only support decisions, they can reshape the norms in which decisions are made. For creatives, the real worry is not one recommendation but a gradual shift in what counts as a good idea.
+Process covers green-lighting and pitches. I propose a data check on pitches, with creative sign-off kept at the final step. Management ties these together through governance: clear rules on how data is used and who can override the model.
+The four are linked. If the process keeps creative sign-off final, the culture is more likely to accept the tool, and the structure can use data without conflict. If decisions drift towards data, culture suffers and resistance grows. So a change to one has to take account of the others.
+For adoption I used the Technology Acceptance Model (Davis, 1989). It holds that intention to use a technology depends on perceived usefulness and perceived ease of use, with usefulness the stronger influence. Creatives will find the tool useful if it shows which audiences a pitch could reach, and easy to use only if insights come in plain language and fit the pitch workflow. So the first step is to show value in their own terms.
+A critical limit: TAM focuses on individual perceptions. It says less about professional identity, power and trust. If creatives resist because they feel their craft is being second-guessed, a simpler interface will not fix it. That is why I pair TAM with a change model and governance that protect creative sign-off.
 Next, the barriers and how to manage the change.</a:t>
             </a:r>
             <a:endParaRPr lang="en-US" dirty="0"/>
@@ -1367,13 +1355,11 @@
             <a:r>
               <a:rPr lang="en-US" dirty="0"/>
               <a:t>This slide covers the barriers, how to manage them, and the change plan.
-I see three main barriers. The first is fear of losing creative control. The response is to keep creative sign-off final and publish clear rules for how data is used. The second is distrust of algorithms. The core issue is visibility: creative teams cannot see how data influences decisions. The response is to show why content is promoted, so creatives can follow the reasoning. The third is skills gaps. The response is training built around real projects.
-These barriers are typical of digital transformation. Vial (2019) identifies structural changes and organisational barriers, including resistance and capability gaps, as central parts of how organisations transform. So I treat the barriers as a design problem to plan for, not a surprise.
-For the change plan I recommend Kotter (1995), condensed from eight steps to six for Apple TV+ and shown in Figure 4. Kotter argues that transformations fail when organisations skip steps or declare victory too early. Step one, urgency: churn and rivals make better discovery pressing. Step two, a coalition of creative champions and data leads. Step three, a vision that data informs and creatives decide. Step four, a pilot on one slate of originals, with early wins shared. Step five, extending the approach into pitches and green-lighting. Step six, embedding it in how you commission.
-A critical note on the model. Kotter's steps are sequential and fairly top-down, which can sit awkwardly with creative organisations that value autonomy. I address this by putting creative champions in the coalition and building feedback channels into the plan, so the change is shaped with creatives and not only delivered to them.
-To build digital confidence, I recommend four actions: training for writers and producers, pilots on a small slate of originals, creative champions on each team, and feedback channels into the model team. The feedback channels let creatives shape the system and not just receive it.
-To know whether it is working, I suggest three pilot measures: a creative-team survey on trust in the tool, the number of pitches using the data check, and whether discovery of original titles improves. Because Apple TV+ is a global platform, I would extend it region by region once the pilot has shown results.
-Some resistance is natural and should be expected. Treating it as useful feedback and not as an obstacle is part of what makes change last. Kotter (1995) stresses the value of early visible wins, which is why the pilot is small and focused. A successful first slate gives sceptical colleagues evidence in place of assurances.
+I see three main barriers. Fear of losing creative control: keep creative sign-off final and publish clear rules for how data is used. Distrust of algorithms: the core issue is visibility, because creative teams cannot see how data influences decisions, so show why content is promoted. And skills gaps: training built around real projects. Vial (2019) identifies structural changes and organisational barriers, including resistance and capability gaps, as central to how organisations transform, so I treat these as a design problem, not a surprise.
+For the change plan I recommend Kotter (1995), condensed from eight steps to six, as shown in Figure 4. Kotter argues that transformations fail when organisations skip steps or declare victory too early. Urgency: churn and rivals make better discovery pressing. A coalition of creative champions and data leads. A vision that data informs and creatives decide. A pilot on one slate of originals, with early wins shared. Extension into pitches and green-lighting. And embedding in how you commission.
+A critical note: Kotter's steps are sequential and fairly top-down, which can sit awkwardly with creative organisations that value autonomy. I address this by putting creative champions in the coalition and building feedback channels into the plan, so the change is shaped with creatives and not only delivered to them.
+To build digital confidence, I recommend training for writers and producers, pilots on a small slate of originals, creative champions on each team, and feedback channels into the model team.
+To know whether it is working, I suggest three pilot measures: a creative-team survey on trust in the tool, the number of pitches using the data check, and whether discovery of original titles improves. Because Apple TV+ is a global platform, I would extend region by region once the pilot has shown results.
 Next, whether it gives you lasting advantage.</a:t>
             </a:r>
             <a:endParaRPr lang="en-US" dirty="0"/>
@@ -1462,17 +1448,14 @@
           <a:p>
             <a:r>
               <a:rPr lang="en-US" dirty="0"/>
-              <a:t>The strategic question is whether this technology gives you a sustained competitive advantage. I applied the VRIO framework, which builds on the resource-based view developed by Barney (1991), as shown in Table 2. The idea is that a resource gives lasting advantage only if it is valuable, rare, difficult to imitate, and the organisation is set up to exploit it. I have tried to be direct about where it falls short.
-Valuable: yes. Better discovery supports retention and agility, meaning the ability to test and adjust quickly. But scaling AI brings privacy, governance and bias risks (Mokoena and Obagbuwa, 2025).
+              <a:t>The strategic question is whether this technology gives you a sustained competitive advantage. I applied the VRIO framework, which builds on the resource-based view developed by Barney (1991) and is shown in Table 2. A resource gives lasting advantage only if it is valuable, rare, difficult to imitate, and the organisation is set up to exploit it.
+Valuable: yes. Better discovery supports retention and agility, but scaling AI brings privacy, governance and bias risks (Mokoena and Obagbuwa, 2025).
 Rare: no. Your rivals already run recommendation engines, and the technique is widely documented (Ricci, Rokach and Shapira, 2015).
 Hard to imitate: partly. The models can be copied. Your ecosystem data and quality-focused catalogue are harder to copy. That is my judgement and not a measured finding.
-Organised to exploit: not yet. From what I understand, creative, marketing and operations teams hold different views, and there are no shared rules yet for how data shapes commissioning. That is my assessment of where you are today.
-My verdict is competitive parity, not sustained advantage. In resource-based terms, a resource that is valuable but not rare gives parity. As machine-learning capabilities converge across the market, accuracy alone differentiates very little. The recommender is a necessary baseline, and advantage comes from pairing it with your ecosystem and your creative judgement.
-I would also add that engagement does not automatically produce retention. A subscriber can watch a lot and still cancel if the service does not feel worth the price. That is my own reasoning, and it is another reason accuracy alone will not win.
-This links back to your goals of agility, innovation and customer retention. Retention is the direct benefit. Agility comes from being able to test and adjust quickly. Innovation comes from giving creatives a role in shaping what the model optimises for, so it supports new ideas and not only familiar ones.
-To keep improving, I recommend four things. First, A/B test changes against retention, which supports agility. Second, bring creatives into the model, helping to set the goals it optimises, which supports innovation. Third, refresh data and models regularly so the system does not go stale. Fourth, in Ansoff's terms (Ansoff, 1957), this is market penetration: deepening retention in your existing markets, not launching a new product. Ansoff's matrix treats penetration as the lowest-risk growth direction, which suits a first step. Its limit is that it depends on how much room your existing markets have to grow, so later moves such as new personalised features across the ecosystem could be product development.
-In practice, the continuous improvement actions should run on a regular cycle, with results reported to leadership. If testing shows a change improves retention but reduces the variety of what is promoted, creative leadership should have the right to adjust the model's goals. That keeps agility and originality working together.
-Technology alone will not win. The organisation has to be ready to use it.
+Organised to exploit: not yet. From what I understand, creative, marketing and operations teams hold different views, and there are no shared rules for how data shapes commissioning. That is my assessment of where you are today.
+My verdict is competitive parity, not sustained advantage. In resource-based terms, a valuable but not rare resource gives parity. As machine-learning capabilities converge, accuracy alone differentiates very little. I would add that engagement does not automatically produce retention, since a subscriber can watch a lot and still cancel if the service does not feel worth the price. That is my own reasoning. Advantage comes from pairing the recommender with your ecosystem and creative judgement.
+This links to your goals. Retention is the direct benefit. Agility comes from being able to test and adjust quickly. Innovation comes from giving creatives a role in what the model optimises, so it supports new ideas as well as familiar ones.
+To keep improving, I recommend four things. A/B test changes against retention. Bring creatives into setting the model's goals. Refresh data and models regularly. And note that in Ansoff's terms (1957) this is market penetration, deepening retention in your existing markets. Ansoff treats penetration as the lowest-risk growth direction, which suits a first step, but it depends on how much room your markets have to grow, so later personalised features across the ecosystem could be product development.
 Next, the risks.</a:t>
             </a:r>
             <a:endParaRPr lang="en-US" dirty="0"/>
@@ -1561,16 +1544,13 @@
           <a:p>
             <a:r>
               <a:rPr lang="en-US" dirty="0"/>
-              <a:t>Table 3 sets out five issues. For each I show why it matters, the ethical principle involved, and a mitigation. I have ordered them by likely impact on Apple TV+.
-I use the AI4People framework from Floridi et al. (2018) to anchor the principles. It proposes five principles for a good AI society: beneficence, non-maleficence, autonomy, justice and explicability. I map each issue to the closest one.
-Privacy comes first. Data collected for recommendations could be reused for other purposes. GDPR Article 5 sets out principles including lawfulness, fairness and transparency, purpose limitation, and data minimisation (European Parliament and Council, 2016), and it applies to your subscribers in the EU. The mitigation is to document the purpose and review it regularly. This also protects your brand. In Floridi's terms, this is about avoiding harm.
-Bias and fairness. Models trained on past viewing narrow what subscribers are shown (Ricci, Rokach and Shapira, 2015). The principle is fairness, in Floridi's terms justice, and the mitigation is regular diversity-of-recommendation audits.
-Transparency. Viewers and creatives cannot see why content is promoted. The principle is transparency, which Floridi calls explicability, and the mitigation is "why am I seeing this" explanations for both groups.
-Creators' autonomy. Algorithms can steer which projects are promoted and made (Napoli, 2014). The principle is autonomy, and the mitigation is to keep creative sign-off, using data to inform and not to decide.
-Finally, the social issue of cultural diversity and filter bubbles. Personalised feeds can reduce exposure to varied content (Pariser, 2011; Helberger, 2019). The principle is diversity, which sits within beneficence and justice, and the mitigation is to set minimum exposure for varied and local content.
-I want to be critical about the mitigations, because they involve trade-offs. Data minimisation protects privacy but can reduce the data that makes recommendations accurate. Minimum exposure rules protect diversity, but they could be seen as limiting viewer choice. And explanations build trust, but complex machine-learning models are hard to explain simply, so an explanation may be a useful approximation and not the full reason. These tensions are why I recommend governance and review, not a one-off fix.
-I have put privacy first because it carries legal exposure and could affect trust in your brand. Bias, transparency and autonomy are closely linked to the creative concern at the heart of this challenge. The social issue of diversity is longer term, but it affects the kind of content culture the service helps to shape.
-These risks are manageable, but only if the controls are built in from the start.
+              <a:t>Table 3 sets out five issues, each with why it matters, the ethical principle and a mitigation, ordered by likely impact on Apple TV+. I anchor the principles in the AI4People framework from Floridi et al. (2018): beneficence, non-maleficence, autonomy, justice and explicability.
+Privacy comes first. Data collected for recommendations could be reused for other purposes. GDPR Article 5 sets out principles including lawfulness, fairness and transparency, purpose limitation and data minimisation (European Parliament and Council, 2016), and it applies to your subscribers in the EU. The mitigation is to document the purpose and review it regularly. This also protects your brand.
+Bias and fairness. Models trained on past viewing narrow what subscribers are shown (Ricci, Rokach and Shapira, 2015). The principle is fairness, which Floridi calls justice, and the mitigation is regular diversity-of-recommendation audits.
+Transparency. Viewers and creatives cannot see why content is promoted. Floridi calls this principle explicability, and the mitigation is "why am I seeing this" explanations for both groups.
+Creators' autonomy. Algorithms can steer which projects are promoted and made (Napoli, 2014). The mitigation is to keep creative sign-off, using data to inform and not to decide.
+Finally, the social issue of cultural diversity and filter bubbles. Personalised feeds can reduce exposure to varied content (Pariser, 2011; Helberger, 2019). The mitigation is minimum exposure for varied and local content.
+I want to be critical about the mitigations, because they involve trade-offs. Data minimisation protects privacy but can reduce the data that makes recommendations accurate. Minimum exposure rules protect diversity but could be seen as limiting viewer choice. And explanations build trust, but complex models are hard to explain, so an explanation may be a useful approximation and not the full reason. These tensions are why I recommend governance and review, not a one-off fix.
 Next, my recommendations.</a:t>
             </a:r>
             <a:endParaRPr lang="en-US" dirty="0"/>

</xml_diff>